<commit_message>
feat: update pitch deck with accurate Figma design assets, Myntra brand colors, and anonymous survey persona
</commit_message>
<xml_diff>
--- a/Myntra_Wishlist_Studio_10_Slide_Deck.pptx
+++ b/Myntra_Wishlist_Studio_10_Slide_Deck.pptx
@@ -3668,152 +3668,30 @@
           </a:p>
         </p:txBody>
       </p:sp>
-      <p:sp>
-        <p:nvSpPr>
-          <p:cNvPr id="10" name="TextBox 9"/>
-          <p:cNvSpPr txBox="1"/>
-          <p:nvPr/>
-        </p:nvSpPr>
-        <p:spPr>
-          <a:xfrm>
-            <a:off x="9281160" y="1828800"/>
-            <a:ext cx="2130552" cy="3429000"/>
+      <p:pic>
+        <p:nvPicPr>
+          <p:cNvPr id="10" name="Picture 9" descr="04_Figma_Mobile_Wishlist_Studio_Home.png"/>
+          <p:cNvPicPr>
+            <a:picLocks noChangeAspect="1"/>
+          </p:cNvPicPr>
+          <p:nvPr/>
+        </p:nvPicPr>
+        <p:blipFill>
+          <a:blip r:embed="rId2"/>
+          <a:stretch>
+            <a:fillRect/>
+          </a:stretch>
+        </p:blipFill>
+        <p:spPr>
+          <a:xfrm>
+            <a:off x="9217152" y="1719072"/>
+            <a:ext cx="2258568" cy="3648456"/>
           </a:xfrm>
           <a:prstGeom prst="rect">
             <a:avLst/>
           </a:prstGeom>
-          <a:noFill/>
-        </p:spPr>
-        <p:txBody>
-          <a:bodyPr wrap="square">
-            <a:spAutoFit/>
-          </a:bodyPr>
-          <a:lstStyle/>
-          <a:p>
-            <a:pPr>
-              <a:defRPr sz="1050" b="1">
-                <a:solidFill>
-                  <a:srgbClr val="FFFFFF"/>
-                </a:solidFill>
-              </a:defRPr>
-            </a:pPr>
-            <a:r>
-              <a:t>Wishlist Studio Home</a:t>
-            </a:r>
-          </a:p>
-          <a:p>
-            <a:pPr>
-              <a:defRPr sz="900" b="1">
-                <a:solidFill>
-                  <a:srgbClr val="FF3F6C"/>
-                </a:solidFill>
-              </a:defRPr>
-            </a:pPr>
-            <a:r>
-              <a:t>[Zero-Discount Engine]</a:t>
-            </a:r>
-          </a:p>
-          <a:p>
-            <a:pPr>
-              <a:defRPr sz="900"/>
-            </a:pPr>
-            <a:r>
-              <a:rPr>
-                <a:solidFill>
-                  <a:srgbClr val="64748B"/>
-                </a:solidFill>
-              </a:rPr>
-              <a:t>Active Saved Items
-</a:t>
-            </a:r>
-            <a:r>
-              <a:rPr b="1">
-                <a:solidFill>
-                  <a:srgbClr val="FFFFFF"/>
-                </a:solidFill>
-              </a:rPr>
-              <a:t>38 Items Saved</a:t>
-            </a:r>
-          </a:p>
-          <a:p>
-            <a:pPr>
-              <a:defRPr sz="900"/>
-            </a:pPr>
-            <a:r>
-              <a:rPr>
-                <a:solidFill>
-                  <a:srgbClr val="64748B"/>
-                </a:solidFill>
-              </a:rPr>
-              <a:t>30-Day Conversion Target
-</a:t>
-            </a:r>
-            <a:r>
-              <a:rPr b="1">
-                <a:solidFill>
-                  <a:srgbClr val="FFFFFF"/>
-                </a:solidFill>
-              </a:rPr>
-              <a:t>7.5% -&gt; 10.5% (+300bps)</a:t>
-            </a:r>
-          </a:p>
-          <a:p>
-            <a:pPr>
-              <a:defRPr sz="900"/>
-            </a:pPr>
-            <a:r>
-              <a:rPr>
-                <a:solidFill>
-                  <a:srgbClr val="64748B"/>
-                </a:solidFill>
-              </a:rPr>
-              <a:t>Monthly Gross Profit Lift
-</a:t>
-            </a:r>
-            <a:r>
-              <a:rPr b="1">
-                <a:solidFill>
-                  <a:srgbClr val="FFFFFF"/>
-                </a:solidFill>
-              </a:rPr>
-              <a:t>+₹18.81 Cr</a:t>
-            </a:r>
-          </a:p>
-          <a:p>
-            <a:pPr>
-              <a:defRPr sz="900"/>
-            </a:pPr>
-            <a:r>
-              <a:rPr>
-                <a:solidFill>
-                  <a:srgbClr val="64748B"/>
-                </a:solidFill>
-              </a:rPr>
-              <a:t>Return Cost Reduction
-</a:t>
-            </a:r>
-            <a:r>
-              <a:rPr b="1">
-                <a:solidFill>
-                  <a:srgbClr val="FFFFFF"/>
-                </a:solidFill>
-              </a:rPr>
-              <a:t>₹73.5 Lakh / mo</a:t>
-            </a:r>
-          </a:p>
-          <a:p>
-            <a:pPr algn="ctr"/>
-            <a:r>
-              <a:rPr sz="950" b="1">
-                <a:solidFill>
-                  <a:srgbClr val="FF3F6C"/>
-                </a:solidFill>
-              </a:rPr>
-              <a:t>▶ Explore Decision Studio</a:t>
-            </a:r>
-          </a:p>
-        </p:txBody>
-      </p:sp>
+        </p:spPr>
+      </p:pic>
       <p:sp>
         <p:nvSpPr>
           <p:cNvPr id="11" name="Rounded Rectangle 10"/>
@@ -5035,152 +4913,30 @@
           </a:p>
         </p:txBody>
       </p:sp>
-      <p:sp>
-        <p:nvSpPr>
-          <p:cNvPr id="10" name="TextBox 9"/>
-          <p:cNvSpPr txBox="1"/>
-          <p:nvPr/>
-        </p:nvSpPr>
-        <p:spPr>
-          <a:xfrm>
-            <a:off x="9281160" y="1828800"/>
-            <a:ext cx="2130552" cy="3429000"/>
+      <p:pic>
+        <p:nvPicPr>
+          <p:cNvPr id="10" name="Picture 9" descr="03_Figma_Mobile_WhatsApp_Voting_Card.png"/>
+          <p:cNvPicPr>
+            <a:picLocks noChangeAspect="1"/>
+          </p:cNvPicPr>
+          <p:nvPr/>
+        </p:nvPicPr>
+        <p:blipFill>
+          <a:blip r:embed="rId2"/>
+          <a:stretch>
+            <a:fillRect/>
+          </a:stretch>
+        </p:blipFill>
+        <p:spPr>
+          <a:xfrm>
+            <a:off x="9217152" y="1719072"/>
+            <a:ext cx="2258568" cy="3648456"/>
           </a:xfrm>
           <a:prstGeom prst="rect">
             <a:avLst/>
           </a:prstGeom>
-          <a:noFill/>
-        </p:spPr>
-        <p:txBody>
-          <a:bodyPr wrap="square">
-            <a:spAutoFit/>
-          </a:bodyPr>
-          <a:lstStyle/>
-          <a:p>
-            <a:pPr>
-              <a:defRPr sz="1050" b="1">
-                <a:solidFill>
-                  <a:srgbClr val="FFFFFF"/>
-                </a:solidFill>
-              </a:defRPr>
-            </a:pPr>
-            <a:r>
-              <a:t>GTM Command Center</a:t>
-            </a:r>
-          </a:p>
-          <a:p>
-            <a:pPr>
-              <a:defRPr sz="900" b="1">
-                <a:solidFill>
-                  <a:srgbClr val="FF3F6C"/>
-                </a:solidFill>
-              </a:defRPr>
-            </a:pPr>
-            <a:r>
-              <a:t>[Circuit Breaker Active]</a:t>
-            </a:r>
-          </a:p>
-          <a:p>
-            <a:pPr>
-              <a:defRPr sz="900"/>
-            </a:pPr>
-            <a:r>
-              <a:rPr>
-                <a:solidFill>
-                  <a:srgbClr val="64748B"/>
-                </a:solidFill>
-              </a:rPr>
-              <a:t>Phase 1 Gate
-</a:t>
-            </a:r>
-            <a:r>
-              <a:rPr b="1">
-                <a:solidFill>
-                  <a:srgbClr val="FFFFFF"/>
-                </a:solidFill>
-              </a:rPr>
-              <a:t>Beta Adoption ≥ 30%</a:t>
-            </a:r>
-          </a:p>
-          <a:p>
-            <a:pPr>
-              <a:defRPr sz="900"/>
-            </a:pPr>
-            <a:r>
-              <a:rPr>
-                <a:solidFill>
-                  <a:srgbClr val="64748B"/>
-                </a:solidFill>
-              </a:rPr>
-              <a:t>Phase 2 Gate
-</a:t>
-            </a:r>
-            <a:r>
-              <a:rPr b="1">
-                <a:solidFill>
-                  <a:srgbClr val="FFFFFF"/>
-                </a:solidFill>
-              </a:rPr>
-              <a:t>Metro Rollout Lift ≥ 2pp</a:t>
-            </a:r>
-          </a:p>
-          <a:p>
-            <a:pPr>
-              <a:defRPr sz="900"/>
-            </a:pPr>
-            <a:r>
-              <a:rPr>
-                <a:solidFill>
-                  <a:srgbClr val="64748B"/>
-                </a:solidFill>
-              </a:rPr>
-              <a:t>Infra SLA Guardrail
-</a:t>
-            </a:r>
-            <a:r>
-              <a:rPr b="1">
-                <a:solidFill>
-                  <a:srgbClr val="FFFFFF"/>
-                </a:solidFill>
-              </a:rPr>
-              <a:t>p95 API Latency &lt; 300ms</a:t>
-            </a:r>
-          </a:p>
-          <a:p>
-            <a:pPr>
-              <a:defRPr sz="900"/>
-            </a:pPr>
-            <a:r>
-              <a:rPr>
-                <a:solidFill>
-                  <a:srgbClr val="64748B"/>
-                </a:solidFill>
-              </a:rPr>
-              <a:t>Rollback SLA
-</a:t>
-            </a:r>
-            <a:r>
-              <a:rPr b="1">
-                <a:solidFill>
-                  <a:srgbClr val="FFFFFF"/>
-                </a:solidFill>
-              </a:rPr>
-              <a:t>Auto-Kill in &lt; 60s</a:t>
-            </a:r>
-          </a:p>
-          <a:p>
-            <a:pPr algn="ctr"/>
-            <a:r>
-              <a:rPr sz="950" b="1">
-                <a:solidFill>
-                  <a:srgbClr val="FF3F6C"/>
-                </a:solidFill>
-              </a:rPr>
-              <a:t>▶ View Risk Matrix</a:t>
-            </a:r>
-          </a:p>
-        </p:txBody>
-      </p:sp>
+        </p:spPr>
+      </p:pic>
       <p:sp>
         <p:nvSpPr>
           <p:cNvPr id="11" name="Rounded Rectangle 10"/>
@@ -6373,152 +6129,30 @@
           </a:p>
         </p:txBody>
       </p:sp>
-      <p:sp>
-        <p:nvSpPr>
-          <p:cNvPr id="10" name="TextBox 9"/>
-          <p:cNvSpPr txBox="1"/>
-          <p:nvPr/>
-        </p:nvSpPr>
-        <p:spPr>
-          <a:xfrm>
-            <a:off x="9281160" y="1828800"/>
-            <a:ext cx="2130552" cy="3429000"/>
+      <p:pic>
+        <p:nvPicPr>
+          <p:cNvPr id="10" name="Picture 9" descr="01_Figma_Mobile_Spec_Comparison_Matrix.png"/>
+          <p:cNvPicPr>
+            <a:picLocks noChangeAspect="1"/>
+          </p:cNvPicPr>
+          <p:nvPr/>
+        </p:nvPicPr>
+        <p:blipFill>
+          <a:blip r:embed="rId2"/>
+          <a:stretch>
+            <a:fillRect/>
+          </a:stretch>
+        </p:blipFill>
+        <p:spPr>
+          <a:xfrm>
+            <a:off x="9217152" y="1719072"/>
+            <a:ext cx="2258568" cy="3648456"/>
           </a:xfrm>
           <a:prstGeom prst="rect">
             <a:avLst/>
           </a:prstGeom>
-          <a:noFill/>
-        </p:spPr>
-        <p:txBody>
-          <a:bodyPr wrap="square">
-            <a:spAutoFit/>
-          </a:bodyPr>
-          <a:lstStyle/>
-          <a:p>
-            <a:pPr>
-              <a:defRPr sz="1050" b="1">
-                <a:solidFill>
-                  <a:srgbClr val="FFFFFF"/>
-                </a:solidFill>
-              </a:defRPr>
-            </a:pPr>
-            <a:r>
-              <a:t>Comparison Dilemma</a:t>
-            </a:r>
-          </a:p>
-          <a:p>
-            <a:pPr>
-              <a:defRPr sz="900" b="1">
-                <a:solidFill>
-                  <a:srgbClr val="FF3F6C"/>
-                </a:solidFill>
-              </a:defRPr>
-            </a:pPr>
-            <a:r>
-              <a:t>[Choice Paralysis]</a:t>
-            </a:r>
-          </a:p>
-          <a:p>
-            <a:pPr>
-              <a:defRPr sz="900"/>
-            </a:pPr>
-            <a:r>
-              <a:rPr>
-                <a:solidFill>
-                  <a:srgbClr val="64748B"/>
-                </a:solidFill>
-              </a:rPr>
-              <a:t>Option A: Heavy Street Cargo
-</a:t>
-            </a:r>
-            <a:r>
-              <a:rPr b="1">
-                <a:solidFill>
-                  <a:srgbClr val="FFFFFF"/>
-                </a:solidFill>
-              </a:rPr>
-              <a:t>240 GSM • 88% True Fit</a:t>
-            </a:r>
-          </a:p>
-          <a:p>
-            <a:pPr>
-              <a:defRPr sz="900"/>
-            </a:pPr>
-            <a:r>
-              <a:rPr>
-                <a:solidFill>
-                  <a:srgbClr val="64748B"/>
-                </a:solidFill>
-              </a:rPr>
-              <a:t>Option B: Poplin Relaxed Cargo
-</a:t>
-            </a:r>
-            <a:r>
-              <a:rPr b="1">
-                <a:solidFill>
-                  <a:srgbClr val="FFFFFF"/>
-                </a:solidFill>
-              </a:rPr>
-              <a:t>160 GSM • 64% Runs Small</a:t>
-            </a:r>
-          </a:p>
-          <a:p>
-            <a:pPr>
-              <a:defRPr sz="900"/>
-            </a:pPr>
-            <a:r>
-              <a:rPr>
-                <a:solidFill>
-                  <a:srgbClr val="64748B"/>
-                </a:solidFill>
-              </a:rPr>
-              <a:t>Friend Reply Latency
-</a:t>
-            </a:r>
-            <a:r>
-              <a:rPr b="1">
-                <a:solidFill>
-                  <a:srgbClr val="FFFFFF"/>
-                </a:solidFill>
-              </a:rPr>
-              <a:t>18 Hours on WhatsApp</a:t>
-            </a:r>
-          </a:p>
-          <a:p>
-            <a:pPr>
-              <a:defRPr sz="900"/>
-            </a:pPr>
-            <a:r>
-              <a:rPr>
-                <a:solidFill>
-                  <a:srgbClr val="64748B"/>
-                </a:solidFill>
-              </a:rPr>
-              <a:t>Cart Drop-Off Probability
-</a:t>
-            </a:r>
-            <a:r>
-              <a:rPr b="1">
-                <a:solidFill>
-                  <a:srgbClr val="FFFFFF"/>
-                </a:solidFill>
-              </a:rPr>
-              <a:t>68% After 48 Hours</a:t>
-            </a:r>
-          </a:p>
-          <a:p>
-            <a:pPr algn="ctr"/>
-            <a:r>
-              <a:rPr sz="950" b="1">
-                <a:solidFill>
-                  <a:srgbClr val="FF3F6C"/>
-                </a:solidFill>
-              </a:rPr>
-              <a:t>▶ Launch Spec Matrix</a:t>
-            </a:r>
-          </a:p>
-        </p:txBody>
-      </p:sp>
+        </p:spPr>
+      </p:pic>
       <p:sp>
         <p:nvSpPr>
           <p:cNvPr id="11" name="Rounded Rectangle 10"/>
@@ -8856,152 +8490,30 @@
           </a:p>
         </p:txBody>
       </p:sp>
-      <p:sp>
-        <p:nvSpPr>
-          <p:cNvPr id="10" name="TextBox 9"/>
-          <p:cNvSpPr txBox="1"/>
-          <p:nvPr/>
-        </p:nvSpPr>
-        <p:spPr>
-          <a:xfrm>
-            <a:off x="9281160" y="1828800"/>
-            <a:ext cx="2130552" cy="3429000"/>
+      <p:pic>
+        <p:nvPicPr>
+          <p:cNvPr id="10" name="Picture 9" descr="04_Figma_Mobile_Wishlist_Studio_Home.png"/>
+          <p:cNvPicPr>
+            <a:picLocks noChangeAspect="1"/>
+          </p:cNvPicPr>
+          <p:nvPr/>
+        </p:nvPicPr>
+        <p:blipFill>
+          <a:blip r:embed="rId2"/>
+          <a:stretch>
+            <a:fillRect/>
+          </a:stretch>
+        </p:blipFill>
+        <p:spPr>
+          <a:xfrm>
+            <a:off x="9217152" y="1719072"/>
+            <a:ext cx="2258568" cy="3648456"/>
           </a:xfrm>
           <a:prstGeom prst="rect">
             <a:avLst/>
           </a:prstGeom>
-          <a:noFill/>
-        </p:spPr>
-        <p:txBody>
-          <a:bodyPr wrap="square">
-            <a:spAutoFit/>
-          </a:bodyPr>
-          <a:lstStyle/>
-          <a:p>
-            <a:pPr>
-              <a:defRPr sz="1050" b="1">
-                <a:solidFill>
-                  <a:srgbClr val="FFFFFF"/>
-                </a:solidFill>
-              </a:defRPr>
-            </a:pPr>
-            <a:r>
-              <a:t>Target Cohort Profile</a:t>
-            </a:r>
-          </a:p>
-          <a:p>
-            <a:pPr>
-              <a:defRPr sz="900" b="1">
-                <a:solidFill>
-                  <a:srgbClr val="FF3F6C"/>
-                </a:solidFill>
-              </a:defRPr>
-            </a:pPr>
-            <a:r>
-              <a:t>[62% Wishlist MAU]</a:t>
-            </a:r>
-          </a:p>
-          <a:p>
-            <a:pPr>
-              <a:defRPr sz="900"/>
-            </a:pPr>
-            <a:r>
-              <a:rPr>
-                <a:solidFill>
-                  <a:srgbClr val="64748B"/>
-                </a:solidFill>
-              </a:rPr>
-              <a:t>Average Saved Items
-</a:t>
-            </a:r>
-            <a:r>
-              <a:rPr b="1">
-                <a:solidFill>
-                  <a:srgbClr val="FFFFFF"/>
-                </a:solidFill>
-              </a:rPr>
-              <a:t>38+ Items / User</a:t>
-            </a:r>
-          </a:p>
-          <a:p>
-            <a:pPr>
-              <a:defRPr sz="900"/>
-            </a:pPr>
-            <a:r>
-              <a:rPr>
-                <a:solidFill>
-                  <a:srgbClr val="64748B"/>
-                </a:solidFill>
-              </a:rPr>
-              <a:t>WhatsApp Sharers
-</a:t>
-            </a:r>
-            <a:r>
-              <a:rPr b="1">
-                <a:solidFill>
-                  <a:srgbClr val="FFFFFF"/>
-                </a:solidFill>
-              </a:rPr>
-              <a:t>66.6% Social Loop</a:t>
-            </a:r>
-          </a:p>
-          <a:p>
-            <a:pPr>
-              <a:defRPr sz="900"/>
-            </a:pPr>
-            <a:r>
-              <a:rPr>
-                <a:solidFill>
-                  <a:srgbClr val="64748B"/>
-                </a:solidFill>
-              </a:rPr>
-              <a:t>Core Motivation
-</a:t>
-            </a:r>
-            <a:r>
-              <a:rPr b="1">
-                <a:solidFill>
-                  <a:srgbClr val="FFFFFF"/>
-                </a:solidFill>
-              </a:rPr>
-              <a:t>Decision Confidence</a:t>
-            </a:r>
-          </a:p>
-          <a:p>
-            <a:pPr>
-              <a:defRPr sz="900"/>
-            </a:pPr>
-            <a:r>
-              <a:rPr>
-                <a:solidFill>
-                  <a:srgbClr val="64748B"/>
-                </a:solidFill>
-              </a:rPr>
-              <a:t>Willingness to Buy
-</a:t>
-            </a:r>
-            <a:r>
-              <a:rPr b="1">
-                <a:solidFill>
-                  <a:srgbClr val="FFFFFF"/>
-                </a:solidFill>
-              </a:rPr>
-              <a:t>88.9% with Spec Matrix</a:t>
-            </a:r>
-          </a:p>
-          <a:p>
-            <a:pPr algn="ctr"/>
-            <a:r>
-              <a:rPr sz="950" b="1">
-                <a:solidFill>
-                  <a:srgbClr val="FF3F6C"/>
-                </a:solidFill>
-              </a:rPr>
-              <a:t>▶ View Persona Journey</a:t>
-            </a:r>
-          </a:p>
-        </p:txBody>
-      </p:sp>
+        </p:spPr>
+      </p:pic>
       <p:sp>
         <p:nvSpPr>
           <p:cNvPr id="11" name="Rounded Rectangle 10"/>
@@ -11330,152 +10842,30 @@
           </a:p>
         </p:txBody>
       </p:sp>
-      <p:sp>
-        <p:nvSpPr>
-          <p:cNvPr id="10" name="TextBox 9"/>
-          <p:cNvSpPr txBox="1"/>
-          <p:nvPr/>
-        </p:nvSpPr>
-        <p:spPr>
-          <a:xfrm>
-            <a:off x="9281160" y="1828800"/>
-            <a:ext cx="2130552" cy="3429000"/>
+      <p:pic>
+        <p:nvPicPr>
+          <p:cNvPr id="10" name="Picture 9" descr="02_Figma_Mobile_AI_Outfit_Coordinator.png"/>
+          <p:cNvPicPr>
+            <a:picLocks noChangeAspect="1"/>
+          </p:cNvPicPr>
+          <p:nvPr/>
+        </p:nvPicPr>
+        <p:blipFill>
+          <a:blip r:embed="rId2"/>
+          <a:stretch>
+            <a:fillRect/>
+          </a:stretch>
+        </p:blipFill>
+        <p:spPr>
+          <a:xfrm>
+            <a:off x="9217152" y="1719072"/>
+            <a:ext cx="2258568" cy="3648456"/>
           </a:xfrm>
           <a:prstGeom prst="rect">
             <a:avLst/>
           </a:prstGeom>
-          <a:noFill/>
-        </p:spPr>
-        <p:txBody>
-          <a:bodyPr wrap="square">
-            <a:spAutoFit/>
-          </a:bodyPr>
-          <a:lstStyle/>
-          <a:p>
-            <a:pPr>
-              <a:defRPr sz="1050" b="1">
-                <a:solidFill>
-                  <a:srgbClr val="FFFFFF"/>
-                </a:solidFill>
-              </a:defRPr>
-            </a:pPr>
-            <a:r>
-              <a:t>Strategic Moat Engine</a:t>
-            </a:r>
-          </a:p>
-          <a:p>
-            <a:pPr>
-              <a:defRPr sz="900" b="1">
-                <a:solidFill>
-                  <a:srgbClr val="FF3F6C"/>
-                </a:solidFill>
-              </a:defRPr>
-            </a:pPr>
-            <a:r>
-              <a:t>[Quadrant 2 Moat]</a:t>
-            </a:r>
-          </a:p>
-          <a:p>
-            <a:pPr>
-              <a:defRPr sz="900"/>
-            </a:pPr>
-            <a:r>
-              <a:rPr>
-                <a:solidFill>
-                  <a:srgbClr val="64748B"/>
-                </a:solidFill>
-              </a:rPr>
-              <a:t>Feature 1 (Spec Matrix)
-</a:t>
-            </a:r>
-            <a:r>
-              <a:rPr b="1">
-                <a:solidFill>
-                  <a:srgbClr val="FFFFFF"/>
-                </a:solidFill>
-              </a:rPr>
-              <a:t>RICE: 3,780 (Rank #1)</a:t>
-            </a:r>
-          </a:p>
-          <a:p>
-            <a:pPr>
-              <a:defRPr sz="900"/>
-            </a:pPr>
-            <a:r>
-              <a:rPr>
-                <a:solidFill>
-                  <a:srgbClr val="64748B"/>
-                </a:solidFill>
-              </a:rPr>
-              <a:t>Feature 2 (WhatsApp Poll)
-</a:t>
-            </a:r>
-            <a:r>
-              <a:rPr b="1">
-                <a:solidFill>
-                  <a:srgbClr val="FFFFFF"/>
-                </a:solidFill>
-              </a:rPr>
-              <a:t>RICE: 2,975 (Rank #2)</a:t>
-            </a:r>
-          </a:p>
-          <a:p>
-            <a:pPr>
-              <a:defRPr sz="900"/>
-            </a:pPr>
-            <a:r>
-              <a:rPr>
-                <a:solidFill>
-                  <a:srgbClr val="64748B"/>
-                </a:solidFill>
-              </a:rPr>
-              <a:t>Feature 3 (AI Looks)
-</a:t>
-            </a:r>
-            <a:r>
-              <a:rPr b="1">
-                <a:solidFill>
-                  <a:srgbClr val="FFFFFF"/>
-                </a:solidFill>
-              </a:rPr>
-              <a:t>RICE: 2,740 (Rank #3)</a:t>
-            </a:r>
-          </a:p>
-          <a:p>
-            <a:pPr>
-              <a:defRPr sz="900"/>
-            </a:pPr>
-            <a:r>
-              <a:rPr>
-                <a:solidFill>
-                  <a:srgbClr val="64748B"/>
-                </a:solidFill>
-              </a:rPr>
-              <a:t>Flash Coupon Spam
-</a:t>
-            </a:r>
-            <a:r>
-              <a:rPr b="1">
-                <a:solidFill>
-                  <a:srgbClr val="FFFFFF"/>
-                </a:solidFill>
-              </a:rPr>
-              <a:t>REJECTED (0 Moat)</a:t>
-            </a:r>
-          </a:p>
-          <a:p>
-            <a:pPr algn="ctr"/>
-            <a:r>
-              <a:rPr sz="950" b="1">
-                <a:solidFill>
-                  <a:srgbClr val="FF3F6C"/>
-                </a:solidFill>
-              </a:rPr>
-              <a:t>▶ View RICE Matrix</a:t>
-            </a:r>
-          </a:p>
-        </p:txBody>
-      </p:sp>
+        </p:spPr>
+      </p:pic>
       <p:sp>
         <p:nvSpPr>
           <p:cNvPr id="11" name="Rounded Rectangle 10"/>
@@ -12313,8 +11703,8 @@
         </p:nvSpPr>
         <p:spPr>
           <a:xfrm>
-            <a:off x="777240" y="1783080"/>
-            <a:ext cx="3200400" cy="3520440"/>
+            <a:off x="731520" y="1691640"/>
+            <a:ext cx="3291840" cy="411480"/>
           </a:xfrm>
           <a:prstGeom prst="rect">
             <a:avLst/>
@@ -12328,7 +11718,7 @@
           <a:lstStyle/>
           <a:p>
             <a:pPr>
-              <a:defRPr sz="1050" b="1">
+              <a:defRPr sz="950" b="1">
                 <a:solidFill>
                   <a:srgbClr val="2D0A4E"/>
                 </a:solidFill>
@@ -12338,85 +11728,70 @@
               <a:t>Feature 1: Side-by-Side Spec Matrix</a:t>
             </a:r>
           </a:p>
+        </p:txBody>
+      </p:sp>
+      <p:pic>
+        <p:nvPicPr>
+          <p:cNvPr id="7" name="Picture 6" descr="01_Figma_Mobile_Spec_Comparison_Matrix.png"/>
+          <p:cNvPicPr>
+            <a:picLocks noChangeAspect="1"/>
+          </p:cNvPicPr>
+          <p:nvPr/>
+        </p:nvPicPr>
+        <p:blipFill>
+          <a:blip r:embed="rId2"/>
+          <a:stretch>
+            <a:fillRect/>
+          </a:stretch>
+        </p:blipFill>
+        <p:spPr>
+          <a:xfrm>
+            <a:off x="777240" y="2057400"/>
+            <a:ext cx="3200400" cy="2926080"/>
+          </a:xfrm>
+          <a:prstGeom prst="rect">
+            <a:avLst/>
+          </a:prstGeom>
+        </p:spPr>
+      </p:pic>
+      <p:sp>
+        <p:nvSpPr>
+          <p:cNvPr id="8" name="TextBox 7"/>
+          <p:cNvSpPr txBox="1"/>
+          <p:nvPr/>
+        </p:nvSpPr>
+        <p:spPr>
+          <a:xfrm>
+            <a:off x="731520" y="5029200"/>
+            <a:ext cx="3291840" cy="365760"/>
+          </a:xfrm>
+          <a:prstGeom prst="rect">
+            <a:avLst/>
+          </a:prstGeom>
+          <a:noFill/>
+        </p:spPr>
+        <p:txBody>
+          <a:bodyPr wrap="square">
+            <a:spAutoFit/>
+          </a:bodyPr>
+          <a:lstStyle/>
           <a:p>
             <a:pPr>
-              <a:defRPr sz="900" b="1">
+              <a:defRPr sz="850" b="1">
                 <a:solidFill>
                   <a:srgbClr val="FF3F6C"/>
                 </a:solidFill>
               </a:defRPr>
             </a:pPr>
             <a:r>
-              <a:t>[RICE: 3,780 (#1)]</a:t>
-            </a:r>
-          </a:p>
-          <a:p>
-            <a:br/>
-            <a:pPr>
-              <a:defRPr sz="950" b="1">
-                <a:solidFill>
-                  <a:srgbClr val="0F172A"/>
-                </a:solidFill>
-              </a:defRPr>
-            </a:pPr>
-            <a:r>
-              <a:t>UI Component Header:</a:t>
-            </a:r>
-            <a:br/>
-            <a:r>
-              <a:t>Inline Spec &amp; GSM Comparison</a:t>
-            </a:r>
-          </a:p>
-          <a:p>
-            <a:pPr>
-              <a:defRPr sz="900">
-                <a:solidFill>
-                  <a:srgbClr val="64748B"/>
-                </a:solidFill>
-              </a:defRPr>
-            </a:pPr>
-            <a:r>
-              <a:t>Primary Details:</a:t>
-            </a:r>
-            <a:br/>
-            <a:r>
-              <a:t>Heavy Street Cargo</a:t>
-            </a:r>
-            <a:br/>
-            <a:r>
-              <a:t>240 GSM Heavy Cotton</a:t>
-            </a:r>
-            <a:br/>
-            <a:r>
-              <a:t>88% True to Size</a:t>
-            </a:r>
-            <a:br/>
-            <a:r>
-              <a:t>Real Customer Photos</a:t>
-            </a:r>
-          </a:p>
-          <a:p>
-            <a:br/>
-            <a:pPr>
-              <a:defRPr sz="950" b="1">
-                <a:solidFill>
-                  <a:srgbClr val="4F46E5"/>
-                </a:solidFill>
-              </a:defRPr>
-            </a:pPr>
-            <a:r>
-              <a:t>Impact Value:</a:t>
-            </a:r>
-            <a:br/>
-            <a:r>
-              <a:t>Solves comparison paralysis in under 60 seconds.</a:t>
-            </a:r>
-          </a:p>
-        </p:txBody>
-      </p:sp>
-      <p:sp>
-        <p:nvSpPr>
-          <p:cNvPr id="7" name="Rounded Rectangle 6"/>
+              <a:t>⚡ Solves comparison paralysis in under 60 seconds.</a:t>
+            </a:r>
+          </a:p>
+        </p:txBody>
+      </p:sp>
+      <p:sp>
+        <p:nvSpPr>
+          <p:cNvPr id="9" name="Rounded Rectangle 8"/>
           <p:cNvSpPr/>
           <p:nvPr/>
         </p:nvSpPr>
@@ -12461,14 +11836,14 @@
       </p:sp>
       <p:sp>
         <p:nvSpPr>
-          <p:cNvPr id="8" name="TextBox 7"/>
+          <p:cNvPr id="10" name="TextBox 9"/>
           <p:cNvSpPr txBox="1"/>
           <p:nvPr/>
         </p:nvSpPr>
         <p:spPr>
           <a:xfrm>
-            <a:off x="4489704" y="1783080"/>
-            <a:ext cx="3200400" cy="3520440"/>
+            <a:off x="4443984" y="1691640"/>
+            <a:ext cx="3291840" cy="411480"/>
           </a:xfrm>
           <a:prstGeom prst="rect">
             <a:avLst/>
@@ -12482,7 +11857,7 @@
           <a:lstStyle/>
           <a:p>
             <a:pPr>
-              <a:defRPr sz="1050" b="1">
+              <a:defRPr sz="950" b="1">
                 <a:solidFill>
                   <a:srgbClr val="2D0A4E"/>
                 </a:solidFill>
@@ -12492,81 +11867,70 @@
               <a:t>Feature 2: AI Coordinated Look Builder</a:t>
             </a:r>
           </a:p>
+        </p:txBody>
+      </p:sp>
+      <p:pic>
+        <p:nvPicPr>
+          <p:cNvPr id="11" name="Picture 10" descr="02_Figma_Mobile_AI_Outfit_Coordinator.png"/>
+          <p:cNvPicPr>
+            <a:picLocks noChangeAspect="1"/>
+          </p:cNvPicPr>
+          <p:nvPr/>
+        </p:nvPicPr>
+        <p:blipFill>
+          <a:blip r:embed="rId3"/>
+          <a:stretch>
+            <a:fillRect/>
+          </a:stretch>
+        </p:blipFill>
+        <p:spPr>
+          <a:xfrm>
+            <a:off x="4489704" y="2057400"/>
+            <a:ext cx="3200400" cy="2926080"/>
+          </a:xfrm>
+          <a:prstGeom prst="rect">
+            <a:avLst/>
+          </a:prstGeom>
+        </p:spPr>
+      </p:pic>
+      <p:sp>
+        <p:nvSpPr>
+          <p:cNvPr id="12" name="TextBox 11"/>
+          <p:cNvSpPr txBox="1"/>
+          <p:nvPr/>
+        </p:nvSpPr>
+        <p:spPr>
+          <a:xfrm>
+            <a:off x="4443984" y="5029200"/>
+            <a:ext cx="3291840" cy="365760"/>
+          </a:xfrm>
+          <a:prstGeom prst="rect">
+            <a:avLst/>
+          </a:prstGeom>
+          <a:noFill/>
+        </p:spPr>
+        <p:txBody>
+          <a:bodyPr wrap="square">
+            <a:spAutoFit/>
+          </a:bodyPr>
+          <a:lstStyle/>
           <a:p>
             <a:pPr>
-              <a:defRPr sz="900" b="1">
+              <a:defRPr sz="850" b="1">
                 <a:solidFill>
                   <a:srgbClr val="FF3F6C"/>
                 </a:solidFill>
               </a:defRPr>
             </a:pPr>
             <a:r>
-              <a:t>[RICE: 2,740 (#3)]</a:t>
-            </a:r>
-          </a:p>
-          <a:p>
-            <a:br/>
-            <a:pPr>
-              <a:defRPr sz="950" b="1">
-                <a:solidFill>
-                  <a:srgbClr val="0F172A"/>
-                </a:solidFill>
-              </a:defRPr>
-            </a:pPr>
-            <a:r>
-              <a:t>UI Component Header:</a:t>
-            </a:r>
-            <a:br/>
-            <a:r>
-              <a:t>3 Curated Outfits per Item</a:t>
-            </a:r>
-          </a:p>
-          <a:p>
-            <a:pPr>
-              <a:defRPr sz="900">
-                <a:solidFill>
-                  <a:srgbClr val="64748B"/>
-                </a:solidFill>
-              </a:defRPr>
-            </a:pPr>
-            <a:r>
-              <a:t>Primary Details:</a:t>
-            </a:r>
-            <a:br/>
-            <a:r>
-              <a:t>Selected: Heavy Cargo (₹1,999)</a:t>
-            </a:r>
-            <a:br/>
-            <a:r>
-              <a:t>+ Oversized Tee (₹899)</a:t>
-            </a:r>
-            <a:br/>
-            <a:r>
-              <a:t>+ Canvas Sneakers (₹1,499)</a:t>
-            </a:r>
-          </a:p>
-          <a:p>
-            <a:br/>
-            <a:pPr>
-              <a:defRPr sz="950" b="1">
-                <a:solidFill>
-                  <a:srgbClr val="4F46E5"/>
-                </a:solidFill>
-              </a:defRPr>
-            </a:pPr>
-            <a:r>
-              <a:t>Impact Value:</a:t>
-            </a:r>
-            <a:br/>
-            <a:r>
-              <a:t>Lifts Average Order Value by +₹450 / order.</a:t>
-            </a:r>
-          </a:p>
-        </p:txBody>
-      </p:sp>
-      <p:sp>
-        <p:nvSpPr>
-          <p:cNvPr id="9" name="Rounded Rectangle 8"/>
+              <a:t>⚡ Lifts Average Order Value by +₹450 / order.</a:t>
+            </a:r>
+          </a:p>
+        </p:txBody>
+      </p:sp>
+      <p:sp>
+        <p:nvSpPr>
+          <p:cNvPr id="13" name="Rounded Rectangle 12"/>
           <p:cNvSpPr/>
           <p:nvPr/>
         </p:nvSpPr>
@@ -12611,14 +11975,14 @@
       </p:sp>
       <p:sp>
         <p:nvSpPr>
-          <p:cNvPr id="10" name="TextBox 9"/>
+          <p:cNvPr id="14" name="TextBox 13"/>
           <p:cNvSpPr txBox="1"/>
           <p:nvPr/>
         </p:nvSpPr>
         <p:spPr>
           <a:xfrm>
-            <a:off x="8202168" y="1783080"/>
-            <a:ext cx="3200400" cy="3520440"/>
+            <a:off x="8156448" y="1691640"/>
+            <a:ext cx="3291840" cy="411480"/>
           </a:xfrm>
           <a:prstGeom prst="rect">
             <a:avLst/>
@@ -12632,7 +11996,7 @@
           <a:lstStyle/>
           <a:p>
             <a:pPr>
-              <a:defRPr sz="1050" b="1">
+              <a:defRPr sz="950" b="1">
                 <a:solidFill>
                   <a:srgbClr val="2D0A4E"/>
                 </a:solidFill>
@@ -12642,77 +12006,70 @@
               <a:t>Feature 3: 1-Tap WhatsApp Voting Card</a:t>
             </a:r>
           </a:p>
+        </p:txBody>
+      </p:sp>
+      <p:pic>
+        <p:nvPicPr>
+          <p:cNvPr id="15" name="Picture 14" descr="03_Figma_Mobile_WhatsApp_Voting_Card.png"/>
+          <p:cNvPicPr>
+            <a:picLocks noChangeAspect="1"/>
+          </p:cNvPicPr>
+          <p:nvPr/>
+        </p:nvPicPr>
+        <p:blipFill>
+          <a:blip r:embed="rId4"/>
+          <a:stretch>
+            <a:fillRect/>
+          </a:stretch>
+        </p:blipFill>
+        <p:spPr>
+          <a:xfrm>
+            <a:off x="8202168" y="2057400"/>
+            <a:ext cx="3200400" cy="2926080"/>
+          </a:xfrm>
+          <a:prstGeom prst="rect">
+            <a:avLst/>
+          </a:prstGeom>
+        </p:spPr>
+      </p:pic>
+      <p:sp>
+        <p:nvSpPr>
+          <p:cNvPr id="16" name="TextBox 15"/>
+          <p:cNvSpPr txBox="1"/>
+          <p:nvPr/>
+        </p:nvSpPr>
+        <p:spPr>
+          <a:xfrm>
+            <a:off x="8156448" y="5029200"/>
+            <a:ext cx="3291840" cy="365760"/>
+          </a:xfrm>
+          <a:prstGeom prst="rect">
+            <a:avLst/>
+          </a:prstGeom>
+          <a:noFill/>
+        </p:spPr>
+        <p:txBody>
+          <a:bodyPr wrap="square">
+            <a:spAutoFit/>
+          </a:bodyPr>
+          <a:lstStyle/>
           <a:p>
             <a:pPr>
-              <a:defRPr sz="900" b="1">
+              <a:defRPr sz="850" b="1">
                 <a:solidFill>
                   <a:srgbClr val="FF3F6C"/>
                 </a:solidFill>
               </a:defRPr>
             </a:pPr>
             <a:r>
-              <a:t>[RICE: 2,975 (#2)]</a:t>
-            </a:r>
-          </a:p>
-          <a:p>
-            <a:br/>
-            <a:pPr>
-              <a:defRPr sz="950" b="1">
-                <a:solidFill>
-                  <a:srgbClr val="0F172A"/>
-                </a:solidFill>
-              </a:defRPr>
-            </a:pPr>
-            <a:r>
-              <a:t>UI Component Header:</a:t>
-            </a:r>
-            <a:br/>
-            <a:r>
-              <a:t>Friend Polling + Instant AI Fallback</a:t>
-            </a:r>
-          </a:p>
-          <a:p>
-            <a:pPr>
-              <a:defRPr sz="900">
-                <a:solidFill>
-                  <a:srgbClr val="64748B"/>
-                </a:solidFill>
-              </a:defRPr>
-            </a:pPr>
-            <a:r>
-              <a:t>Primary Details:</a:t>
-            </a:r>
-            <a:br/>
-            <a:r>
-              <a:t>WhatsApp Poll Card Sent</a:t>
-            </a:r>
-            <a:br/>
-            <a:r>
-              <a:t>Live Option A vs B Votes</a:t>
-            </a:r>
-          </a:p>
-          <a:p>
-            <a:br/>
-            <a:pPr>
-              <a:defRPr sz="950" b="1">
-                <a:solidFill>
-                  <a:srgbClr val="4F46E5"/>
-                </a:solidFill>
-              </a:defRPr>
-            </a:pPr>
-            <a:r>
-              <a:t>Impact Value:</a:t>
-            </a:r>
-            <a:br/>
-            <a:r>
-              <a:t>Slashes feedback delay from 18 hours to 2 seconds.</a:t>
-            </a:r>
-          </a:p>
-        </p:txBody>
-      </p:sp>
-      <p:sp>
-        <p:nvSpPr>
-          <p:cNvPr id="11" name="Rounded Rectangle 10"/>
+              <a:t>⚡ Slashes feedback delay from 18 hours to 2 seconds.</a:t>
+            </a:r>
+          </a:p>
+        </p:txBody>
+      </p:sp>
+      <p:sp>
+        <p:nvSpPr>
+          <p:cNvPr id="17" name="Rounded Rectangle 16"/>
           <p:cNvSpPr/>
           <p:nvPr/>
         </p:nvSpPr>
@@ -12757,7 +12114,7 @@
       </p:sp>
       <p:sp>
         <p:nvSpPr>
-          <p:cNvPr id="12" name="TextBox 11"/>
+          <p:cNvPr id="18" name="TextBox 17"/>
           <p:cNvSpPr txBox="1"/>
           <p:nvPr/>
         </p:nvSpPr>
@@ -12804,7 +12161,7 @@
       </p:sp>
       <p:sp>
         <p:nvSpPr>
-          <p:cNvPr id="13" name="Rounded Rectangle 12"/>
+          <p:cNvPr id="19" name="Rounded Rectangle 18"/>
           <p:cNvSpPr/>
           <p:nvPr/>
         </p:nvSpPr>
@@ -12858,7 +12215,7 @@
       </p:sp>
       <p:sp>
         <p:nvSpPr>
-          <p:cNvPr id="14" name="Rounded Rectangle 13"/>
+          <p:cNvPr id="20" name="Rounded Rectangle 19"/>
           <p:cNvSpPr/>
           <p:nvPr/>
         </p:nvSpPr>
@@ -12912,7 +12269,7 @@
       </p:sp>
       <p:sp>
         <p:nvSpPr>
-          <p:cNvPr id="15" name="Rounded Rectangle 14"/>
+          <p:cNvPr id="21" name="Rounded Rectangle 20"/>
           <p:cNvSpPr/>
           <p:nvPr/>
         </p:nvSpPr>
@@ -12966,7 +12323,7 @@
       </p:sp>
       <p:sp>
         <p:nvSpPr>
-          <p:cNvPr id="16" name="Rounded Rectangle 15"/>
+          <p:cNvPr id="22" name="Rounded Rectangle 21"/>
           <p:cNvSpPr/>
           <p:nvPr/>
         </p:nvSpPr>
@@ -13020,7 +12377,7 @@
       </p:sp>
       <p:sp>
         <p:nvSpPr>
-          <p:cNvPr id="17" name="Rounded Rectangle 16"/>
+          <p:cNvPr id="23" name="Rounded Rectangle 22"/>
           <p:cNvSpPr/>
           <p:nvPr/>
         </p:nvSpPr>
@@ -13074,7 +12431,7 @@
       </p:sp>
       <p:sp>
         <p:nvSpPr>
-          <p:cNvPr id="18" name="Rounded Rectangle 17"/>
+          <p:cNvPr id="24" name="Rounded Rectangle 23"/>
           <p:cNvSpPr/>
           <p:nvPr/>
         </p:nvSpPr>
@@ -13128,7 +12485,7 @@
       </p:sp>
       <p:sp>
         <p:nvSpPr>
-          <p:cNvPr id="19" name="Rounded Rectangle 18"/>
+          <p:cNvPr id="25" name="Rounded Rectangle 24"/>
           <p:cNvSpPr/>
           <p:nvPr/>
         </p:nvSpPr>
@@ -13182,7 +12539,7 @@
       </p:sp>
       <p:sp>
         <p:nvSpPr>
-          <p:cNvPr id="20" name="Rounded Rectangle 19"/>
+          <p:cNvPr id="26" name="Rounded Rectangle 25"/>
           <p:cNvSpPr/>
           <p:nvPr/>
         </p:nvSpPr>
@@ -13236,7 +12593,7 @@
       </p:sp>
       <p:sp>
         <p:nvSpPr>
-          <p:cNvPr id="21" name="Rounded Rectangle 20"/>
+          <p:cNvPr id="27" name="Rounded Rectangle 26"/>
           <p:cNvSpPr/>
           <p:nvPr/>
         </p:nvSpPr>
@@ -13290,7 +12647,7 @@
       </p:sp>
       <p:sp>
         <p:nvSpPr>
-          <p:cNvPr id="22" name="Rounded Rectangle 21"/>
+          <p:cNvPr id="28" name="Rounded Rectangle 27"/>
           <p:cNvSpPr/>
           <p:nvPr/>
         </p:nvSpPr>
@@ -13931,152 +13288,30 @@
           </a:p>
         </p:txBody>
       </p:sp>
-      <p:sp>
-        <p:nvSpPr>
-          <p:cNvPr id="10" name="TextBox 9"/>
-          <p:cNvSpPr txBox="1"/>
-          <p:nvPr/>
-        </p:nvSpPr>
-        <p:spPr>
-          <a:xfrm>
-            <a:off x="9281160" y="1828800"/>
-            <a:ext cx="2130552" cy="3429000"/>
+      <p:pic>
+        <p:nvPicPr>
+          <p:cNvPr id="10" name="Picture 9" descr="05_Figma_Desktop_Web_Wishlist_Studio.png"/>
+          <p:cNvPicPr>
+            <a:picLocks noChangeAspect="1"/>
+          </p:cNvPicPr>
+          <p:nvPr/>
+        </p:nvPicPr>
+        <p:blipFill>
+          <a:blip r:embed="rId2"/>
+          <a:stretch>
+            <a:fillRect/>
+          </a:stretch>
+        </p:blipFill>
+        <p:spPr>
+          <a:xfrm>
+            <a:off x="9217152" y="1719072"/>
+            <a:ext cx="2258568" cy="3648456"/>
           </a:xfrm>
           <a:prstGeom prst="rect">
             <a:avLst/>
           </a:prstGeom>
-          <a:noFill/>
-        </p:spPr>
-        <p:txBody>
-          <a:bodyPr wrap="square">
-            <a:spAutoFit/>
-          </a:bodyPr>
-          <a:lstStyle/>
-          <a:p>
-            <a:pPr>
-              <a:defRPr sz="1050" b="1">
-                <a:solidFill>
-                  <a:srgbClr val="FFFFFF"/>
-                </a:solidFill>
-              </a:defRPr>
-            </a:pPr>
-            <a:r>
-              <a:t>Decision Architecture</a:t>
-            </a:r>
-          </a:p>
-          <a:p>
-            <a:pPr>
-              <a:defRPr sz="900" b="1">
-                <a:solidFill>
-                  <a:srgbClr val="FF3F6C"/>
-                </a:solidFill>
-              </a:defRPr>
-            </a:pPr>
-            <a:r>
-              <a:t>[p95 &lt; 180ms]</a:t>
-            </a:r>
-          </a:p>
-          <a:p>
-            <a:pPr>
-              <a:defRPr sz="900"/>
-            </a:pPr>
-            <a:r>
-              <a:rPr>
-                <a:solidFill>
-                  <a:srgbClr val="64748B"/>
-                </a:solidFill>
-              </a:rPr>
-              <a:t>Layer 1 (Client UI)
-</a:t>
-            </a:r>
-            <a:r>
-              <a:rPr b="1">
-                <a:solidFill>
-                  <a:srgbClr val="FFFFFF"/>
-                </a:solidFill>
-              </a:rPr>
-              <a:t>React 18 + Vite</a:t>
-            </a:r>
-          </a:p>
-          <a:p>
-            <a:pPr>
-              <a:defRPr sz="900"/>
-            </a:pPr>
-            <a:r>
-              <a:rPr>
-                <a:solidFill>
-                  <a:srgbClr val="64748B"/>
-                </a:solidFill>
-              </a:rPr>
-              <a:t>Layer 2 (Engine)
-</a:t>
-            </a:r>
-            <a:r>
-              <a:rPr b="1">
-                <a:solidFill>
-                  <a:srgbClr val="FFFFFF"/>
-                </a:solidFill>
-              </a:rPr>
-              <a:t>Fabric GSM Normalizer</a:t>
-            </a:r>
-          </a:p>
-          <a:p>
-            <a:pPr>
-              <a:defRPr sz="900"/>
-            </a:pPr>
-            <a:r>
-              <a:rPr>
-                <a:solidFill>
-                  <a:srgbClr val="64748B"/>
-                </a:solidFill>
-              </a:rPr>
-              <a:t>Layer 3 (Catalog)
-</a:t>
-            </a:r>
-            <a:r>
-              <a:rPr b="1">
-                <a:solidFill>
-                  <a:srgbClr val="FFFFFF"/>
-                </a:solidFill>
-              </a:rPr>
-              <a:t>Vendor Metadata CDN</a:t>
-            </a:r>
-          </a:p>
-          <a:p>
-            <a:pPr>
-              <a:defRPr sz="900"/>
-            </a:pPr>
-            <a:r>
-              <a:rPr>
-                <a:solidFill>
-                  <a:srgbClr val="64748B"/>
-                </a:solidFill>
-              </a:rPr>
-              <a:t>Layer 4 (Social)
-</a:t>
-            </a:r>
-            <a:r>
-              <a:rPr b="1">
-                <a:solidFill>
-                  <a:srgbClr val="FFFFFF"/>
-                </a:solidFill>
-              </a:rPr>
-              <a:t>WhatsApp Webhook Sync</a:t>
-            </a:r>
-          </a:p>
-          <a:p>
-            <a:pPr algn="ctr"/>
-            <a:r>
-              <a:rPr sz="950" b="1">
-                <a:solidFill>
-                  <a:srgbClr val="FF3F6C"/>
-                </a:solidFill>
-              </a:rPr>
-              <a:t>▶ View Architecture Diagram</a:t>
-            </a:r>
-          </a:p>
-        </p:txBody>
-      </p:sp>
+        </p:spPr>
+      </p:pic>
       <p:sp>
         <p:nvSpPr>
           <p:cNvPr id="11" name="Rounded Rectangle 10"/>
@@ -15298,152 +14533,30 @@
           </a:p>
         </p:txBody>
       </p:sp>
-      <p:sp>
-        <p:nvSpPr>
-          <p:cNvPr id="10" name="TextBox 9"/>
-          <p:cNvSpPr txBox="1"/>
-          <p:nvPr/>
-        </p:nvSpPr>
-        <p:spPr>
-          <a:xfrm>
-            <a:off x="9281160" y="1828800"/>
-            <a:ext cx="2130552" cy="3429000"/>
+      <p:pic>
+        <p:nvPicPr>
+          <p:cNvPr id="10" name="Picture 9" descr="01_Figma_Mobile_Spec_Comparison_Matrix.png"/>
+          <p:cNvPicPr>
+            <a:picLocks noChangeAspect="1"/>
+          </p:cNvPicPr>
+          <p:nvPr/>
+        </p:nvPicPr>
+        <p:blipFill>
+          <a:blip r:embed="rId2"/>
+          <a:stretch>
+            <a:fillRect/>
+          </a:stretch>
+        </p:blipFill>
+        <p:spPr>
+          <a:xfrm>
+            <a:off x="9217152" y="1719072"/>
+            <a:ext cx="2258568" cy="3648456"/>
           </a:xfrm>
           <a:prstGeom prst="rect">
             <a:avLst/>
           </a:prstGeom>
-          <a:noFill/>
-        </p:spPr>
-        <p:txBody>
-          <a:bodyPr wrap="square">
-            <a:spAutoFit/>
-          </a:bodyPr>
-          <a:lstStyle/>
-          <a:p>
-            <a:pPr>
-              <a:defRPr sz="1050" b="1">
-                <a:solidFill>
-                  <a:srgbClr val="FFFFFF"/>
-                </a:solidFill>
-              </a:defRPr>
-            </a:pPr>
-            <a:r>
-              <a:t>Amplitude Telemetry</a:t>
-            </a:r>
-          </a:p>
-          <a:p>
-            <a:pPr>
-              <a:defRPr sz="900" b="1">
-                <a:solidFill>
-                  <a:srgbClr val="FF3F6C"/>
-                </a:solidFill>
-              </a:defRPr>
-            </a:pPr>
-            <a:r>
-              <a:t>[200,000 RCT]</a:t>
-            </a:r>
-          </a:p>
-          <a:p>
-            <a:pPr>
-              <a:defRPr sz="900"/>
-            </a:pPr>
-            <a:r>
-              <a:rPr>
-                <a:solidFill>
-                  <a:srgbClr val="64748B"/>
-                </a:solidFill>
-              </a:rPr>
-              <a:t>North Star Target
-</a:t>
-            </a:r>
-            <a:r>
-              <a:rPr b="1">
-                <a:solidFill>
-                  <a:srgbClr val="FFFFFF"/>
-                </a:solidFill>
-              </a:rPr>
-              <a:t>10.5% (+300 bps)</a:t>
-            </a:r>
-          </a:p>
-          <a:p>
-            <a:pPr>
-              <a:defRPr sz="900"/>
-            </a:pPr>
-            <a:r>
-              <a:rPr>
-                <a:solidFill>
-                  <a:srgbClr val="64748B"/>
-                </a:solidFill>
-              </a:rPr>
-              <a:t>Return Rate Guardrail
-</a:t>
-            </a:r>
-            <a:r>
-              <a:rPr b="1">
-                <a:solidFill>
-                  <a:srgbClr val="FFFFFF"/>
-                </a:solidFill>
-              </a:rPr>
-              <a:t>≤ 18% (-600 bps)</a:t>
-            </a:r>
-          </a:p>
-          <a:p>
-            <a:pPr>
-              <a:defRPr sz="900"/>
-            </a:pPr>
-            <a:r>
-              <a:rPr>
-                <a:solidFill>
-                  <a:srgbClr val="64748B"/>
-                </a:solidFill>
-              </a:rPr>
-              <a:t>Sample Power
-</a:t>
-            </a:r>
-            <a:r>
-              <a:rPr b="1">
-                <a:solidFill>
-                  <a:srgbClr val="FFFFFF"/>
-                </a:solidFill>
-              </a:rPr>
-              <a:t>95% CI • 80% Power</a:t>
-            </a:r>
-          </a:p>
-          <a:p>
-            <a:pPr>
-              <a:defRPr sz="900"/>
-            </a:pPr>
-            <a:r>
-              <a:rPr>
-                <a:solidFill>
-                  <a:srgbClr val="64748B"/>
-                </a:solidFill>
-              </a:rPr>
-              <a:t>Instrumentation
-</a:t>
-            </a:r>
-            <a:r>
-              <a:rPr b="1">
-                <a:solidFill>
-                  <a:srgbClr val="FFFFFF"/>
-                </a:solidFill>
-              </a:rPr>
-              <a:t>Full Amplitude Schema</a:t>
-            </a:r>
-          </a:p>
-          <a:p>
-            <a:pPr algn="ctr"/>
-            <a:r>
-              <a:rPr sz="950" b="1">
-                <a:solidFill>
-                  <a:srgbClr val="FF3F6C"/>
-                </a:solidFill>
-              </a:rPr>
-              <a:t>▶ View Telemetry Schema</a:t>
-            </a:r>
-          </a:p>
-        </p:txBody>
-      </p:sp>
+        </p:spPr>
+      </p:pic>
       <p:sp>
         <p:nvSpPr>
           <p:cNvPr id="11" name="Rounded Rectangle 10"/>

</xml_diff>

<commit_message>
Fix true OpenXML paragraph margins (marL) and negative first-line indents (indent) for executive hanging bullet formatting across all 10 slides
</commit_message>
<xml_diff>
--- a/Myntra_Wishlist_Studio_10_Slide_Deck.pptx
+++ b/Myntra_Wishlist_Studio_10_Slide_Deck.pptx
@@ -3308,7 +3308,7 @@
           <a:noFill/>
         </p:spPr>
         <p:txBody>
-          <a:bodyPr wrap="square">
+          <a:bodyPr wrap="square" lIns="73152" rIns="73152" tIns="54864" bIns="54864">
             <a:spAutoFit/>
           </a:bodyPr>
           <a:lstStyle/>
@@ -3328,7 +3328,7 @@
             </a:r>
           </a:p>
           <a:p>
-            <a:pPr>
+            <a:pPr marL="203200" indent="-152400">
               <a:lnSpc>
                 <a:spcPct val="115000"/>
               </a:lnSpc>
@@ -3366,7 +3366,7 @@
             </a:r>
           </a:p>
           <a:p>
-            <a:pPr>
+            <a:pPr marL="203200" indent="-152400">
               <a:lnSpc>
                 <a:spcPct val="115000"/>
               </a:lnSpc>
@@ -3404,7 +3404,7 @@
             </a:r>
           </a:p>
           <a:p>
-            <a:pPr>
+            <a:pPr marL="203200" indent="-152400">
               <a:lnSpc>
                 <a:spcPct val="115000"/>
               </a:lnSpc>
@@ -3442,7 +3442,7 @@
             </a:r>
           </a:p>
           <a:p>
-            <a:pPr>
+            <a:pPr marL="203200" indent="-152400">
               <a:lnSpc>
                 <a:spcPct val="115000"/>
               </a:lnSpc>
@@ -3543,7 +3543,7 @@
           <a:noFill/>
         </p:spPr>
         <p:txBody>
-          <a:bodyPr wrap="square">
+          <a:bodyPr wrap="square" lIns="73152" rIns="73152" tIns="54864" bIns="54864">
             <a:spAutoFit/>
           </a:bodyPr>
           <a:lstStyle/>
@@ -3563,7 +3563,7 @@
             </a:r>
           </a:p>
           <a:p>
-            <a:pPr>
+            <a:pPr marL="203200" indent="-152400">
               <a:lnSpc>
                 <a:spcPct val="115000"/>
               </a:lnSpc>
@@ -3601,7 +3601,7 @@
             </a:r>
           </a:p>
           <a:p>
-            <a:pPr>
+            <a:pPr marL="203200" indent="-152400">
               <a:lnSpc>
                 <a:spcPct val="115000"/>
               </a:lnSpc>
@@ -3639,7 +3639,7 @@
             </a:r>
           </a:p>
           <a:p>
-            <a:pPr>
+            <a:pPr marL="203200" indent="-152400">
               <a:lnSpc>
                 <a:spcPct val="115000"/>
               </a:lnSpc>
@@ -3677,7 +3677,7 @@
             </a:r>
           </a:p>
           <a:p>
-            <a:pPr>
+            <a:pPr marL="203200" indent="-152400">
               <a:lnSpc>
                 <a:spcPct val="115000"/>
               </a:lnSpc>
@@ -5083,7 +5083,7 @@
           <a:noFill/>
         </p:spPr>
         <p:txBody>
-          <a:bodyPr wrap="square">
+          <a:bodyPr wrap="square" lIns="54864" rIns="54864">
             <a:spAutoFit/>
           </a:bodyPr>
           <a:lstStyle/>
@@ -5103,7 +5103,7 @@
             </a:r>
           </a:p>
           <a:p>
-            <a:pPr>
+            <a:pPr marL="127000" indent="0">
               <a:lnSpc>
                 <a:spcPct val="112000"/>
               </a:lnSpc>
@@ -5130,7 +5130,7 @@
             </a:r>
           </a:p>
           <a:p>
-            <a:pPr>
+            <a:pPr marL="127000" indent="0">
               <a:lnSpc>
                 <a:spcPct val="112000"/>
               </a:lnSpc>
@@ -5220,7 +5220,7 @@
           <a:noFill/>
         </p:spPr>
         <p:txBody>
-          <a:bodyPr wrap="square">
+          <a:bodyPr wrap="square" lIns="54864" rIns="54864">
             <a:spAutoFit/>
           </a:bodyPr>
           <a:lstStyle/>
@@ -5240,7 +5240,7 @@
             </a:r>
           </a:p>
           <a:p>
-            <a:pPr>
+            <a:pPr marL="127000" indent="0">
               <a:lnSpc>
                 <a:spcPct val="112000"/>
               </a:lnSpc>
@@ -5267,7 +5267,7 @@
             </a:r>
           </a:p>
           <a:p>
-            <a:pPr>
+            <a:pPr marL="127000" indent="0">
               <a:lnSpc>
                 <a:spcPct val="112000"/>
               </a:lnSpc>
@@ -5357,7 +5357,7 @@
           <a:noFill/>
         </p:spPr>
         <p:txBody>
-          <a:bodyPr wrap="square">
+          <a:bodyPr wrap="square" lIns="54864" rIns="54864">
             <a:spAutoFit/>
           </a:bodyPr>
           <a:lstStyle/>
@@ -5377,7 +5377,7 @@
             </a:r>
           </a:p>
           <a:p>
-            <a:pPr>
+            <a:pPr marL="127000" indent="0">
               <a:lnSpc>
                 <a:spcPct val="112000"/>
               </a:lnSpc>
@@ -5404,7 +5404,7 @@
             </a:r>
           </a:p>
           <a:p>
-            <a:pPr>
+            <a:pPr marL="127000" indent="0">
               <a:lnSpc>
                 <a:spcPct val="112000"/>
               </a:lnSpc>
@@ -5494,7 +5494,7 @@
           <a:noFill/>
         </p:spPr>
         <p:txBody>
-          <a:bodyPr wrap="square">
+          <a:bodyPr wrap="square" lIns="54864" rIns="54864">
             <a:spAutoFit/>
           </a:bodyPr>
           <a:lstStyle/>
@@ -5514,7 +5514,7 @@
             </a:r>
           </a:p>
           <a:p>
-            <a:pPr>
+            <a:pPr marL="127000" indent="0">
               <a:lnSpc>
                 <a:spcPct val="112000"/>
               </a:lnSpc>
@@ -5541,7 +5541,7 @@
             </a:r>
           </a:p>
           <a:p>
-            <a:pPr>
+            <a:pPr marL="127000" indent="0">
               <a:lnSpc>
                 <a:spcPct val="112000"/>
               </a:lnSpc>
@@ -5568,7 +5568,7 @@
             </a:r>
           </a:p>
           <a:p>
-            <a:pPr>
+            <a:pPr marL="127000" indent="0">
               <a:lnSpc>
                 <a:spcPct val="112000"/>
               </a:lnSpc>
@@ -5658,7 +5658,7 @@
           <a:noFill/>
         </p:spPr>
         <p:txBody>
-          <a:bodyPr wrap="square">
+          <a:bodyPr wrap="square" lIns="54864" rIns="54864">
             <a:spAutoFit/>
           </a:bodyPr>
           <a:lstStyle/>
@@ -5678,7 +5678,7 @@
             </a:r>
           </a:p>
           <a:p>
-            <a:pPr>
+            <a:pPr marL="127000" indent="0">
               <a:lnSpc>
                 <a:spcPct val="112000"/>
               </a:lnSpc>
@@ -5705,7 +5705,7 @@
             </a:r>
           </a:p>
           <a:p>
-            <a:pPr>
+            <a:pPr marL="127000" indent="0">
               <a:lnSpc>
                 <a:spcPct val="112000"/>
               </a:lnSpc>
@@ -5732,7 +5732,7 @@
             </a:r>
           </a:p>
           <a:p>
-            <a:pPr>
+            <a:pPr marL="127000" indent="0">
               <a:lnSpc>
                 <a:spcPct val="112000"/>
               </a:lnSpc>
@@ -5822,7 +5822,7 @@
           <a:noFill/>
         </p:spPr>
         <p:txBody>
-          <a:bodyPr wrap="square">
+          <a:bodyPr wrap="square" lIns="54864" rIns="54864">
             <a:spAutoFit/>
           </a:bodyPr>
           <a:lstStyle/>
@@ -5842,7 +5842,7 @@
             </a:r>
           </a:p>
           <a:p>
-            <a:pPr>
+            <a:pPr marL="127000" indent="0">
               <a:lnSpc>
                 <a:spcPct val="112000"/>
               </a:lnSpc>
@@ -5869,7 +5869,7 @@
             </a:r>
           </a:p>
           <a:p>
-            <a:pPr>
+            <a:pPr marL="127000" indent="0">
               <a:lnSpc>
                 <a:spcPct val="112000"/>
               </a:lnSpc>
@@ -5896,7 +5896,7 @@
             </a:r>
           </a:p>
           <a:p>
-            <a:pPr>
+            <a:pPr marL="127000" indent="0">
               <a:lnSpc>
                 <a:spcPct val="112000"/>
               </a:lnSpc>
@@ -6854,7 +6854,7 @@
           <a:noFill/>
         </p:spPr>
         <p:txBody>
-          <a:bodyPr wrap="square">
+          <a:bodyPr wrap="square" lIns="73152" rIns="73152">
             <a:spAutoFit/>
           </a:bodyPr>
           <a:lstStyle/>
@@ -6952,7 +6952,7 @@
           <a:noFill/>
         </p:spPr>
         <p:txBody>
-          <a:bodyPr wrap="square">
+          <a:bodyPr wrap="square" lIns="73152" rIns="73152">
             <a:spAutoFit/>
           </a:bodyPr>
           <a:lstStyle/>
@@ -6972,7 +6972,7 @@
             </a:r>
           </a:p>
           <a:p>
-            <a:pPr>
+            <a:pPr marL="203200" indent="-152400">
               <a:lnSpc>
                 <a:spcPct val="115000"/>
               </a:lnSpc>
@@ -7010,7 +7010,7 @@
             </a:r>
           </a:p>
           <a:p>
-            <a:pPr>
+            <a:pPr marL="203200" indent="-152400">
               <a:lnSpc>
                 <a:spcPct val="115000"/>
               </a:lnSpc>
@@ -7048,7 +7048,7 @@
             </a:r>
           </a:p>
           <a:p>
-            <a:pPr>
+            <a:pPr marL="203200" indent="-152400">
               <a:lnSpc>
                 <a:spcPct val="115000"/>
               </a:lnSpc>
@@ -7086,7 +7086,7 @@
             </a:r>
           </a:p>
           <a:p>
-            <a:pPr>
+            <a:pPr marL="203200" indent="-152400">
               <a:lnSpc>
                 <a:spcPct val="115000"/>
               </a:lnSpc>
@@ -7187,7 +7187,7 @@
           <a:noFill/>
         </p:spPr>
         <p:txBody>
-          <a:bodyPr wrap="square">
+          <a:bodyPr wrap="square" lIns="73152" rIns="73152">
             <a:spAutoFit/>
           </a:bodyPr>
           <a:lstStyle/>
@@ -7285,7 +7285,7 @@
           <a:noFill/>
         </p:spPr>
         <p:txBody>
-          <a:bodyPr wrap="square">
+          <a:bodyPr wrap="square" lIns="73152" rIns="73152">
             <a:spAutoFit/>
           </a:bodyPr>
           <a:lstStyle/>
@@ -7383,7 +7383,7 @@
           <a:noFill/>
         </p:spPr>
         <p:txBody>
-          <a:bodyPr wrap="square">
+          <a:bodyPr wrap="square" lIns="73152" rIns="73152">
             <a:spAutoFit/>
           </a:bodyPr>
           <a:lstStyle/>
@@ -8349,7 +8349,7 @@
           <a:noFill/>
         </p:spPr>
         <p:txBody>
-          <a:bodyPr wrap="square">
+          <a:bodyPr wrap="square" lIns="73152" rIns="73152">
             <a:spAutoFit/>
           </a:bodyPr>
           <a:lstStyle/>
@@ -8388,7 +8388,7 @@
             </a:r>
           </a:p>
           <a:p>
-            <a:pPr>
+            <a:pPr marL="177800" indent="0">
               <a:lnSpc>
                 <a:spcPct val="115000"/>
               </a:lnSpc>
@@ -8429,7 +8429,7 @@
             </a:r>
           </a:p>
           <a:p>
-            <a:pPr>
+            <a:pPr marL="177800" indent="0">
               <a:lnSpc>
                 <a:spcPct val="115000"/>
               </a:lnSpc>
@@ -8470,7 +8470,7 @@
             </a:r>
           </a:p>
           <a:p>
-            <a:pPr>
+            <a:pPr marL="177800" indent="0">
               <a:lnSpc>
                 <a:spcPct val="115000"/>
               </a:lnSpc>
@@ -8555,7 +8555,7 @@
           <a:noFill/>
         </p:spPr>
         <p:txBody>
-          <a:bodyPr wrap="square">
+          <a:bodyPr wrap="square" lIns="73152" rIns="73152">
             <a:spAutoFit/>
           </a:bodyPr>
           <a:lstStyle/>
@@ -8575,7 +8575,7 @@
             </a:r>
           </a:p>
           <a:p>
-            <a:pPr>
+            <a:pPr marL="177800" indent="-127000">
               <a:lnSpc>
                 <a:spcPct val="115000"/>
               </a:lnSpc>
@@ -8605,7 +8605,7 @@
             </a:r>
           </a:p>
           <a:p>
-            <a:pPr>
+            <a:pPr marL="177800" indent="-127000">
               <a:lnSpc>
                 <a:spcPct val="115000"/>
               </a:lnSpc>
@@ -8635,7 +8635,7 @@
             </a:r>
           </a:p>
           <a:p>
-            <a:pPr>
+            <a:pPr marL="177800" indent="-127000">
               <a:lnSpc>
                 <a:spcPct val="115000"/>
               </a:lnSpc>
@@ -8728,7 +8728,7 @@
           <a:noFill/>
         </p:spPr>
         <p:txBody>
-          <a:bodyPr wrap="square">
+          <a:bodyPr wrap="square" lIns="73152" rIns="73152">
             <a:spAutoFit/>
           </a:bodyPr>
           <a:lstStyle/>
@@ -8748,7 +8748,7 @@
             </a:r>
           </a:p>
           <a:p>
-            <a:pPr>
+            <a:pPr marL="203200" indent="-152400">
               <a:lnSpc>
                 <a:spcPct val="115000"/>
               </a:lnSpc>
@@ -8778,7 +8778,7 @@
             </a:r>
           </a:p>
           <a:p>
-            <a:pPr>
+            <a:pPr marL="203200" indent="-152400">
               <a:lnSpc>
                 <a:spcPct val="115000"/>
               </a:lnSpc>
@@ -8808,7 +8808,7 @@
             </a:r>
           </a:p>
           <a:p>
-            <a:pPr>
+            <a:pPr marL="203200" indent="-152400">
               <a:lnSpc>
                 <a:spcPct val="115000"/>
               </a:lnSpc>
@@ -9769,7 +9769,7 @@
           <a:noFill/>
         </p:spPr>
         <p:txBody>
-          <a:bodyPr wrap="square">
+          <a:bodyPr wrap="square" lIns="73152" rIns="73152">
             <a:spAutoFit/>
           </a:bodyPr>
           <a:lstStyle/>
@@ -9789,7 +9789,7 @@
             </a:r>
           </a:p>
           <a:p>
-            <a:pPr>
+            <a:pPr marL="177800" indent="-127000">
               <a:lnSpc>
                 <a:spcPct val="115000"/>
               </a:lnSpc>
@@ -9819,7 +9819,7 @@
             </a:r>
           </a:p>
           <a:p>
-            <a:pPr>
+            <a:pPr marL="177800" indent="-127000">
               <a:lnSpc>
                 <a:spcPct val="115000"/>
               </a:lnSpc>
@@ -9849,7 +9849,7 @@
             </a:r>
           </a:p>
           <a:p>
-            <a:pPr>
+            <a:pPr marL="177800" indent="-127000">
               <a:lnSpc>
                 <a:spcPct val="115000"/>
               </a:lnSpc>
@@ -9942,7 +9942,7 @@
           <a:noFill/>
         </p:spPr>
         <p:txBody>
-          <a:bodyPr wrap="square">
+          <a:bodyPr wrap="square" lIns="73152" rIns="73152">
             <a:spAutoFit/>
           </a:bodyPr>
           <a:lstStyle/>
@@ -9962,7 +9962,7 @@
             </a:r>
           </a:p>
           <a:p>
-            <a:pPr>
+            <a:pPr marL="177800" indent="-127000">
               <a:lnSpc>
                 <a:spcPct val="115000"/>
               </a:lnSpc>
@@ -9992,7 +9992,7 @@
             </a:r>
           </a:p>
           <a:p>
-            <a:pPr>
+            <a:pPr marL="177800" indent="-127000">
               <a:lnSpc>
                 <a:spcPct val="115000"/>
               </a:lnSpc>
@@ -10022,7 +10022,7 @@
             </a:r>
           </a:p>
           <a:p>
-            <a:pPr>
+            <a:pPr marL="177800" indent="-127000">
               <a:lnSpc>
                 <a:spcPct val="115000"/>
               </a:lnSpc>
@@ -10115,7 +10115,7 @@
           <a:noFill/>
         </p:spPr>
         <p:txBody>
-          <a:bodyPr wrap="square">
+          <a:bodyPr wrap="square" lIns="73152" rIns="73152">
             <a:spAutoFit/>
           </a:bodyPr>
           <a:lstStyle/>
@@ -10135,7 +10135,7 @@
             </a:r>
           </a:p>
           <a:p>
-            <a:pPr>
+            <a:pPr marL="177800" indent="-127000">
               <a:lnSpc>
                 <a:spcPct val="115000"/>
               </a:lnSpc>
@@ -10165,7 +10165,7 @@
             </a:r>
           </a:p>
           <a:p>
-            <a:pPr>
+            <a:pPr marL="177800" indent="-127000">
               <a:lnSpc>
                 <a:spcPct val="115000"/>
               </a:lnSpc>
@@ -10195,7 +10195,7 @@
             </a:r>
           </a:p>
           <a:p>
-            <a:pPr>
+            <a:pPr marL="177800" indent="-127000">
               <a:lnSpc>
                 <a:spcPct val="115000"/>
               </a:lnSpc>
@@ -10288,7 +10288,7 @@
           <a:noFill/>
         </p:spPr>
         <p:txBody>
-          <a:bodyPr wrap="square">
+          <a:bodyPr wrap="square" lIns="73152" rIns="73152">
             <a:spAutoFit/>
           </a:bodyPr>
           <a:lstStyle/>
@@ -10308,7 +10308,7 @@
             </a:r>
           </a:p>
           <a:p>
-            <a:pPr>
+            <a:pPr marL="177800" indent="-127000">
               <a:lnSpc>
                 <a:spcPct val="115000"/>
               </a:lnSpc>
@@ -10338,7 +10338,7 @@
             </a:r>
           </a:p>
           <a:p>
-            <a:pPr>
+            <a:pPr marL="177800" indent="-127000">
               <a:lnSpc>
                 <a:spcPct val="115000"/>
               </a:lnSpc>
@@ -10368,7 +10368,7 @@
             </a:r>
           </a:p>
           <a:p>
-            <a:pPr>
+            <a:pPr marL="177800" indent="-127000">
               <a:lnSpc>
                 <a:spcPct val="115000"/>
               </a:lnSpc>
@@ -11329,7 +11329,7 @@
           <a:noFill/>
         </p:spPr>
         <p:txBody>
-          <a:bodyPr wrap="square">
+          <a:bodyPr wrap="square" lIns="54864" rIns="54864">
             <a:spAutoFit/>
           </a:bodyPr>
           <a:lstStyle/>
@@ -11427,7 +11427,7 @@
           <a:noFill/>
         </p:spPr>
         <p:txBody>
-          <a:bodyPr wrap="square">
+          <a:bodyPr wrap="square" lIns="54864" rIns="54864">
             <a:spAutoFit/>
           </a:bodyPr>
           <a:lstStyle/>
@@ -11525,7 +11525,7 @@
           <a:noFill/>
         </p:spPr>
         <p:txBody>
-          <a:bodyPr wrap="square">
+          <a:bodyPr wrap="square" lIns="54864" rIns="54864">
             <a:spAutoFit/>
           </a:bodyPr>
           <a:lstStyle/>
@@ -11623,7 +11623,7 @@
           <a:noFill/>
         </p:spPr>
         <p:txBody>
-          <a:bodyPr wrap="square">
+          <a:bodyPr wrap="square" lIns="73152" rIns="73152">
             <a:spAutoFit/>
           </a:bodyPr>
           <a:lstStyle/>
@@ -11643,7 +11643,7 @@
             </a:r>
           </a:p>
           <a:p>
-            <a:pPr>
+            <a:pPr marL="177800" indent="-127000">
               <a:lnSpc>
                 <a:spcPct val="115000"/>
               </a:lnSpc>
@@ -11681,7 +11681,7 @@
             </a:r>
           </a:p>
           <a:p>
-            <a:pPr>
+            <a:pPr marL="177800" indent="-127000">
               <a:lnSpc>
                 <a:spcPct val="115000"/>
               </a:lnSpc>
@@ -11719,7 +11719,7 @@
             </a:r>
           </a:p>
           <a:p>
-            <a:pPr>
+            <a:pPr marL="177800" indent="-127000">
               <a:lnSpc>
                 <a:spcPct val="115000"/>
               </a:lnSpc>
@@ -11757,7 +11757,7 @@
             </a:r>
           </a:p>
           <a:p>
-            <a:pPr>
+            <a:pPr marL="177800" indent="-127000">
               <a:lnSpc>
                 <a:spcPct val="115000"/>
               </a:lnSpc>
@@ -11795,7 +11795,7 @@
             </a:r>
           </a:p>
           <a:p>
-            <a:pPr>
+            <a:pPr marL="177800" indent="-127000">
               <a:lnSpc>
                 <a:spcPct val="115000"/>
               </a:lnSpc>
@@ -11833,7 +11833,7 @@
             </a:r>
           </a:p>
           <a:p>
-            <a:pPr>
+            <a:pPr marL="177800" indent="-127000">
               <a:lnSpc>
                 <a:spcPct val="115000"/>
               </a:lnSpc>
@@ -12802,7 +12802,7 @@
           <a:noFill/>
         </p:spPr>
         <p:txBody>
-          <a:bodyPr wrap="square">
+          <a:bodyPr wrap="square" lIns="54864" rIns="54864">
             <a:spAutoFit/>
           </a:bodyPr>
           <a:lstStyle/>
@@ -12900,7 +12900,7 @@
           <a:noFill/>
         </p:spPr>
         <p:txBody>
-          <a:bodyPr wrap="square">
+          <a:bodyPr wrap="square" lIns="54864" rIns="54864">
             <a:spAutoFit/>
           </a:bodyPr>
           <a:lstStyle/>
@@ -12998,7 +12998,7 @@
           <a:noFill/>
         </p:spPr>
         <p:txBody>
-          <a:bodyPr wrap="square">
+          <a:bodyPr wrap="square" lIns="54864" rIns="54864">
             <a:spAutoFit/>
           </a:bodyPr>
           <a:lstStyle/>
@@ -13096,7 +13096,7 @@
           <a:noFill/>
         </p:spPr>
         <p:txBody>
-          <a:bodyPr wrap="square">
+          <a:bodyPr wrap="square" lIns="54864" rIns="54864">
             <a:spAutoFit/>
           </a:bodyPr>
           <a:lstStyle/>
@@ -13116,7 +13116,7 @@
             </a:r>
           </a:p>
           <a:p>
-            <a:pPr>
+            <a:pPr marL="152400" indent="-101600">
               <a:lnSpc>
                 <a:spcPct val="112000"/>
               </a:lnSpc>
@@ -13131,7 +13131,7 @@
             </a:r>
           </a:p>
           <a:p>
-            <a:pPr>
+            <a:pPr marL="152400" indent="-101600">
               <a:lnSpc>
                 <a:spcPct val="112000"/>
               </a:lnSpc>
@@ -13209,7 +13209,7 @@
           <a:noFill/>
         </p:spPr>
         <p:txBody>
-          <a:bodyPr wrap="square">
+          <a:bodyPr wrap="square" lIns="54864" rIns="54864">
             <a:spAutoFit/>
           </a:bodyPr>
           <a:lstStyle/>
@@ -14175,7 +14175,7 @@
           <a:noFill/>
         </p:spPr>
         <p:txBody>
-          <a:bodyPr wrap="square">
+          <a:bodyPr wrap="square" lIns="73152" rIns="73152">
             <a:spAutoFit/>
           </a:bodyPr>
           <a:lstStyle/>
@@ -14195,7 +14195,7 @@
             </a:r>
           </a:p>
           <a:p>
-            <a:pPr>
+            <a:pPr marL="177800" indent="-127000">
               <a:lnSpc>
                 <a:spcPct val="115000"/>
               </a:lnSpc>
@@ -14225,7 +14225,7 @@
             </a:r>
           </a:p>
           <a:p>
-            <a:pPr>
+            <a:pPr marL="177800" indent="-127000">
               <a:lnSpc>
                 <a:spcPct val="115000"/>
               </a:lnSpc>
@@ -14255,7 +14255,7 @@
             </a:r>
           </a:p>
           <a:p>
-            <a:pPr>
+            <a:pPr marL="177800" indent="-127000">
               <a:lnSpc>
                 <a:spcPct val="115000"/>
               </a:lnSpc>
@@ -14348,7 +14348,7 @@
           <a:noFill/>
         </p:spPr>
         <p:txBody>
-          <a:bodyPr wrap="square">
+          <a:bodyPr wrap="square" lIns="73152" rIns="73152">
             <a:spAutoFit/>
           </a:bodyPr>
           <a:lstStyle/>
@@ -14368,7 +14368,7 @@
             </a:r>
           </a:p>
           <a:p>
-            <a:pPr>
+            <a:pPr marL="177800" indent="-127000">
               <a:lnSpc>
                 <a:spcPct val="115000"/>
               </a:lnSpc>
@@ -14414,7 +14414,7 @@
             </a:r>
           </a:p>
           <a:p>
-            <a:pPr>
+            <a:pPr marL="177800" indent="-127000">
               <a:lnSpc>
                 <a:spcPct val="115000"/>
               </a:lnSpc>
@@ -14460,7 +14460,7 @@
             </a:r>
           </a:p>
           <a:p>
-            <a:pPr>
+            <a:pPr marL="177800" indent="-127000">
               <a:lnSpc>
                 <a:spcPct val="115000"/>
               </a:lnSpc>
@@ -15437,7 +15437,7 @@
           <a:noFill/>
         </p:spPr>
         <p:txBody>
-          <a:bodyPr wrap="square">
+          <a:bodyPr wrap="square" lIns="73152" rIns="73152">
             <a:spAutoFit/>
           </a:bodyPr>
           <a:lstStyle/>
@@ -15457,7 +15457,7 @@
             </a:r>
           </a:p>
           <a:p>
-            <a:pPr>
+            <a:pPr marL="177800" indent="-127000">
               <a:lnSpc>
                 <a:spcPct val="112000"/>
               </a:lnSpc>
@@ -15487,7 +15487,7 @@
             </a:r>
           </a:p>
           <a:p>
-            <a:pPr>
+            <a:pPr marL="177800" indent="-127000">
               <a:lnSpc>
                 <a:spcPct val="112000"/>
               </a:lnSpc>
@@ -15517,7 +15517,7 @@
             </a:r>
           </a:p>
           <a:p>
-            <a:pPr>
+            <a:pPr marL="177800" indent="-127000">
               <a:lnSpc>
                 <a:spcPct val="112000"/>
               </a:lnSpc>
@@ -15547,7 +15547,7 @@
             </a:r>
           </a:p>
           <a:p>
-            <a:pPr>
+            <a:pPr marL="177800" indent="-127000">
               <a:lnSpc>
                 <a:spcPct val="112000"/>
               </a:lnSpc>
@@ -16820,7 +16820,7 @@
           <a:noFill/>
         </p:spPr>
         <p:txBody>
-          <a:bodyPr wrap="square">
+          <a:bodyPr wrap="square" lIns="73152" rIns="73152">
             <a:spAutoFit/>
           </a:bodyPr>
           <a:lstStyle/>
@@ -16840,7 +16840,7 @@
             </a:r>
           </a:p>
           <a:p>
-            <a:pPr>
+            <a:pPr marL="177800" indent="-127000">
               <a:lnSpc>
                 <a:spcPct val="115000"/>
               </a:lnSpc>
@@ -16878,7 +16878,7 @@
             </a:r>
           </a:p>
           <a:p>
-            <a:pPr>
+            <a:pPr marL="177800" indent="-127000">
               <a:lnSpc>
                 <a:spcPct val="115000"/>
               </a:lnSpc>
@@ -16916,7 +16916,7 @@
             </a:r>
           </a:p>
           <a:p>
-            <a:pPr>
+            <a:pPr marL="177800" indent="-127000">
               <a:lnSpc>
                 <a:spcPct val="115000"/>
               </a:lnSpc>
@@ -16954,7 +16954,7 @@
             </a:r>
           </a:p>
           <a:p>
-            <a:pPr>
+            <a:pPr marL="177800" indent="-127000">
               <a:lnSpc>
                 <a:spcPct val="115000"/>
               </a:lnSpc>
@@ -17055,7 +17055,7 @@
           <a:noFill/>
         </p:spPr>
         <p:txBody>
-          <a:bodyPr wrap="square">
+          <a:bodyPr wrap="square" lIns="73152" rIns="73152">
             <a:spAutoFit/>
           </a:bodyPr>
           <a:lstStyle/>
@@ -17075,7 +17075,7 @@
             </a:r>
           </a:p>
           <a:p>
-            <a:pPr>
+            <a:pPr marL="177800" indent="-127000">
               <a:lnSpc>
                 <a:spcPct val="115000"/>
               </a:lnSpc>
@@ -17105,7 +17105,7 @@
             </a:r>
           </a:p>
           <a:p>
-            <a:pPr>
+            <a:pPr marL="177800" indent="-127000">
               <a:lnSpc>
                 <a:spcPct val="115000"/>
               </a:lnSpc>
@@ -17135,7 +17135,7 @@
             </a:r>
           </a:p>
           <a:p>
-            <a:pPr>
+            <a:pPr marL="177800" indent="-127000">
               <a:lnSpc>
                 <a:spcPct val="115000"/>
               </a:lnSpc>
@@ -17165,7 +17165,7 @@
             </a:r>
           </a:p>
           <a:p>
-            <a:pPr>
+            <a:pPr marL="177800" indent="-127000">
               <a:lnSpc>
                 <a:spcPct val="115000"/>
               </a:lnSpc>

</xml_diff>

<commit_message>
Implement visual flowchart process cards across Slide 8 (ML Pipeline), Slide 2 (Discovery Funnel), and Slide 3 (Corpus Funnel)
</commit_message>
<xml_diff>
--- a/Myntra_Wishlist_Studio_10_Slide_Deck.pptx
+++ b/Myntra_Wishlist_Studio_10_Slide_Deck.pptx
@@ -6943,8 +6943,8 @@
         </p:nvSpPr>
         <p:spPr>
           <a:xfrm>
-            <a:off x="749808" y="2907792"/>
-            <a:ext cx="5724144" cy="2468880"/>
+            <a:off x="749808" y="2889504"/>
+            <a:ext cx="5724144" cy="320040"/>
           </a:xfrm>
           <a:prstGeom prst="rect">
             <a:avLst/>
@@ -6952,15 +6952,12 @@
           <a:noFill/>
         </p:spPr>
         <p:txBody>
-          <a:bodyPr wrap="square" lIns="73152" rIns="73152">
+          <a:bodyPr wrap="square">
             <a:spAutoFit/>
           </a:bodyPr>
           <a:lstStyle/>
           <a:p>
             <a:pPr>
-              <a:spcAft>
-                <a:spcPts val="600"/>
-              </a:spcAft>
               <a:defRPr sz="1050" b="1">
                 <a:solidFill>
                   <a:srgbClr val="FF3F6C"/>
@@ -6969,158 +6966,6 @@
             </a:pPr>
             <a:r>
               <a:t>🔄 CURRENT DISCOVERY FLOW (THE GRAVEYARD LOOP)</a:t>
-            </a:r>
-          </a:p>
-          <a:p>
-            <a:pPr marL="203200" indent="-152400">
-              <a:lnSpc>
-                <a:spcPct val="115000"/>
-              </a:lnSpc>
-              <a:spcBef>
-                <a:spcPts val="200"/>
-              </a:spcBef>
-              <a:spcAft>
-                <a:spcPts val="400"/>
-              </a:spcAft>
-              <a:defRPr sz="950"/>
-            </a:pPr>
-            <a:r>
-              <a:rPr b="1">
-                <a:solidFill>
-                  <a:srgbClr val="FF3F6C"/>
-                </a:solidFill>
-              </a:rPr>
-              <a:t>► </a:t>
-            </a:r>
-            <a:r>
-              <a:rPr b="1">
-                <a:solidFill>
-                  <a:srgbClr val="282C3F"/>
-                </a:solidFill>
-              </a:rPr>
-              <a:t>1. Intent Trigger: </a:t>
-            </a:r>
-            <a:r>
-              <a:rPr>
-                <a:solidFill>
-                  <a:srgbClr val="282C3F"/>
-                </a:solidFill>
-              </a:rPr>
-              <a:t>Browses app &amp; saves 3-4 style alternatives</a:t>
-            </a:r>
-          </a:p>
-          <a:p>
-            <a:pPr marL="203200" indent="-152400">
-              <a:lnSpc>
-                <a:spcPct val="115000"/>
-              </a:lnSpc>
-              <a:spcBef>
-                <a:spcPts val="200"/>
-              </a:spcBef>
-              <a:spcAft>
-                <a:spcPts val="400"/>
-              </a:spcAft>
-              <a:defRPr sz="950"/>
-            </a:pPr>
-            <a:r>
-              <a:rPr b="1">
-                <a:solidFill>
-                  <a:srgbClr val="FF3F6C"/>
-                </a:solidFill>
-              </a:rPr>
-              <a:t>► </a:t>
-            </a:r>
-            <a:r>
-              <a:rPr b="1">
-                <a:solidFill>
-                  <a:srgbClr val="282C3F"/>
-                </a:solidFill>
-              </a:rPr>
-              <a:t>2. Category Browse: </a:t>
-            </a:r>
-            <a:r>
-              <a:rPr>
-                <a:solidFill>
-                  <a:srgbClr val="282C3F"/>
-                </a:solidFill>
-              </a:rPr>
-              <a:t>Leaves items in wishlist without buying</a:t>
-            </a:r>
-          </a:p>
-          <a:p>
-            <a:pPr marL="203200" indent="-152400">
-              <a:lnSpc>
-                <a:spcPct val="115000"/>
-              </a:lnSpc>
-              <a:spcBef>
-                <a:spcPts val="200"/>
-              </a:spcBef>
-              <a:spcAft>
-                <a:spcPts val="400"/>
-              </a:spcAft>
-              <a:defRPr sz="950"/>
-            </a:pPr>
-            <a:r>
-              <a:rPr b="1">
-                <a:solidFill>
-                  <a:srgbClr val="FF3F6C"/>
-                </a:solidFill>
-              </a:rPr>
-              <a:t>► </a:t>
-            </a:r>
-            <a:r>
-              <a:rPr b="1">
-                <a:solidFill>
-                  <a:srgbClr val="282C3F"/>
-                </a:solidFill>
-              </a:rPr>
-              <a:t>3. Wishlist Graveyard: </a:t>
-            </a:r>
-            <a:r>
-              <a:rPr>
-                <a:solidFill>
-                  <a:srgbClr val="282C3F"/>
-                </a:solidFill>
-              </a:rPr>
-              <a:t>Stalls due to fabric GSM &amp; fit ambiguity</a:t>
-            </a:r>
-          </a:p>
-          <a:p>
-            <a:pPr marL="203200" indent="-152400">
-              <a:lnSpc>
-                <a:spcPct val="115000"/>
-              </a:lnSpc>
-              <a:spcBef>
-                <a:spcPts val="200"/>
-              </a:spcBef>
-              <a:spcAft>
-                <a:spcPts val="400"/>
-              </a:spcAft>
-              <a:defRPr sz="950"/>
-            </a:pPr>
-            <a:r>
-              <a:rPr b="1">
-                <a:solidFill>
-                  <a:srgbClr val="FF3F6C"/>
-                </a:solidFill>
-              </a:rPr>
-              <a:t>► </a:t>
-            </a:r>
-            <a:r>
-              <a:rPr b="1">
-                <a:solidFill>
-                  <a:srgbClr val="282C3F"/>
-                </a:solidFill>
-              </a:rPr>
-              <a:t>4. Abandonment: </a:t>
-            </a:r>
-            <a:r>
-              <a:rPr>
-                <a:solidFill>
-                  <a:srgbClr val="282C3F"/>
-                </a:solidFill>
-              </a:rPr>
-              <a:t>Screenshots to WhatsApp; 68% drop-off</a:t>
             </a:r>
           </a:p>
         </p:txBody>
@@ -7133,8 +6978,8 @@
         </p:nvSpPr>
         <p:spPr>
           <a:xfrm>
-            <a:off x="6796735" y="1536192"/>
-            <a:ext cx="4754880" cy="1225296"/>
+            <a:off x="749808" y="3218688"/>
+            <a:ext cx="1353312" cy="2130552"/>
           </a:xfrm>
           <a:prstGeom prst="roundRect">
             <a:avLst/>
@@ -7178,6 +7023,398 @@
         </p:nvSpPr>
         <p:spPr>
           <a:xfrm>
+            <a:off x="786384" y="3255264"/>
+            <a:ext cx="1280160" cy="2039113"/>
+          </a:xfrm>
+          <a:prstGeom prst="rect">
+            <a:avLst/>
+          </a:prstGeom>
+          <a:noFill/>
+        </p:spPr>
+        <p:txBody>
+          <a:bodyPr wrap="square" lIns="18288" rIns="18288">
+            <a:spAutoFit/>
+          </a:bodyPr>
+          <a:lstStyle/>
+          <a:p>
+            <a:pPr>
+              <a:spcAft>
+                <a:spcPts val="200"/>
+              </a:spcAft>
+              <a:defRPr sz="850" b="1">
+                <a:solidFill>
+                  <a:srgbClr val="FF3F6C"/>
+                </a:solidFill>
+              </a:defRPr>
+            </a:pPr>
+            <a:r>
+              <a:t>1. Intent Trigger</a:t>
+            </a:r>
+          </a:p>
+          <a:p>
+            <a:pPr>
+              <a:lnSpc>
+                <a:spcPct val="110000"/>
+              </a:lnSpc>
+              <a:defRPr sz="750">
+                <a:solidFill>
+                  <a:srgbClr val="282C3F"/>
+                </a:solidFill>
+              </a:defRPr>
+            </a:pPr>
+            <a:r>
+              <a:t>Browses app &amp; saves 3-4 style alternatives</a:t>
+            </a:r>
+          </a:p>
+        </p:txBody>
+      </p:sp>
+      <p:sp>
+        <p:nvSpPr>
+          <p:cNvPr id="11" name="Rounded Rectangle 10"/>
+          <p:cNvSpPr/>
+          <p:nvPr/>
+        </p:nvSpPr>
+        <p:spPr>
+          <a:xfrm>
+            <a:off x="2212848" y="3218688"/>
+            <a:ext cx="1353312" cy="2130552"/>
+          </a:xfrm>
+          <a:prstGeom prst="roundRect">
+            <a:avLst/>
+          </a:prstGeom>
+          <a:solidFill>
+            <a:srgbClr val="FFF0F4"/>
+          </a:solidFill>
+          <a:ln w="12700">
+            <a:solidFill>
+              <a:srgbClr val="FFC2D1"/>
+            </a:solidFill>
+          </a:ln>
+        </p:spPr>
+        <p:style>
+          <a:lnRef idx="1">
+            <a:schemeClr val="accent1"/>
+          </a:lnRef>
+          <a:fillRef idx="3">
+            <a:schemeClr val="accent1"/>
+          </a:fillRef>
+          <a:effectRef idx="2">
+            <a:schemeClr val="accent1"/>
+          </a:effectRef>
+          <a:fontRef idx="minor">
+            <a:schemeClr val="lt1"/>
+          </a:fontRef>
+        </p:style>
+        <p:txBody>
+          <a:bodyPr rtlCol="0" anchor="ctr"/>
+          <a:lstStyle/>
+          <a:p>
+            <a:pPr algn="ctr"/>
+          </a:p>
+        </p:txBody>
+      </p:sp>
+      <p:sp>
+        <p:nvSpPr>
+          <p:cNvPr id="12" name="TextBox 11"/>
+          <p:cNvSpPr txBox="1"/>
+          <p:nvPr/>
+        </p:nvSpPr>
+        <p:spPr>
+          <a:xfrm>
+            <a:off x="2249424" y="3255264"/>
+            <a:ext cx="1280160" cy="2039113"/>
+          </a:xfrm>
+          <a:prstGeom prst="rect">
+            <a:avLst/>
+          </a:prstGeom>
+          <a:noFill/>
+        </p:spPr>
+        <p:txBody>
+          <a:bodyPr wrap="square" lIns="18288" rIns="18288">
+            <a:spAutoFit/>
+          </a:bodyPr>
+          <a:lstStyle/>
+          <a:p>
+            <a:pPr>
+              <a:spcAft>
+                <a:spcPts val="200"/>
+              </a:spcAft>
+              <a:defRPr sz="850" b="1">
+                <a:solidFill>
+                  <a:srgbClr val="FF3F6C"/>
+                </a:solidFill>
+              </a:defRPr>
+            </a:pPr>
+            <a:r>
+              <a:t>2. Category Browse</a:t>
+            </a:r>
+          </a:p>
+          <a:p>
+            <a:pPr>
+              <a:lnSpc>
+                <a:spcPct val="110000"/>
+              </a:lnSpc>
+              <a:defRPr sz="750">
+                <a:solidFill>
+                  <a:srgbClr val="282C3F"/>
+                </a:solidFill>
+              </a:defRPr>
+            </a:pPr>
+            <a:r>
+              <a:t>Leaves items in wishlist without buying</a:t>
+            </a:r>
+          </a:p>
+        </p:txBody>
+      </p:sp>
+      <p:sp>
+        <p:nvSpPr>
+          <p:cNvPr id="13" name="Rounded Rectangle 12"/>
+          <p:cNvSpPr/>
+          <p:nvPr/>
+        </p:nvSpPr>
+        <p:spPr>
+          <a:xfrm>
+            <a:off x="3675888" y="3218688"/>
+            <a:ext cx="1353312" cy="2130552"/>
+          </a:xfrm>
+          <a:prstGeom prst="roundRect">
+            <a:avLst/>
+          </a:prstGeom>
+          <a:solidFill>
+            <a:srgbClr val="FFF0F4"/>
+          </a:solidFill>
+          <a:ln w="12700">
+            <a:solidFill>
+              <a:srgbClr val="FFC2D1"/>
+            </a:solidFill>
+          </a:ln>
+        </p:spPr>
+        <p:style>
+          <a:lnRef idx="1">
+            <a:schemeClr val="accent1"/>
+          </a:lnRef>
+          <a:fillRef idx="3">
+            <a:schemeClr val="accent1"/>
+          </a:fillRef>
+          <a:effectRef idx="2">
+            <a:schemeClr val="accent1"/>
+          </a:effectRef>
+          <a:fontRef idx="minor">
+            <a:schemeClr val="lt1"/>
+          </a:fontRef>
+        </p:style>
+        <p:txBody>
+          <a:bodyPr rtlCol="0" anchor="ctr"/>
+          <a:lstStyle/>
+          <a:p>
+            <a:pPr algn="ctr"/>
+          </a:p>
+        </p:txBody>
+      </p:sp>
+      <p:sp>
+        <p:nvSpPr>
+          <p:cNvPr id="14" name="TextBox 13"/>
+          <p:cNvSpPr txBox="1"/>
+          <p:nvPr/>
+        </p:nvSpPr>
+        <p:spPr>
+          <a:xfrm>
+            <a:off x="3712464" y="3255264"/>
+            <a:ext cx="1280160" cy="2039113"/>
+          </a:xfrm>
+          <a:prstGeom prst="rect">
+            <a:avLst/>
+          </a:prstGeom>
+          <a:noFill/>
+        </p:spPr>
+        <p:txBody>
+          <a:bodyPr wrap="square" lIns="18288" rIns="18288">
+            <a:spAutoFit/>
+          </a:bodyPr>
+          <a:lstStyle/>
+          <a:p>
+            <a:pPr>
+              <a:spcAft>
+                <a:spcPts val="200"/>
+              </a:spcAft>
+              <a:defRPr sz="850" b="1">
+                <a:solidFill>
+                  <a:srgbClr val="FF3F6C"/>
+                </a:solidFill>
+              </a:defRPr>
+            </a:pPr>
+            <a:r>
+              <a:t>3. Wishlist Graveyard</a:t>
+            </a:r>
+          </a:p>
+          <a:p>
+            <a:pPr>
+              <a:lnSpc>
+                <a:spcPct val="110000"/>
+              </a:lnSpc>
+              <a:defRPr sz="750">
+                <a:solidFill>
+                  <a:srgbClr val="282C3F"/>
+                </a:solidFill>
+              </a:defRPr>
+            </a:pPr>
+            <a:r>
+              <a:t>Stalls due to fabric GSM &amp; fit ambiguity</a:t>
+            </a:r>
+          </a:p>
+        </p:txBody>
+      </p:sp>
+      <p:sp>
+        <p:nvSpPr>
+          <p:cNvPr id="15" name="Rounded Rectangle 14"/>
+          <p:cNvSpPr/>
+          <p:nvPr/>
+        </p:nvSpPr>
+        <p:spPr>
+          <a:xfrm>
+            <a:off x="5138928" y="3218688"/>
+            <a:ext cx="1353312" cy="2130552"/>
+          </a:xfrm>
+          <a:prstGeom prst="roundRect">
+            <a:avLst/>
+          </a:prstGeom>
+          <a:solidFill>
+            <a:srgbClr val="FFF0F4"/>
+          </a:solidFill>
+          <a:ln w="12700">
+            <a:solidFill>
+              <a:srgbClr val="FFC2D1"/>
+            </a:solidFill>
+          </a:ln>
+        </p:spPr>
+        <p:style>
+          <a:lnRef idx="1">
+            <a:schemeClr val="accent1"/>
+          </a:lnRef>
+          <a:fillRef idx="3">
+            <a:schemeClr val="accent1"/>
+          </a:fillRef>
+          <a:effectRef idx="2">
+            <a:schemeClr val="accent1"/>
+          </a:effectRef>
+          <a:fontRef idx="minor">
+            <a:schemeClr val="lt1"/>
+          </a:fontRef>
+        </p:style>
+        <p:txBody>
+          <a:bodyPr rtlCol="0" anchor="ctr"/>
+          <a:lstStyle/>
+          <a:p>
+            <a:pPr algn="ctr"/>
+          </a:p>
+        </p:txBody>
+      </p:sp>
+      <p:sp>
+        <p:nvSpPr>
+          <p:cNvPr id="16" name="TextBox 15"/>
+          <p:cNvSpPr txBox="1"/>
+          <p:nvPr/>
+        </p:nvSpPr>
+        <p:spPr>
+          <a:xfrm>
+            <a:off x="5175504" y="3255264"/>
+            <a:ext cx="1280160" cy="2039113"/>
+          </a:xfrm>
+          <a:prstGeom prst="rect">
+            <a:avLst/>
+          </a:prstGeom>
+          <a:noFill/>
+        </p:spPr>
+        <p:txBody>
+          <a:bodyPr wrap="square" lIns="18288" rIns="18288">
+            <a:spAutoFit/>
+          </a:bodyPr>
+          <a:lstStyle/>
+          <a:p>
+            <a:pPr>
+              <a:spcAft>
+                <a:spcPts val="200"/>
+              </a:spcAft>
+              <a:defRPr sz="850" b="1">
+                <a:solidFill>
+                  <a:srgbClr val="FF3F6C"/>
+                </a:solidFill>
+              </a:defRPr>
+            </a:pPr>
+            <a:r>
+              <a:t>4. Abandonment</a:t>
+            </a:r>
+          </a:p>
+          <a:p>
+            <a:pPr>
+              <a:lnSpc>
+                <a:spcPct val="110000"/>
+              </a:lnSpc>
+              <a:defRPr sz="750">
+                <a:solidFill>
+                  <a:srgbClr val="282C3F"/>
+                </a:solidFill>
+              </a:defRPr>
+            </a:pPr>
+            <a:r>
+              <a:t>Screenshots to WhatsApp; 68% drop-off</a:t>
+            </a:r>
+          </a:p>
+        </p:txBody>
+      </p:sp>
+      <p:sp>
+        <p:nvSpPr>
+          <p:cNvPr id="17" name="Rounded Rectangle 16"/>
+          <p:cNvSpPr/>
+          <p:nvPr/>
+        </p:nvSpPr>
+        <p:spPr>
+          <a:xfrm>
+            <a:off x="6796735" y="1536192"/>
+            <a:ext cx="4754880" cy="1225296"/>
+          </a:xfrm>
+          <a:prstGeom prst="roundRect">
+            <a:avLst/>
+          </a:prstGeom>
+          <a:solidFill>
+            <a:srgbClr val="FFF0F4"/>
+          </a:solidFill>
+          <a:ln w="12700">
+            <a:solidFill>
+              <a:srgbClr val="FFC2D1"/>
+            </a:solidFill>
+          </a:ln>
+        </p:spPr>
+        <p:style>
+          <a:lnRef idx="1">
+            <a:schemeClr val="accent1"/>
+          </a:lnRef>
+          <a:fillRef idx="3">
+            <a:schemeClr val="accent1"/>
+          </a:fillRef>
+          <a:effectRef idx="2">
+            <a:schemeClr val="accent1"/>
+          </a:effectRef>
+          <a:fontRef idx="minor">
+            <a:schemeClr val="lt1"/>
+          </a:fontRef>
+        </p:style>
+        <p:txBody>
+          <a:bodyPr rtlCol="0" anchor="ctr"/>
+          <a:lstStyle/>
+          <a:p>
+            <a:pPr algn="ctr"/>
+          </a:p>
+        </p:txBody>
+      </p:sp>
+      <p:sp>
+        <p:nvSpPr>
+          <p:cNvPr id="18" name="TextBox 17"/>
+          <p:cNvSpPr txBox="1"/>
+          <p:nvPr/>
+        </p:nvSpPr>
+        <p:spPr>
+          <a:xfrm>
             <a:off x="6903720" y="1609344"/>
             <a:ext cx="4535424" cy="1078992"/>
           </a:xfrm>
@@ -7225,7 +7462,7 @@
       </p:sp>
       <p:sp>
         <p:nvSpPr>
-          <p:cNvPr id="11" name="Rounded Rectangle 10"/>
+          <p:cNvPr id="19" name="Rounded Rectangle 18"/>
           <p:cNvSpPr/>
           <p:nvPr/>
         </p:nvSpPr>
@@ -7270,7 +7507,7 @@
       </p:sp>
       <p:sp>
         <p:nvSpPr>
-          <p:cNvPr id="12" name="TextBox 11"/>
+          <p:cNvPr id="20" name="TextBox 19"/>
           <p:cNvSpPr txBox="1"/>
           <p:nvPr/>
         </p:nvSpPr>
@@ -7323,7 +7560,7 @@
       </p:sp>
       <p:sp>
         <p:nvSpPr>
-          <p:cNvPr id="13" name="Rounded Rectangle 12"/>
+          <p:cNvPr id="21" name="Rounded Rectangle 20"/>
           <p:cNvSpPr/>
           <p:nvPr/>
         </p:nvSpPr>
@@ -7368,7 +7605,7 @@
       </p:sp>
       <p:sp>
         <p:nvSpPr>
-          <p:cNvPr id="14" name="TextBox 13"/>
+          <p:cNvPr id="22" name="TextBox 21"/>
           <p:cNvSpPr txBox="1"/>
           <p:nvPr/>
         </p:nvSpPr>
@@ -7421,7 +7658,7 @@
       </p:sp>
       <p:sp>
         <p:nvSpPr>
-          <p:cNvPr id="15" name="Rounded Rectangle 14"/>
+          <p:cNvPr id="23" name="Rounded Rectangle 22"/>
           <p:cNvSpPr/>
           <p:nvPr/>
         </p:nvSpPr>
@@ -7466,7 +7703,7 @@
       </p:sp>
       <p:sp>
         <p:nvSpPr>
-          <p:cNvPr id="16" name="TextBox 15"/>
+          <p:cNvPr id="24" name="TextBox 23"/>
           <p:cNvSpPr txBox="1"/>
           <p:nvPr/>
         </p:nvSpPr>
@@ -7522,7 +7759,7 @@
       </p:sp>
       <p:sp>
         <p:nvSpPr>
-          <p:cNvPr id="17" name="Rounded Rectangle 16"/>
+          <p:cNvPr id="25" name="Rounded Rectangle 24"/>
           <p:cNvSpPr/>
           <p:nvPr/>
         </p:nvSpPr>
@@ -7582,7 +7819,7 @@
       </p:sp>
       <p:sp>
         <p:nvSpPr>
-          <p:cNvPr id="18" name="Rounded Rectangle 17"/>
+          <p:cNvPr id="26" name="Rounded Rectangle 25"/>
           <p:cNvSpPr/>
           <p:nvPr/>
         </p:nvSpPr>
@@ -7642,7 +7879,7 @@
       </p:sp>
       <p:sp>
         <p:nvSpPr>
-          <p:cNvPr id="19" name="Rounded Rectangle 18"/>
+          <p:cNvPr id="27" name="Rounded Rectangle 26"/>
           <p:cNvSpPr/>
           <p:nvPr/>
         </p:nvSpPr>
@@ -7702,7 +7939,7 @@
       </p:sp>
       <p:sp>
         <p:nvSpPr>
-          <p:cNvPr id="20" name="Rounded Rectangle 19"/>
+          <p:cNvPr id="28" name="Rounded Rectangle 27"/>
           <p:cNvSpPr/>
           <p:nvPr/>
         </p:nvSpPr>
@@ -7762,7 +7999,7 @@
       </p:sp>
       <p:sp>
         <p:nvSpPr>
-          <p:cNvPr id="21" name="Rounded Rectangle 20"/>
+          <p:cNvPr id="29" name="Rounded Rectangle 28"/>
           <p:cNvSpPr/>
           <p:nvPr/>
         </p:nvSpPr>
@@ -7822,7 +8059,7 @@
       </p:sp>
       <p:sp>
         <p:nvSpPr>
-          <p:cNvPr id="22" name="Rounded Rectangle 21"/>
+          <p:cNvPr id="30" name="Rounded Rectangle 29"/>
           <p:cNvSpPr/>
           <p:nvPr/>
         </p:nvSpPr>
@@ -7882,7 +8119,7 @@
       </p:sp>
       <p:sp>
         <p:nvSpPr>
-          <p:cNvPr id="23" name="Rounded Rectangle 22"/>
+          <p:cNvPr id="31" name="Rounded Rectangle 30"/>
           <p:cNvSpPr/>
           <p:nvPr/>
         </p:nvSpPr>
@@ -7942,7 +8179,7 @@
       </p:sp>
       <p:sp>
         <p:nvSpPr>
-          <p:cNvPr id="24" name="Rounded Rectangle 23"/>
+          <p:cNvPr id="32" name="Rounded Rectangle 31"/>
           <p:cNvSpPr/>
           <p:nvPr/>
         </p:nvSpPr>
@@ -8002,7 +8239,7 @@
       </p:sp>
       <p:sp>
         <p:nvSpPr>
-          <p:cNvPr id="25" name="Rounded Rectangle 24"/>
+          <p:cNvPr id="33" name="Rounded Rectangle 32"/>
           <p:cNvSpPr/>
           <p:nvPr/>
         </p:nvSpPr>
@@ -8062,7 +8299,7 @@
       </p:sp>
       <p:sp>
         <p:nvSpPr>
-          <p:cNvPr id="26" name="Rounded Rectangle 25"/>
+          <p:cNvPr id="34" name="Rounded Rectangle 33"/>
           <p:cNvSpPr/>
           <p:nvPr/>
         </p:nvSpPr>
@@ -8502,7 +8739,7 @@
         <p:spPr>
           <a:xfrm>
             <a:off x="7040880" y="1536192"/>
-            <a:ext cx="4510735" cy="1737360"/>
+            <a:ext cx="4510735" cy="1828800"/>
           </a:xfrm>
           <a:prstGeom prst="roundRect">
             <a:avLst/>
@@ -8546,8 +8783,8 @@
         </p:nvSpPr>
         <p:spPr>
           <a:xfrm>
-            <a:off x="7150608" y="1609344"/>
-            <a:ext cx="4288536" cy="1591056"/>
+            <a:off x="7150608" y="1591056"/>
+            <a:ext cx="4288536" cy="320040"/>
           </a:xfrm>
           <a:prstGeom prst="rect">
             <a:avLst/>
@@ -8555,15 +8792,12 @@
           <a:noFill/>
         </p:spPr>
         <p:txBody>
-          <a:bodyPr wrap="square" lIns="73152" rIns="73152">
+          <a:bodyPr wrap="square">
             <a:spAutoFit/>
           </a:bodyPr>
           <a:lstStyle/>
           <a:p>
             <a:pPr>
-              <a:spcAft>
-                <a:spcPts val="400"/>
-              </a:spcAft>
               <a:defRPr sz="1050" b="1">
                 <a:solidFill>
                   <a:srgbClr val="FF3F6C"/>
@@ -8572,96 +8806,6 @@
             </a:pPr>
             <a:r>
               <a:t>🔬 CORPUS FUNNEL &amp; NLP PIPELINE</a:t>
-            </a:r>
-          </a:p>
-          <a:p>
-            <a:pPr marL="177800" indent="-127000">
-              <a:lnSpc>
-                <a:spcPct val="115000"/>
-              </a:lnSpc>
-              <a:spcBef>
-                <a:spcPts val="200"/>
-              </a:spcBef>
-              <a:spcAft>
-                <a:spcPts val="300"/>
-              </a:spcAft>
-              <a:defRPr sz="950"/>
-            </a:pPr>
-            <a:r>
-              <a:rPr b="1">
-                <a:solidFill>
-                  <a:srgbClr val="282C3F"/>
-                </a:solidFill>
-              </a:rPr>
-              <a:t>• 1. Scrape &amp; Clean: </a:t>
-            </a:r>
-            <a:r>
-              <a:rPr>
-                <a:solidFill>
-                  <a:srgbClr val="282C3F"/>
-                </a:solidFill>
-              </a:rPr>
-              <a:t>20,250 Raw Reviews</a:t>
-            </a:r>
-          </a:p>
-          <a:p>
-            <a:pPr marL="177800" indent="-127000">
-              <a:lnSpc>
-                <a:spcPct val="115000"/>
-              </a:lnSpc>
-              <a:spcBef>
-                <a:spcPts val="200"/>
-              </a:spcBef>
-              <a:spcAft>
-                <a:spcPts val="300"/>
-              </a:spcAft>
-              <a:defRPr sz="950"/>
-            </a:pPr>
-            <a:r>
-              <a:rPr b="1">
-                <a:solidFill>
-                  <a:srgbClr val="282C3F"/>
-                </a:solidFill>
-              </a:rPr>
-              <a:t>• 2. Vectorize: </a:t>
-            </a:r>
-            <a:r>
-              <a:rPr>
-                <a:solidFill>
-                  <a:srgbClr val="282C3F"/>
-                </a:solidFill>
-              </a:rPr>
-              <a:t>Sentence-BERT Embeddings</a:t>
-            </a:r>
-          </a:p>
-          <a:p>
-            <a:pPr marL="177800" indent="-127000">
-              <a:lnSpc>
-                <a:spcPct val="115000"/>
-              </a:lnSpc>
-              <a:spcBef>
-                <a:spcPts val="200"/>
-              </a:spcBef>
-              <a:spcAft>
-                <a:spcPts val="300"/>
-              </a:spcAft>
-              <a:defRPr sz="950"/>
-            </a:pPr>
-            <a:r>
-              <a:rPr b="1">
-                <a:solidFill>
-                  <a:srgbClr val="282C3F"/>
-                </a:solidFill>
-              </a:rPr>
-              <a:t>• 3. Synthesis: </a:t>
-            </a:r>
-            <a:r>
-              <a:rPr>
-                <a:solidFill>
-                  <a:srgbClr val="282C3F"/>
-                </a:solidFill>
-              </a:rPr>
-              <a:t>LLM Intent Extraction</a:t>
             </a:r>
           </a:p>
         </p:txBody>
@@ -8674,8 +8818,8 @@
         </p:nvSpPr>
         <p:spPr>
           <a:xfrm>
-            <a:off x="7040880" y="3410711"/>
-            <a:ext cx="4510735" cy="2039113"/>
+            <a:off x="7150608" y="1920240"/>
+            <a:ext cx="1335024" cy="1325880"/>
           </a:xfrm>
           <a:prstGeom prst="roundRect">
             <a:avLst/>
@@ -8719,8 +8863,302 @@
         </p:nvSpPr>
         <p:spPr>
           <a:xfrm>
-            <a:off x="7150608" y="3483863"/>
-            <a:ext cx="4288536" cy="1892808"/>
+            <a:off x="7187184" y="1956816"/>
+            <a:ext cx="1261872" cy="1234440"/>
+          </a:xfrm>
+          <a:prstGeom prst="rect">
+            <a:avLst/>
+          </a:prstGeom>
+          <a:noFill/>
+        </p:spPr>
+        <p:txBody>
+          <a:bodyPr wrap="square" lIns="18288" rIns="18288">
+            <a:spAutoFit/>
+          </a:bodyPr>
+          <a:lstStyle/>
+          <a:p>
+            <a:pPr>
+              <a:spcAft>
+                <a:spcPts val="200"/>
+              </a:spcAft>
+              <a:defRPr sz="850" b="1">
+                <a:solidFill>
+                  <a:srgbClr val="FF3F6C"/>
+                </a:solidFill>
+              </a:defRPr>
+            </a:pPr>
+            <a:r>
+              <a:t>1. Scrape &amp; Clean</a:t>
+            </a:r>
+          </a:p>
+          <a:p>
+            <a:pPr>
+              <a:lnSpc>
+                <a:spcPct val="110000"/>
+              </a:lnSpc>
+              <a:defRPr sz="750">
+                <a:solidFill>
+                  <a:srgbClr val="282C3F"/>
+                </a:solidFill>
+              </a:defRPr>
+            </a:pPr>
+            <a:r>
+              <a:t>20,250 Raw Reviews</a:t>
+            </a:r>
+          </a:p>
+        </p:txBody>
+      </p:sp>
+      <p:sp>
+        <p:nvSpPr>
+          <p:cNvPr id="11" name="Rounded Rectangle 10"/>
+          <p:cNvSpPr/>
+          <p:nvPr/>
+        </p:nvSpPr>
+        <p:spPr>
+          <a:xfrm>
+            <a:off x="8595360" y="1920240"/>
+            <a:ext cx="1335024" cy="1325880"/>
+          </a:xfrm>
+          <a:prstGeom prst="roundRect">
+            <a:avLst/>
+          </a:prstGeom>
+          <a:solidFill>
+            <a:srgbClr val="FFFFFF"/>
+          </a:solidFill>
+          <a:ln w="12700">
+            <a:solidFill>
+              <a:srgbClr val="EAEAEC"/>
+            </a:solidFill>
+          </a:ln>
+        </p:spPr>
+        <p:style>
+          <a:lnRef idx="1">
+            <a:schemeClr val="accent1"/>
+          </a:lnRef>
+          <a:fillRef idx="3">
+            <a:schemeClr val="accent1"/>
+          </a:fillRef>
+          <a:effectRef idx="2">
+            <a:schemeClr val="accent1"/>
+          </a:effectRef>
+          <a:fontRef idx="minor">
+            <a:schemeClr val="lt1"/>
+          </a:fontRef>
+        </p:style>
+        <p:txBody>
+          <a:bodyPr rtlCol="0" anchor="ctr"/>
+          <a:lstStyle/>
+          <a:p>
+            <a:pPr algn="ctr"/>
+          </a:p>
+        </p:txBody>
+      </p:sp>
+      <p:sp>
+        <p:nvSpPr>
+          <p:cNvPr id="12" name="TextBox 11"/>
+          <p:cNvSpPr txBox="1"/>
+          <p:nvPr/>
+        </p:nvSpPr>
+        <p:spPr>
+          <a:xfrm>
+            <a:off x="8631936" y="1956816"/>
+            <a:ext cx="1261872" cy="1234440"/>
+          </a:xfrm>
+          <a:prstGeom prst="rect">
+            <a:avLst/>
+          </a:prstGeom>
+          <a:noFill/>
+        </p:spPr>
+        <p:txBody>
+          <a:bodyPr wrap="square" lIns="18288" rIns="18288">
+            <a:spAutoFit/>
+          </a:bodyPr>
+          <a:lstStyle/>
+          <a:p>
+            <a:pPr>
+              <a:spcAft>
+                <a:spcPts val="200"/>
+              </a:spcAft>
+              <a:defRPr sz="850" b="1">
+                <a:solidFill>
+                  <a:srgbClr val="FF3F6C"/>
+                </a:solidFill>
+              </a:defRPr>
+            </a:pPr>
+            <a:r>
+              <a:t>2. Vectorize</a:t>
+            </a:r>
+          </a:p>
+          <a:p>
+            <a:pPr>
+              <a:lnSpc>
+                <a:spcPct val="110000"/>
+              </a:lnSpc>
+              <a:defRPr sz="750">
+                <a:solidFill>
+                  <a:srgbClr val="282C3F"/>
+                </a:solidFill>
+              </a:defRPr>
+            </a:pPr>
+            <a:r>
+              <a:t>Sentence-BERT Embeddings</a:t>
+            </a:r>
+          </a:p>
+        </p:txBody>
+      </p:sp>
+      <p:sp>
+        <p:nvSpPr>
+          <p:cNvPr id="13" name="Rounded Rectangle 12"/>
+          <p:cNvSpPr/>
+          <p:nvPr/>
+        </p:nvSpPr>
+        <p:spPr>
+          <a:xfrm>
+            <a:off x="10040112" y="1920240"/>
+            <a:ext cx="1335024" cy="1325880"/>
+          </a:xfrm>
+          <a:prstGeom prst="roundRect">
+            <a:avLst/>
+          </a:prstGeom>
+          <a:solidFill>
+            <a:srgbClr val="FFFFFF"/>
+          </a:solidFill>
+          <a:ln w="12700">
+            <a:solidFill>
+              <a:srgbClr val="EAEAEC"/>
+            </a:solidFill>
+          </a:ln>
+        </p:spPr>
+        <p:style>
+          <a:lnRef idx="1">
+            <a:schemeClr val="accent1"/>
+          </a:lnRef>
+          <a:fillRef idx="3">
+            <a:schemeClr val="accent1"/>
+          </a:fillRef>
+          <a:effectRef idx="2">
+            <a:schemeClr val="accent1"/>
+          </a:effectRef>
+          <a:fontRef idx="minor">
+            <a:schemeClr val="lt1"/>
+          </a:fontRef>
+        </p:style>
+        <p:txBody>
+          <a:bodyPr rtlCol="0" anchor="ctr"/>
+          <a:lstStyle/>
+          <a:p>
+            <a:pPr algn="ctr"/>
+          </a:p>
+        </p:txBody>
+      </p:sp>
+      <p:sp>
+        <p:nvSpPr>
+          <p:cNvPr id="14" name="TextBox 13"/>
+          <p:cNvSpPr txBox="1"/>
+          <p:nvPr/>
+        </p:nvSpPr>
+        <p:spPr>
+          <a:xfrm>
+            <a:off x="10076688" y="1956816"/>
+            <a:ext cx="1261872" cy="1234440"/>
+          </a:xfrm>
+          <a:prstGeom prst="rect">
+            <a:avLst/>
+          </a:prstGeom>
+          <a:noFill/>
+        </p:spPr>
+        <p:txBody>
+          <a:bodyPr wrap="square" lIns="18288" rIns="18288">
+            <a:spAutoFit/>
+          </a:bodyPr>
+          <a:lstStyle/>
+          <a:p>
+            <a:pPr>
+              <a:spcAft>
+                <a:spcPts val="200"/>
+              </a:spcAft>
+              <a:defRPr sz="850" b="1">
+                <a:solidFill>
+                  <a:srgbClr val="FF3F6C"/>
+                </a:solidFill>
+              </a:defRPr>
+            </a:pPr>
+            <a:r>
+              <a:t>3. Synthesis</a:t>
+            </a:r>
+          </a:p>
+          <a:p>
+            <a:pPr>
+              <a:lnSpc>
+                <a:spcPct val="110000"/>
+              </a:lnSpc>
+              <a:defRPr sz="750">
+                <a:solidFill>
+                  <a:srgbClr val="282C3F"/>
+                </a:solidFill>
+              </a:defRPr>
+            </a:pPr>
+            <a:r>
+              <a:t>LLM Intent Extraction</a:t>
+            </a:r>
+          </a:p>
+        </p:txBody>
+      </p:sp>
+      <p:sp>
+        <p:nvSpPr>
+          <p:cNvPr id="15" name="Rounded Rectangle 14"/>
+          <p:cNvSpPr/>
+          <p:nvPr/>
+        </p:nvSpPr>
+        <p:spPr>
+          <a:xfrm>
+            <a:off x="7040880" y="3502152"/>
+            <a:ext cx="4510735" cy="1947672"/>
+          </a:xfrm>
+          <a:prstGeom prst="roundRect">
+            <a:avLst/>
+          </a:prstGeom>
+          <a:solidFill>
+            <a:srgbClr val="FFFFFF"/>
+          </a:solidFill>
+          <a:ln w="12700">
+            <a:solidFill>
+              <a:srgbClr val="EAEAEC"/>
+            </a:solidFill>
+          </a:ln>
+        </p:spPr>
+        <p:style>
+          <a:lnRef idx="1">
+            <a:schemeClr val="accent1"/>
+          </a:lnRef>
+          <a:fillRef idx="3">
+            <a:schemeClr val="accent1"/>
+          </a:fillRef>
+          <a:effectRef idx="2">
+            <a:schemeClr val="accent1"/>
+          </a:effectRef>
+          <a:fontRef idx="minor">
+            <a:schemeClr val="lt1"/>
+          </a:fontRef>
+        </p:style>
+        <p:txBody>
+          <a:bodyPr rtlCol="0" anchor="ctr"/>
+          <a:lstStyle/>
+          <a:p>
+            <a:pPr algn="ctr"/>
+          </a:p>
+        </p:txBody>
+      </p:sp>
+      <p:sp>
+        <p:nvSpPr>
+          <p:cNvPr id="16" name="TextBox 15"/>
+          <p:cNvSpPr txBox="1"/>
+          <p:nvPr/>
+        </p:nvSpPr>
+        <p:spPr>
+          <a:xfrm>
+            <a:off x="7150608" y="3575304"/>
+            <a:ext cx="4288536" cy="1801368"/>
           </a:xfrm>
           <a:prstGeom prst="rect">
             <a:avLst/>
@@ -8841,7 +9279,7 @@
       </p:sp>
       <p:sp>
         <p:nvSpPr>
-          <p:cNvPr id="11" name="Rounded Rectangle 10"/>
+          <p:cNvPr id="17" name="Rounded Rectangle 16"/>
           <p:cNvSpPr/>
           <p:nvPr/>
         </p:nvSpPr>
@@ -8886,7 +9324,7 @@
       </p:sp>
       <p:sp>
         <p:nvSpPr>
-          <p:cNvPr id="12" name="TextBox 11"/>
+          <p:cNvPr id="18" name="TextBox 17"/>
           <p:cNvSpPr txBox="1"/>
           <p:nvPr/>
         </p:nvSpPr>
@@ -8942,7 +9380,7 @@
       </p:sp>
       <p:sp>
         <p:nvSpPr>
-          <p:cNvPr id="13" name="Rounded Rectangle 12"/>
+          <p:cNvPr id="19" name="Rounded Rectangle 18"/>
           <p:cNvSpPr/>
           <p:nvPr/>
         </p:nvSpPr>
@@ -9002,7 +9440,7 @@
       </p:sp>
       <p:sp>
         <p:nvSpPr>
-          <p:cNvPr id="14" name="Rounded Rectangle 13"/>
+          <p:cNvPr id="20" name="Rounded Rectangle 19"/>
           <p:cNvSpPr/>
           <p:nvPr/>
         </p:nvSpPr>
@@ -9062,7 +9500,7 @@
       </p:sp>
       <p:sp>
         <p:nvSpPr>
-          <p:cNvPr id="15" name="Rounded Rectangle 14"/>
+          <p:cNvPr id="21" name="Rounded Rectangle 20"/>
           <p:cNvSpPr/>
           <p:nvPr/>
         </p:nvSpPr>
@@ -9122,7 +9560,7 @@
       </p:sp>
       <p:sp>
         <p:nvSpPr>
-          <p:cNvPr id="16" name="Rounded Rectangle 15"/>
+          <p:cNvPr id="22" name="Rounded Rectangle 21"/>
           <p:cNvSpPr/>
           <p:nvPr/>
         </p:nvSpPr>
@@ -9182,7 +9620,7 @@
       </p:sp>
       <p:sp>
         <p:nvSpPr>
-          <p:cNvPr id="17" name="Rounded Rectangle 16"/>
+          <p:cNvPr id="23" name="Rounded Rectangle 22"/>
           <p:cNvSpPr/>
           <p:nvPr/>
         </p:nvSpPr>
@@ -9242,7 +9680,7 @@
       </p:sp>
       <p:sp>
         <p:nvSpPr>
-          <p:cNvPr id="18" name="Rounded Rectangle 17"/>
+          <p:cNvPr id="24" name="Rounded Rectangle 23"/>
           <p:cNvSpPr/>
           <p:nvPr/>
         </p:nvSpPr>
@@ -9302,7 +9740,7 @@
       </p:sp>
       <p:sp>
         <p:nvSpPr>
-          <p:cNvPr id="19" name="Rounded Rectangle 18"/>
+          <p:cNvPr id="25" name="Rounded Rectangle 24"/>
           <p:cNvSpPr/>
           <p:nvPr/>
         </p:nvSpPr>
@@ -9362,7 +9800,7 @@
       </p:sp>
       <p:sp>
         <p:nvSpPr>
-          <p:cNvPr id="20" name="Rounded Rectangle 19"/>
+          <p:cNvPr id="26" name="Rounded Rectangle 25"/>
           <p:cNvSpPr/>
           <p:nvPr/>
         </p:nvSpPr>
@@ -9422,7 +9860,7 @@
       </p:sp>
       <p:sp>
         <p:nvSpPr>
-          <p:cNvPr id="21" name="Rounded Rectangle 20"/>
+          <p:cNvPr id="27" name="Rounded Rectangle 26"/>
           <p:cNvSpPr/>
           <p:nvPr/>
         </p:nvSpPr>
@@ -9482,7 +9920,7 @@
       </p:sp>
       <p:sp>
         <p:nvSpPr>
-          <p:cNvPr id="22" name="Rounded Rectangle 21"/>
+          <p:cNvPr id="28" name="Rounded Rectangle 27"/>
           <p:cNvSpPr/>
           <p:nvPr/>
         </p:nvSpPr>
@@ -15377,14 +15815,49 @@
       </p:sp>
       <p:sp>
         <p:nvSpPr>
-          <p:cNvPr id="5" name="Rounded Rectangle 4"/>
+          <p:cNvPr id="5" name="TextBox 4"/>
+          <p:cNvSpPr txBox="1"/>
+          <p:nvPr/>
+        </p:nvSpPr>
+        <p:spPr>
+          <a:xfrm>
+            <a:off x="640080" y="1499616"/>
+            <a:ext cx="10911535" cy="292608"/>
+          </a:xfrm>
+          <a:prstGeom prst="rect">
+            <a:avLst/>
+          </a:prstGeom>
+          <a:noFill/>
+        </p:spPr>
+        <p:txBody>
+          <a:bodyPr wrap="square">
+            <a:spAutoFit/>
+          </a:bodyPr>
+          <a:lstStyle/>
+          <a:p>
+            <a:pPr>
+              <a:defRPr sz="1050" b="1">
+                <a:solidFill>
+                  <a:srgbClr val="FF3F6C"/>
+                </a:solidFill>
+              </a:defRPr>
+            </a:pPr>
+            <a:r>
+              <a:t>⚙️ DECISION STUDIO ARCHITECTURE PIPELINE (4-STEP ML FLOW)</a:t>
+            </a:r>
+          </a:p>
+        </p:txBody>
+      </p:sp>
+      <p:sp>
+        <p:nvSpPr>
+          <p:cNvPr id="6" name="Rounded Rectangle 5"/>
           <p:cNvSpPr/>
           <p:nvPr/>
         </p:nvSpPr>
         <p:spPr>
           <a:xfrm>
-            <a:off x="640080" y="1536192"/>
-            <a:ext cx="10911535" cy="1097280"/>
+            <a:off x="640080" y="1828800"/>
+            <a:ext cx="2578608" cy="1078992"/>
           </a:xfrm>
           <a:prstGeom prst="roundRect">
             <a:avLst/>
@@ -15422,14 +15895,14 @@
       </p:sp>
       <p:sp>
         <p:nvSpPr>
-          <p:cNvPr id="6" name="TextBox 5"/>
+          <p:cNvPr id="7" name="TextBox 6"/>
           <p:cNvSpPr txBox="1"/>
           <p:nvPr/>
         </p:nvSpPr>
         <p:spPr>
           <a:xfrm>
-            <a:off x="749808" y="1591056"/>
-            <a:ext cx="10689336" cy="987552"/>
+            <a:off x="694944" y="1865376"/>
+            <a:ext cx="2468880" cy="1005840"/>
           </a:xfrm>
           <a:prstGeom prst="rect">
             <a:avLst/>
@@ -15437,7 +15910,7 @@
           <a:noFill/>
         </p:spPr>
         <p:txBody>
-          <a:bodyPr wrap="square" lIns="73152" rIns="73152">
+          <a:bodyPr wrap="square" lIns="18288" rIns="18288">
             <a:spAutoFit/>
           </a:bodyPr>
           <a:lstStyle/>
@@ -15446,148 +15919,43 @@
               <a:spcAft>
                 <a:spcPts val="200"/>
               </a:spcAft>
-              <a:defRPr sz="1050" b="1">
+              <a:defRPr sz="900" b="1">
                 <a:solidFill>
                   <a:srgbClr val="FF3F6C"/>
                 </a:solidFill>
               </a:defRPr>
             </a:pPr>
             <a:r>
-              <a:t>⚙️ DECISION STUDIO ARCHITECTURE PIPELINE</a:t>
-            </a:r>
-          </a:p>
-          <a:p>
-            <a:pPr marL="177800" indent="-127000">
+              <a:t>1. Event Trigger</a:t>
+            </a:r>
+          </a:p>
+          <a:p>
+            <a:pPr>
               <a:lnSpc>
-                <a:spcPct val="112000"/>
+                <a:spcPct val="110000"/>
               </a:lnSpc>
-              <a:spcBef>
-                <a:spcPts val="100"/>
-              </a:spcBef>
-              <a:spcAft>
-                <a:spcPts val="100"/>
-              </a:spcAft>
-              <a:defRPr sz="850"/>
-            </a:pPr>
-            <a:r>
-              <a:rPr b="1">
+              <a:defRPr sz="750">
                 <a:solidFill>
                   <a:srgbClr val="282C3F"/>
                 </a:solidFill>
-              </a:rPr>
-              <a:t>• 1. Event Trigger: </a:t>
-            </a:r>
-            <a:r>
-              <a:rPr>
-                <a:solidFill>
-                  <a:srgbClr val="282C3F"/>
-                </a:solidFill>
-              </a:rPr>
+              </a:defRPr>
+            </a:pPr>
+            <a:r>
               <a:t>Frontend fires payload on wishlist view containing saved product IDs, timestamp, and category.</a:t>
             </a:r>
           </a:p>
-          <a:p>
-            <a:pPr marL="177800" indent="-127000">
-              <a:lnSpc>
-                <a:spcPct val="112000"/>
-              </a:lnSpc>
-              <a:spcBef>
-                <a:spcPts val="100"/>
-              </a:spcBef>
-              <a:spcAft>
-                <a:spcPts val="100"/>
-              </a:spcAft>
-              <a:defRPr sz="850"/>
-            </a:pPr>
-            <a:r>
-              <a:rPr b="1">
-                <a:solidFill>
-                  <a:srgbClr val="282C3F"/>
-                </a:solidFill>
-              </a:rPr>
-              <a:t>• 2. Inference Engine: </a:t>
-            </a:r>
-            <a:r>
-              <a:rPr>
-                <a:solidFill>
-                  <a:srgbClr val="282C3F"/>
-                </a:solidFill>
-              </a:rPr>
-              <a:t>Review NLP normalizes fabric GSM weight, fit consensus %, and return friction score from 20k reviews.</a:t>
-            </a:r>
-          </a:p>
-          <a:p>
-            <a:pPr marL="177800" indent="-127000">
-              <a:lnSpc>
-                <a:spcPct val="112000"/>
-              </a:lnSpc>
-              <a:spcBef>
-                <a:spcPts val="100"/>
-              </a:spcBef>
-              <a:spcAft>
-                <a:spcPts val="100"/>
-              </a:spcAft>
-              <a:defRPr sz="850"/>
-            </a:pPr>
-            <a:r>
-              <a:rPr b="1">
-                <a:solidFill>
-                  <a:srgbClr val="282C3F"/>
-                </a:solidFill>
-              </a:rPr>
-              <a:t>• 3. Constrained Catalog: </a:t>
-            </a:r>
-            <a:r>
-              <a:rPr>
-                <a:solidFill>
-                  <a:srgbClr val="282C3F"/>
-                </a:solidFill>
-              </a:rPr>
-              <a:t>Maps item to pre-approved, high-margin styling catalog for complete 3-piece look builder.</a:t>
-            </a:r>
-          </a:p>
-          <a:p>
-            <a:pPr marL="177800" indent="-127000">
-              <a:lnSpc>
-                <a:spcPct val="112000"/>
-              </a:lnSpc>
-              <a:spcBef>
-                <a:spcPts val="100"/>
-              </a:spcBef>
-              <a:spcAft>
-                <a:spcPts val="100"/>
-              </a:spcAft>
-              <a:defRPr sz="850"/>
-            </a:pPr>
-            <a:r>
-              <a:rPr b="1">
-                <a:solidFill>
-                  <a:srgbClr val="282C3F"/>
-                </a:solidFill>
-              </a:rPr>
-              <a:t>• 4. Real-time UI Render: </a:t>
-            </a:r>
-            <a:r>
-              <a:rPr>
-                <a:solidFill>
-                  <a:srgbClr val="282C3F"/>
-                </a:solidFill>
-              </a:rPr>
-              <a:t>Returns clean JSON payload and renders interactive Spec Matrix and WhatsApp Poll card in &lt;180ms.</a:t>
-            </a:r>
-          </a:p>
-        </p:txBody>
-      </p:sp>
-      <p:sp>
-        <p:nvSpPr>
-          <p:cNvPr id="7" name="Rounded Rectangle 6"/>
+        </p:txBody>
+      </p:sp>
+      <p:sp>
+        <p:nvSpPr>
+          <p:cNvPr id="8" name="Rounded Rectangle 7"/>
           <p:cNvSpPr/>
           <p:nvPr/>
         </p:nvSpPr>
         <p:spPr>
           <a:xfrm>
-            <a:off x="640080" y="2743200"/>
-            <a:ext cx="3474720" cy="2706624"/>
+            <a:off x="3410712" y="1828800"/>
+            <a:ext cx="2578608" cy="1078992"/>
           </a:xfrm>
           <a:prstGeom prst="roundRect">
             <a:avLst/>
@@ -15625,14 +15993,308 @@
       </p:sp>
       <p:sp>
         <p:nvSpPr>
-          <p:cNvPr id="8" name="TextBox 7"/>
+          <p:cNvPr id="9" name="TextBox 8"/>
           <p:cNvSpPr txBox="1"/>
           <p:nvPr/>
         </p:nvSpPr>
         <p:spPr>
           <a:xfrm>
-            <a:off x="713232" y="2779776"/>
-            <a:ext cx="3328416" cy="365760"/>
+            <a:off x="3465576" y="1865376"/>
+            <a:ext cx="2468880" cy="1005840"/>
+          </a:xfrm>
+          <a:prstGeom prst="rect">
+            <a:avLst/>
+          </a:prstGeom>
+          <a:noFill/>
+        </p:spPr>
+        <p:txBody>
+          <a:bodyPr wrap="square" lIns="18288" rIns="18288">
+            <a:spAutoFit/>
+          </a:bodyPr>
+          <a:lstStyle/>
+          <a:p>
+            <a:pPr>
+              <a:spcAft>
+                <a:spcPts val="200"/>
+              </a:spcAft>
+              <a:defRPr sz="900" b="1">
+                <a:solidFill>
+                  <a:srgbClr val="FF3F6C"/>
+                </a:solidFill>
+              </a:defRPr>
+            </a:pPr>
+            <a:r>
+              <a:t>2. Inference Engine</a:t>
+            </a:r>
+          </a:p>
+          <a:p>
+            <a:pPr>
+              <a:lnSpc>
+                <a:spcPct val="110000"/>
+              </a:lnSpc>
+              <a:defRPr sz="750">
+                <a:solidFill>
+                  <a:srgbClr val="282C3F"/>
+                </a:solidFill>
+              </a:defRPr>
+            </a:pPr>
+            <a:r>
+              <a:t>Review NLP normalizes fabric GSM weight, fit consensus %, and return friction score from 20k reviews.</a:t>
+            </a:r>
+          </a:p>
+        </p:txBody>
+      </p:sp>
+      <p:sp>
+        <p:nvSpPr>
+          <p:cNvPr id="10" name="Rounded Rectangle 9"/>
+          <p:cNvSpPr/>
+          <p:nvPr/>
+        </p:nvSpPr>
+        <p:spPr>
+          <a:xfrm>
+            <a:off x="6181344" y="1828800"/>
+            <a:ext cx="2578608" cy="1078992"/>
+          </a:xfrm>
+          <a:prstGeom prst="roundRect">
+            <a:avLst/>
+          </a:prstGeom>
+          <a:solidFill>
+            <a:srgbClr val="FFFFFF"/>
+          </a:solidFill>
+          <a:ln w="12700">
+            <a:solidFill>
+              <a:srgbClr val="EAEAEC"/>
+            </a:solidFill>
+          </a:ln>
+        </p:spPr>
+        <p:style>
+          <a:lnRef idx="1">
+            <a:schemeClr val="accent1"/>
+          </a:lnRef>
+          <a:fillRef idx="3">
+            <a:schemeClr val="accent1"/>
+          </a:fillRef>
+          <a:effectRef idx="2">
+            <a:schemeClr val="accent1"/>
+          </a:effectRef>
+          <a:fontRef idx="minor">
+            <a:schemeClr val="lt1"/>
+          </a:fontRef>
+        </p:style>
+        <p:txBody>
+          <a:bodyPr rtlCol="0" anchor="ctr"/>
+          <a:lstStyle/>
+          <a:p>
+            <a:pPr algn="ctr"/>
+          </a:p>
+        </p:txBody>
+      </p:sp>
+      <p:sp>
+        <p:nvSpPr>
+          <p:cNvPr id="11" name="TextBox 10"/>
+          <p:cNvSpPr txBox="1"/>
+          <p:nvPr/>
+        </p:nvSpPr>
+        <p:spPr>
+          <a:xfrm>
+            <a:off x="6236208" y="1865376"/>
+            <a:ext cx="2468880" cy="1005840"/>
+          </a:xfrm>
+          <a:prstGeom prst="rect">
+            <a:avLst/>
+          </a:prstGeom>
+          <a:noFill/>
+        </p:spPr>
+        <p:txBody>
+          <a:bodyPr wrap="square" lIns="18288" rIns="18288">
+            <a:spAutoFit/>
+          </a:bodyPr>
+          <a:lstStyle/>
+          <a:p>
+            <a:pPr>
+              <a:spcAft>
+                <a:spcPts val="200"/>
+              </a:spcAft>
+              <a:defRPr sz="900" b="1">
+                <a:solidFill>
+                  <a:srgbClr val="FF3F6C"/>
+                </a:solidFill>
+              </a:defRPr>
+            </a:pPr>
+            <a:r>
+              <a:t>3. Constrained Catalog</a:t>
+            </a:r>
+          </a:p>
+          <a:p>
+            <a:pPr>
+              <a:lnSpc>
+                <a:spcPct val="110000"/>
+              </a:lnSpc>
+              <a:defRPr sz="750">
+                <a:solidFill>
+                  <a:srgbClr val="282C3F"/>
+                </a:solidFill>
+              </a:defRPr>
+            </a:pPr>
+            <a:r>
+              <a:t>Maps item to pre-approved, high-margin styling catalog for complete 3-piece look builder.</a:t>
+            </a:r>
+          </a:p>
+        </p:txBody>
+      </p:sp>
+      <p:sp>
+        <p:nvSpPr>
+          <p:cNvPr id="12" name="Rounded Rectangle 11"/>
+          <p:cNvSpPr/>
+          <p:nvPr/>
+        </p:nvSpPr>
+        <p:spPr>
+          <a:xfrm>
+            <a:off x="8951976" y="1828800"/>
+            <a:ext cx="2578608" cy="1078992"/>
+          </a:xfrm>
+          <a:prstGeom prst="roundRect">
+            <a:avLst/>
+          </a:prstGeom>
+          <a:solidFill>
+            <a:srgbClr val="FFFFFF"/>
+          </a:solidFill>
+          <a:ln w="12700">
+            <a:solidFill>
+              <a:srgbClr val="EAEAEC"/>
+            </a:solidFill>
+          </a:ln>
+        </p:spPr>
+        <p:style>
+          <a:lnRef idx="1">
+            <a:schemeClr val="accent1"/>
+          </a:lnRef>
+          <a:fillRef idx="3">
+            <a:schemeClr val="accent1"/>
+          </a:fillRef>
+          <a:effectRef idx="2">
+            <a:schemeClr val="accent1"/>
+          </a:effectRef>
+          <a:fontRef idx="minor">
+            <a:schemeClr val="lt1"/>
+          </a:fontRef>
+        </p:style>
+        <p:txBody>
+          <a:bodyPr rtlCol="0" anchor="ctr"/>
+          <a:lstStyle/>
+          <a:p>
+            <a:pPr algn="ctr"/>
+          </a:p>
+        </p:txBody>
+      </p:sp>
+      <p:sp>
+        <p:nvSpPr>
+          <p:cNvPr id="13" name="TextBox 12"/>
+          <p:cNvSpPr txBox="1"/>
+          <p:nvPr/>
+        </p:nvSpPr>
+        <p:spPr>
+          <a:xfrm>
+            <a:off x="9006840" y="1865376"/>
+            <a:ext cx="2468880" cy="1005840"/>
+          </a:xfrm>
+          <a:prstGeom prst="rect">
+            <a:avLst/>
+          </a:prstGeom>
+          <a:noFill/>
+        </p:spPr>
+        <p:txBody>
+          <a:bodyPr wrap="square" lIns="18288" rIns="18288">
+            <a:spAutoFit/>
+          </a:bodyPr>
+          <a:lstStyle/>
+          <a:p>
+            <a:pPr>
+              <a:spcAft>
+                <a:spcPts val="200"/>
+              </a:spcAft>
+              <a:defRPr sz="900" b="1">
+                <a:solidFill>
+                  <a:srgbClr val="FF3F6C"/>
+                </a:solidFill>
+              </a:defRPr>
+            </a:pPr>
+            <a:r>
+              <a:t>4. Real-time UI Render</a:t>
+            </a:r>
+          </a:p>
+          <a:p>
+            <a:pPr>
+              <a:lnSpc>
+                <a:spcPct val="110000"/>
+              </a:lnSpc>
+              <a:defRPr sz="750">
+                <a:solidFill>
+                  <a:srgbClr val="282C3F"/>
+                </a:solidFill>
+              </a:defRPr>
+            </a:pPr>
+            <a:r>
+              <a:t>Returns clean JSON payload and renders interactive Spec Matrix and WhatsApp Poll card in &lt;180ms.</a:t>
+            </a:r>
+          </a:p>
+        </p:txBody>
+      </p:sp>
+      <p:sp>
+        <p:nvSpPr>
+          <p:cNvPr id="14" name="Rounded Rectangle 13"/>
+          <p:cNvSpPr/>
+          <p:nvPr/>
+        </p:nvSpPr>
+        <p:spPr>
+          <a:xfrm>
+            <a:off x="640080" y="2999232"/>
+            <a:ext cx="3474720" cy="2450592"/>
+          </a:xfrm>
+          <a:prstGeom prst="roundRect">
+            <a:avLst/>
+          </a:prstGeom>
+          <a:solidFill>
+            <a:srgbClr val="FFFFFF"/>
+          </a:solidFill>
+          <a:ln w="12700">
+            <a:solidFill>
+              <a:srgbClr val="EAEAEC"/>
+            </a:solidFill>
+          </a:ln>
+        </p:spPr>
+        <p:style>
+          <a:lnRef idx="1">
+            <a:schemeClr val="accent1"/>
+          </a:lnRef>
+          <a:fillRef idx="3">
+            <a:schemeClr val="accent1"/>
+          </a:fillRef>
+          <a:effectRef idx="2">
+            <a:schemeClr val="accent1"/>
+          </a:effectRef>
+          <a:fontRef idx="minor">
+            <a:schemeClr val="lt1"/>
+          </a:fontRef>
+        </p:style>
+        <p:txBody>
+          <a:bodyPr rtlCol="0" anchor="ctr"/>
+          <a:lstStyle/>
+          <a:p>
+            <a:pPr algn="ctr"/>
+          </a:p>
+        </p:txBody>
+      </p:sp>
+      <p:sp>
+        <p:nvSpPr>
+          <p:cNvPr id="15" name="TextBox 14"/>
+          <p:cNvSpPr txBox="1"/>
+          <p:nvPr/>
+        </p:nvSpPr>
+        <p:spPr>
+          <a:xfrm>
+            <a:off x="713232" y="3035808"/>
+            <a:ext cx="3328416" cy="347472"/>
           </a:xfrm>
           <a:prstGeom prst="rect">
             <a:avLst/>
@@ -15660,7 +16322,7 @@
       </p:sp>
       <p:pic>
         <p:nvPicPr>
-          <p:cNvPr id="9" name="Picture 8" descr="01_Figma_Mobile_Spec_Comparison_Matrix.png"/>
+          <p:cNvPr id="16" name="Picture 15" descr="01_Figma_Mobile_Spec_Comparison_Matrix.png"/>
           <p:cNvPicPr>
             <a:picLocks noChangeAspect="1"/>
           </p:cNvPicPr>
@@ -15674,8 +16336,8 @@
         </p:blipFill>
         <p:spPr>
           <a:xfrm>
-            <a:off x="749808" y="3127248"/>
-            <a:ext cx="3255264" cy="2240280"/>
+            <a:off x="749808" y="3364992"/>
+            <a:ext cx="3255264" cy="2011680"/>
           </a:xfrm>
           <a:prstGeom prst="rect">
             <a:avLst/>
@@ -15684,14 +16346,14 @@
       </p:pic>
       <p:sp>
         <p:nvSpPr>
-          <p:cNvPr id="10" name="Rounded Rectangle 9"/>
+          <p:cNvPr id="17" name="Rounded Rectangle 16"/>
           <p:cNvSpPr/>
           <p:nvPr/>
         </p:nvSpPr>
         <p:spPr>
           <a:xfrm>
-            <a:off x="4352544" y="2743200"/>
-            <a:ext cx="3474720" cy="2706624"/>
+            <a:off x="4352544" y="2999232"/>
+            <a:ext cx="3474720" cy="2450592"/>
           </a:xfrm>
           <a:prstGeom prst="roundRect">
             <a:avLst/>
@@ -15729,14 +16391,14 @@
       </p:sp>
       <p:sp>
         <p:nvSpPr>
-          <p:cNvPr id="11" name="TextBox 10"/>
+          <p:cNvPr id="18" name="TextBox 17"/>
           <p:cNvSpPr txBox="1"/>
           <p:nvPr/>
         </p:nvSpPr>
         <p:spPr>
           <a:xfrm>
-            <a:off x="4425696" y="2779776"/>
-            <a:ext cx="3328416" cy="365760"/>
+            <a:off x="4425696" y="3035808"/>
+            <a:ext cx="3328416" cy="347472"/>
           </a:xfrm>
           <a:prstGeom prst="rect">
             <a:avLst/>
@@ -15764,7 +16426,7 @@
       </p:sp>
       <p:pic>
         <p:nvPicPr>
-          <p:cNvPr id="12" name="Picture 11" descr="02_Figma_Mobile_AI_Outfit_Coordinator.png"/>
+          <p:cNvPr id="19" name="Picture 18" descr="02_Figma_Mobile_AI_Outfit_Coordinator.png"/>
           <p:cNvPicPr>
             <a:picLocks noChangeAspect="1"/>
           </p:cNvPicPr>
@@ -15778,8 +16440,8 @@
         </p:blipFill>
         <p:spPr>
           <a:xfrm>
-            <a:off x="4462272" y="3127248"/>
-            <a:ext cx="3255264" cy="2240280"/>
+            <a:off x="4462272" y="3364992"/>
+            <a:ext cx="3255264" cy="2011680"/>
           </a:xfrm>
           <a:prstGeom prst="rect">
             <a:avLst/>
@@ -15788,14 +16450,14 @@
       </p:pic>
       <p:sp>
         <p:nvSpPr>
-          <p:cNvPr id="13" name="Rounded Rectangle 12"/>
+          <p:cNvPr id="20" name="Rounded Rectangle 19"/>
           <p:cNvSpPr/>
           <p:nvPr/>
         </p:nvSpPr>
         <p:spPr>
           <a:xfrm>
-            <a:off x="8065008" y="2743200"/>
-            <a:ext cx="3474720" cy="2706624"/>
+            <a:off x="8065008" y="2999232"/>
+            <a:ext cx="3474720" cy="2450592"/>
           </a:xfrm>
           <a:prstGeom prst="roundRect">
             <a:avLst/>
@@ -15833,14 +16495,14 @@
       </p:sp>
       <p:sp>
         <p:nvSpPr>
-          <p:cNvPr id="14" name="TextBox 13"/>
+          <p:cNvPr id="21" name="TextBox 20"/>
           <p:cNvSpPr txBox="1"/>
           <p:nvPr/>
         </p:nvSpPr>
         <p:spPr>
           <a:xfrm>
-            <a:off x="8138160" y="2779776"/>
-            <a:ext cx="3328416" cy="365760"/>
+            <a:off x="8138160" y="3035808"/>
+            <a:ext cx="3328416" cy="347472"/>
           </a:xfrm>
           <a:prstGeom prst="rect">
             <a:avLst/>
@@ -15868,7 +16530,7 @@
       </p:sp>
       <p:pic>
         <p:nvPicPr>
-          <p:cNvPr id="15" name="Picture 14" descr="03_Figma_Mobile_WhatsApp_Voting_Card.png"/>
+          <p:cNvPr id="22" name="Picture 21" descr="03_Figma_Mobile_WhatsApp_Voting_Card.png"/>
           <p:cNvPicPr>
             <a:picLocks noChangeAspect="1"/>
           </p:cNvPicPr>
@@ -15882,8 +16544,8 @@
         </p:blipFill>
         <p:spPr>
           <a:xfrm>
-            <a:off x="8174736" y="3127248"/>
-            <a:ext cx="3255264" cy="2240280"/>
+            <a:off x="8174736" y="3364992"/>
+            <a:ext cx="3255264" cy="2011680"/>
           </a:xfrm>
           <a:prstGeom prst="rect">
             <a:avLst/>
@@ -15892,7 +16554,7 @@
       </p:pic>
       <p:sp>
         <p:nvSpPr>
-          <p:cNvPr id="16" name="Rounded Rectangle 15"/>
+          <p:cNvPr id="23" name="Rounded Rectangle 22"/>
           <p:cNvSpPr/>
           <p:nvPr/>
         </p:nvSpPr>
@@ -15937,7 +16599,7 @@
       </p:sp>
       <p:sp>
         <p:nvSpPr>
-          <p:cNvPr id="17" name="TextBox 16"/>
+          <p:cNvPr id="24" name="TextBox 23"/>
           <p:cNvSpPr txBox="1"/>
           <p:nvPr/>
         </p:nvSpPr>
@@ -15993,7 +16655,7 @@
       </p:sp>
       <p:sp>
         <p:nvSpPr>
-          <p:cNvPr id="18" name="Rounded Rectangle 17"/>
+          <p:cNvPr id="25" name="Rounded Rectangle 24"/>
           <p:cNvSpPr/>
           <p:nvPr/>
         </p:nvSpPr>
@@ -16053,7 +16715,7 @@
       </p:sp>
       <p:sp>
         <p:nvSpPr>
-          <p:cNvPr id="19" name="Rounded Rectangle 18"/>
+          <p:cNvPr id="26" name="Rounded Rectangle 25"/>
           <p:cNvSpPr/>
           <p:nvPr/>
         </p:nvSpPr>
@@ -16113,7 +16775,7 @@
       </p:sp>
       <p:sp>
         <p:nvSpPr>
-          <p:cNvPr id="20" name="Rounded Rectangle 19"/>
+          <p:cNvPr id="27" name="Rounded Rectangle 26"/>
           <p:cNvSpPr/>
           <p:nvPr/>
         </p:nvSpPr>
@@ -16173,7 +16835,7 @@
       </p:sp>
       <p:sp>
         <p:nvSpPr>
-          <p:cNvPr id="21" name="Rounded Rectangle 20"/>
+          <p:cNvPr id="28" name="Rounded Rectangle 27"/>
           <p:cNvSpPr/>
           <p:nvPr/>
         </p:nvSpPr>
@@ -16233,7 +16895,7 @@
       </p:sp>
       <p:sp>
         <p:nvSpPr>
-          <p:cNvPr id="22" name="Rounded Rectangle 21"/>
+          <p:cNvPr id="29" name="Rounded Rectangle 28"/>
           <p:cNvSpPr/>
           <p:nvPr/>
         </p:nvSpPr>
@@ -16293,7 +16955,7 @@
       </p:sp>
       <p:sp>
         <p:nvSpPr>
-          <p:cNvPr id="23" name="Rounded Rectangle 22"/>
+          <p:cNvPr id="30" name="Rounded Rectangle 29"/>
           <p:cNvSpPr/>
           <p:nvPr/>
         </p:nvSpPr>
@@ -16353,7 +17015,7 @@
       </p:sp>
       <p:sp>
         <p:nvSpPr>
-          <p:cNvPr id="24" name="Rounded Rectangle 23"/>
+          <p:cNvPr id="31" name="Rounded Rectangle 30"/>
           <p:cNvSpPr/>
           <p:nvPr/>
         </p:nvSpPr>
@@ -16413,7 +17075,7 @@
       </p:sp>
       <p:sp>
         <p:nvSpPr>
-          <p:cNvPr id="25" name="Rounded Rectangle 24"/>
+          <p:cNvPr id="32" name="Rounded Rectangle 31"/>
           <p:cNvSpPr/>
           <p:nvPr/>
         </p:nvSpPr>
@@ -16473,7 +17135,7 @@
       </p:sp>
       <p:sp>
         <p:nvSpPr>
-          <p:cNvPr id="26" name="Rounded Rectangle 25"/>
+          <p:cNvPr id="33" name="Rounded Rectangle 32"/>
           <p:cNvSpPr/>
           <p:nvPr/>
         </p:nvSpPr>
@@ -16533,7 +17195,7 @@
       </p:sp>
       <p:sp>
         <p:nvSpPr>
-          <p:cNvPr id="27" name="Rounded Rectangle 26"/>
+          <p:cNvPr id="34" name="Rounded Rectangle 33"/>
           <p:cNvSpPr/>
           <p:nvPr/>
         </p:nvSpPr>

</xml_diff>

<commit_message>
fix(pptx): enforce strict minimum 14pt font size across all 10 presentation slides per evaluation guidelines
</commit_message>
<xml_diff>
--- a/Myntra_Wishlist_Studio_10_Slide_Deck.pptx
+++ b/Myntra_Wishlist_Studio_10_Slide_Deck.pptx
@@ -3105,8 +3105,8 @@
         </p:nvSpPr>
         <p:spPr>
           <a:xfrm>
-            <a:off x="3124047" y="182880"/>
-            <a:ext cx="5943600" cy="329184"/>
+            <a:off x="2666847" y="164592"/>
+            <a:ext cx="6858000" cy="384048"/>
           </a:xfrm>
           <a:prstGeom prst="roundRect">
             <a:avLst/>
@@ -3143,7 +3143,7 @@
               <a:spcAft>
                 <a:spcPts val="0"/>
               </a:spcAft>
-              <a:defRPr sz="950" b="1">
+              <a:defRPr sz="1400" b="1">
                 <a:solidFill>
                   <a:srgbClr val="FFFFFF"/>
                 </a:solidFill>
@@ -3163,8 +3163,8 @@
         </p:nvSpPr>
         <p:spPr>
           <a:xfrm>
-            <a:off x="640080" y="585216"/>
-            <a:ext cx="9601200" cy="777240"/>
+            <a:off x="594360" y="594360"/>
+            <a:ext cx="9875520" cy="777240"/>
           </a:xfrm>
           <a:prstGeom prst="rect">
             <a:avLst/>
@@ -3181,7 +3181,7 @@
               <a:spcAft>
                 <a:spcPts val="200"/>
               </a:spcAft>
-              <a:defRPr sz="1350" b="1">
+              <a:defRPr sz="1800" b="1">
                 <a:solidFill>
                   <a:srgbClr val="282C3F"/>
                 </a:solidFill>
@@ -3199,7 +3199,7 @@
               <a:spcAft>
                 <a:spcPts val="400"/>
               </a:spcAft>
-              <a:defRPr sz="1000" b="1">
+              <a:defRPr sz="1400" b="1">
                 <a:solidFill>
                   <a:srgbClr val="FF3F6C"/>
                 </a:solidFill>
@@ -3219,7 +3219,7 @@
         </p:nvSpPr>
         <p:spPr>
           <a:xfrm>
-            <a:off x="10424160" y="585216"/>
+            <a:off x="10424160" y="594360"/>
             <a:ext cx="1188720" cy="457200"/>
           </a:xfrm>
           <a:prstGeom prst="rect">
@@ -3234,7 +3234,7 @@
           <a:lstStyle/>
           <a:p>
             <a:pPr algn="r">
-              <a:defRPr sz="2200" b="1">
+              <a:defRPr sz="2400" b="1">
                 <a:solidFill>
                   <a:srgbClr val="FF3F6C"/>
                 </a:solidFill>
@@ -3254,7 +3254,7 @@
         </p:nvSpPr>
         <p:spPr>
           <a:xfrm>
-            <a:off x="640080" y="1444752"/>
+            <a:off x="594360" y="1417320"/>
             <a:ext cx="3931920" cy="3794760"/>
           </a:xfrm>
           <a:prstGeom prst="roundRect">
@@ -3263,7 +3263,7 @@
           <a:solidFill>
             <a:srgbClr val="FFFFFF"/>
           </a:solidFill>
-          <a:ln w="12700">
+          <a:ln w="19050">
             <a:solidFill>
               <a:srgbClr val="EAEAEC"/>
             </a:solidFill>
@@ -3299,8 +3299,8 @@
         </p:nvSpPr>
         <p:spPr>
           <a:xfrm>
-            <a:off x="749808" y="1536192"/>
-            <a:ext cx="3712464" cy="3611880"/>
+            <a:off x="704088" y="1490472"/>
+            <a:ext cx="3712464" cy="3648456"/>
           </a:xfrm>
           <a:prstGeom prst="rect">
             <a:avLst/>
@@ -3308,16 +3308,16 @@
           <a:noFill/>
         </p:spPr>
         <p:txBody>
-          <a:bodyPr wrap="square" lIns="73152" rIns="73152" tIns="54864" bIns="54864">
+          <a:bodyPr wrap="square" lIns="54864" rIns="54864">
             <a:spAutoFit/>
           </a:bodyPr>
           <a:lstStyle/>
           <a:p>
             <a:pPr>
               <a:spcAft>
-                <a:spcPts val="600"/>
-              </a:spcAft>
-              <a:defRPr sz="1100" b="1">
+                <a:spcPts val="400"/>
+              </a:spcAft>
+              <a:defRPr sz="1500" b="1">
                 <a:solidFill>
                   <a:srgbClr val="FF3F6C"/>
                 </a:solidFill>
@@ -3336,9 +3336,9 @@
                 <a:spcPts val="200"/>
               </a:spcBef>
               <a:spcAft>
-                <a:spcPts val="400"/>
-              </a:spcAft>
-              <a:defRPr sz="950"/>
+                <a:spcPts val="300"/>
+              </a:spcAft>
+              <a:defRPr sz="1400"/>
             </a:pPr>
             <a:r>
               <a:rPr b="1">
@@ -3374,9 +3374,9 @@
                 <a:spcPts val="200"/>
               </a:spcBef>
               <a:spcAft>
-                <a:spcPts val="400"/>
-              </a:spcAft>
-              <a:defRPr sz="950"/>
+                <a:spcPts val="300"/>
+              </a:spcAft>
+              <a:defRPr sz="1400"/>
             </a:pPr>
             <a:r>
               <a:rPr b="1">
@@ -3412,9 +3412,9 @@
                 <a:spcPts val="200"/>
               </a:spcBef>
               <a:spcAft>
-                <a:spcPts val="400"/>
-              </a:spcAft>
-              <a:defRPr sz="950"/>
+                <a:spcPts val="300"/>
+              </a:spcAft>
+              <a:defRPr sz="1400"/>
             </a:pPr>
             <a:r>
               <a:rPr b="1">
@@ -3450,9 +3450,9 @@
                 <a:spcPts val="200"/>
               </a:spcBef>
               <a:spcAft>
-                <a:spcPts val="400"/>
-              </a:spcAft>
-              <a:defRPr sz="950"/>
+                <a:spcPts val="300"/>
+              </a:spcAft>
+              <a:defRPr sz="1400"/>
             </a:pPr>
             <a:r>
               <a:rPr b="1">
@@ -3489,8 +3489,8 @@
         </p:nvSpPr>
         <p:spPr>
           <a:xfrm>
-            <a:off x="4709160" y="1444752"/>
-            <a:ext cx="4251960" cy="3794760"/>
+            <a:off x="4663440" y="1417320"/>
+            <a:ext cx="4389120" cy="3794760"/>
           </a:xfrm>
           <a:prstGeom prst="roundRect">
             <a:avLst/>
@@ -3498,7 +3498,7 @@
           <a:solidFill>
             <a:srgbClr val="FFF0F4"/>
           </a:solidFill>
-          <a:ln w="12700">
+          <a:ln w="19050">
             <a:solidFill>
               <a:srgbClr val="FFC2D1"/>
             </a:solidFill>
@@ -3534,8 +3534,8 @@
         </p:nvSpPr>
         <p:spPr>
           <a:xfrm>
-            <a:off x="4818888" y="1536192"/>
-            <a:ext cx="4032504" cy="3611880"/>
+            <a:off x="4773168" y="1490472"/>
+            <a:ext cx="4169664" cy="3648456"/>
           </a:xfrm>
           <a:prstGeom prst="rect">
             <a:avLst/>
@@ -3543,7 +3543,7 @@
           <a:noFill/>
         </p:spPr>
         <p:txBody>
-          <a:bodyPr wrap="square" lIns="54864" rIns="54864" tIns="54864" bIns="54864">
+          <a:bodyPr wrap="square" lIns="54864" rIns="54864">
             <a:spAutoFit/>
           </a:bodyPr>
           <a:lstStyle/>
@@ -3552,7 +3552,7 @@
               <a:spcAft>
                 <a:spcPts val="400"/>
               </a:spcAft>
-              <a:defRPr sz="1100" b="1">
+              <a:defRPr sz="1500" b="1">
                 <a:solidFill>
                   <a:srgbClr val="FF3F6C"/>
                 </a:solidFill>
@@ -3571,9 +3571,9 @@
                 <a:spcPts val="200"/>
               </a:spcBef>
               <a:spcAft>
-                <a:spcPts val="300"/>
-              </a:spcAft>
-              <a:defRPr sz="919"/>
+                <a:spcPts val="200"/>
+              </a:spcAft>
+              <a:defRPr sz="1400"/>
             </a:pPr>
             <a:r>
               <a:rPr b="1">
@@ -3601,9 +3601,9 @@
                 <a:spcPts val="200"/>
               </a:spcBef>
               <a:spcAft>
-                <a:spcPts val="300"/>
-              </a:spcAft>
-              <a:defRPr sz="919"/>
+                <a:spcPts val="200"/>
+              </a:spcAft>
+              <a:defRPr sz="1400"/>
             </a:pPr>
             <a:r>
               <a:rPr b="1">
@@ -3631,9 +3631,9 @@
                 <a:spcPts val="200"/>
               </a:spcBef>
               <a:spcAft>
-                <a:spcPts val="300"/>
-              </a:spcAft>
-              <a:defRPr sz="919"/>
+                <a:spcPts val="200"/>
+              </a:spcAft>
+              <a:defRPr sz="1400"/>
             </a:pPr>
             <a:r>
               <a:rPr b="1">
@@ -3661,9 +3661,9 @@
                 <a:spcPts val="200"/>
               </a:spcBef>
               <a:spcAft>
-                <a:spcPts val="300"/>
-              </a:spcAft>
-              <a:defRPr sz="919"/>
+                <a:spcPts val="200"/>
+              </a:spcAft>
+              <a:defRPr sz="1400"/>
             </a:pPr>
             <a:r>
               <a:rPr b="1">
@@ -3691,9 +3691,9 @@
                 <a:spcPts val="200"/>
               </a:spcBef>
               <a:spcAft>
-                <a:spcPts val="300"/>
-              </a:spcAft>
-              <a:defRPr sz="919"/>
+                <a:spcPts val="200"/>
+              </a:spcAft>
+              <a:defRPr sz="1400"/>
             </a:pPr>
             <a:r>
               <a:rPr b="1">
@@ -3722,8 +3722,8 @@
         </p:nvSpPr>
         <p:spPr>
           <a:xfrm>
-            <a:off x="9098280" y="1444752"/>
-            <a:ext cx="2450592" cy="3794760"/>
+            <a:off x="9189720" y="1417320"/>
+            <a:ext cx="2404872" cy="3794760"/>
           </a:xfrm>
           <a:prstGeom prst="roundRect">
             <a:avLst/>
@@ -3731,7 +3731,7 @@
           <a:solidFill>
             <a:srgbClr val="282C3F"/>
           </a:solidFill>
-          <a:ln w="12700">
+          <a:ln w="19050">
             <a:solidFill>
               <a:srgbClr val="0F172A"/>
             </a:solidFill>
@@ -3775,8 +3775,8 @@
         </p:blipFill>
         <p:spPr>
           <a:xfrm>
-            <a:off x="9153144" y="1499616"/>
-            <a:ext cx="2340864" cy="3685032"/>
+            <a:off x="9244584" y="1472184"/>
+            <a:ext cx="2295144" cy="3685032"/>
           </a:xfrm>
           <a:prstGeom prst="rect">
             <a:avLst/>
@@ -3791,8 +3791,8 @@
         </p:nvSpPr>
         <p:spPr>
           <a:xfrm>
-            <a:off x="640080" y="5376672"/>
-            <a:ext cx="2615184" cy="1051560"/>
+            <a:off x="594360" y="5349240"/>
+            <a:ext cx="2633472" cy="1234440"/>
           </a:xfrm>
           <a:prstGeom prst="roundRect">
             <a:avLst/>
@@ -3800,7 +3800,7 @@
           <a:solidFill>
             <a:srgbClr val="FFFFFF"/>
           </a:solidFill>
-          <a:ln w="12700">
+          <a:ln w="19050">
             <a:solidFill>
               <a:srgbClr val="EAEAEC"/>
             </a:solidFill>
@@ -3836,8 +3836,8 @@
         </p:nvSpPr>
         <p:spPr>
           <a:xfrm>
-            <a:off x="640080" y="5468112"/>
-            <a:ext cx="2615184" cy="868680"/>
+            <a:off x="594360" y="5422392"/>
+            <a:ext cx="2633472" cy="1088136"/>
           </a:xfrm>
           <a:prstGeom prst="rect">
             <a:avLst/>
@@ -3851,7 +3851,7 @@
           <a:lstStyle/>
           <a:p>
             <a:pPr algn="ctr">
-              <a:defRPr sz="1600" b="1">
+              <a:defRPr sz="2400" b="1">
                 <a:solidFill>
                   <a:srgbClr val="FF3F6C"/>
                 </a:solidFill>
@@ -3866,7 +3866,7 @@
               <a:spcBef>
                 <a:spcPts val="200"/>
               </a:spcBef>
-              <a:defRPr sz="900" b="1">
+              <a:defRPr sz="1400" b="1">
                 <a:solidFill>
                   <a:srgbClr val="535766"/>
                 </a:solidFill>
@@ -3886,8 +3886,8 @@
         </p:nvSpPr>
         <p:spPr>
           <a:xfrm>
-            <a:off x="3401568" y="5376672"/>
-            <a:ext cx="2615184" cy="1051560"/>
+            <a:off x="3383280" y="5349240"/>
+            <a:ext cx="2633472" cy="1234440"/>
           </a:xfrm>
           <a:prstGeom prst="roundRect">
             <a:avLst/>
@@ -3895,7 +3895,7 @@
           <a:solidFill>
             <a:srgbClr val="FFFFFF"/>
           </a:solidFill>
-          <a:ln w="12700">
+          <a:ln w="19050">
             <a:solidFill>
               <a:srgbClr val="EAEAEC"/>
             </a:solidFill>
@@ -3931,8 +3931,8 @@
         </p:nvSpPr>
         <p:spPr>
           <a:xfrm>
-            <a:off x="3401568" y="5468112"/>
-            <a:ext cx="2615184" cy="868680"/>
+            <a:off x="3383280" y="5422392"/>
+            <a:ext cx="2633472" cy="1088136"/>
           </a:xfrm>
           <a:prstGeom prst="rect">
             <a:avLst/>
@@ -3946,7 +3946,7 @@
           <a:lstStyle/>
           <a:p>
             <a:pPr algn="ctr">
-              <a:defRPr sz="1600" b="1">
+              <a:defRPr sz="2400" b="1">
                 <a:solidFill>
                   <a:srgbClr val="FF3F6C"/>
                 </a:solidFill>
@@ -3961,7 +3961,7 @@
               <a:spcBef>
                 <a:spcPts val="200"/>
               </a:spcBef>
-              <a:defRPr sz="900" b="1">
+              <a:defRPr sz="1400" b="1">
                 <a:solidFill>
                   <a:srgbClr val="535766"/>
                 </a:solidFill>
@@ -3981,8 +3981,8 @@
         </p:nvSpPr>
         <p:spPr>
           <a:xfrm>
-            <a:off x="6163056" y="5376672"/>
-            <a:ext cx="2615184" cy="1051560"/>
+            <a:off x="6172200" y="5349240"/>
+            <a:ext cx="2633472" cy="1234440"/>
           </a:xfrm>
           <a:prstGeom prst="roundRect">
             <a:avLst/>
@@ -3990,7 +3990,7 @@
           <a:solidFill>
             <a:srgbClr val="FFFFFF"/>
           </a:solidFill>
-          <a:ln w="12700">
+          <a:ln w="19050">
             <a:solidFill>
               <a:srgbClr val="EAEAEC"/>
             </a:solidFill>
@@ -4026,8 +4026,8 @@
         </p:nvSpPr>
         <p:spPr>
           <a:xfrm>
-            <a:off x="6163056" y="5468112"/>
-            <a:ext cx="2615184" cy="868680"/>
+            <a:off x="6172200" y="5422392"/>
+            <a:ext cx="2633472" cy="1088136"/>
           </a:xfrm>
           <a:prstGeom prst="rect">
             <a:avLst/>
@@ -4041,7 +4041,7 @@
           <a:lstStyle/>
           <a:p>
             <a:pPr algn="ctr">
-              <a:defRPr sz="1600" b="1">
+              <a:defRPr sz="2400" b="1">
                 <a:solidFill>
                   <a:srgbClr val="FF3F6C"/>
                 </a:solidFill>
@@ -4056,7 +4056,7 @@
               <a:spcBef>
                 <a:spcPts val="200"/>
               </a:spcBef>
-              <a:defRPr sz="900" b="1">
+              <a:defRPr sz="1400" b="1">
                 <a:solidFill>
                   <a:srgbClr val="535766"/>
                 </a:solidFill>
@@ -4076,8 +4076,8 @@
         </p:nvSpPr>
         <p:spPr>
           <a:xfrm>
-            <a:off x="8924544" y="5376672"/>
-            <a:ext cx="2615184" cy="1051560"/>
+            <a:off x="8961120" y="5349240"/>
+            <a:ext cx="2633472" cy="1234440"/>
           </a:xfrm>
           <a:prstGeom prst="roundRect">
             <a:avLst/>
@@ -4085,7 +4085,7 @@
           <a:solidFill>
             <a:srgbClr val="FFFFFF"/>
           </a:solidFill>
-          <a:ln w="12700">
+          <a:ln w="19050">
             <a:solidFill>
               <a:srgbClr val="EAEAEC"/>
             </a:solidFill>
@@ -4121,8 +4121,8 @@
         </p:nvSpPr>
         <p:spPr>
           <a:xfrm>
-            <a:off x="8924544" y="5468112"/>
-            <a:ext cx="2615184" cy="868680"/>
+            <a:off x="8961120" y="5422392"/>
+            <a:ext cx="2633472" cy="1088136"/>
           </a:xfrm>
           <a:prstGeom prst="rect">
             <a:avLst/>
@@ -4136,7 +4136,7 @@
           <a:lstStyle/>
           <a:p>
             <a:pPr algn="ctr">
-              <a:defRPr sz="1600" b="1">
+              <a:defRPr sz="2400" b="1">
                 <a:solidFill>
                   <a:srgbClr val="FF3F6C"/>
                 </a:solidFill>
@@ -4151,7 +4151,7 @@
               <a:spcBef>
                 <a:spcPts val="200"/>
               </a:spcBef>
-              <a:defRPr sz="900" b="1">
+              <a:defRPr sz="1400" b="1">
                 <a:solidFill>
                   <a:srgbClr val="535766"/>
                 </a:solidFill>
@@ -4189,8 +4189,8 @@
         </p:nvSpPr>
         <p:spPr>
           <a:xfrm>
-            <a:off x="3124047" y="182880"/>
-            <a:ext cx="5943600" cy="329184"/>
+            <a:off x="2666847" y="164592"/>
+            <a:ext cx="6858000" cy="384048"/>
           </a:xfrm>
           <a:prstGeom prst="roundRect">
             <a:avLst/>
@@ -4227,7 +4227,7 @@
               <a:spcAft>
                 <a:spcPts val="0"/>
               </a:spcAft>
-              <a:defRPr sz="950" b="1">
+              <a:defRPr sz="1400" b="1">
                 <a:solidFill>
                   <a:srgbClr val="FFFFFF"/>
                 </a:solidFill>
@@ -4247,8 +4247,8 @@
         </p:nvSpPr>
         <p:spPr>
           <a:xfrm>
-            <a:off x="640080" y="585216"/>
-            <a:ext cx="9601200" cy="777240"/>
+            <a:off x="594360" y="594360"/>
+            <a:ext cx="9875520" cy="777240"/>
           </a:xfrm>
           <a:prstGeom prst="rect">
             <a:avLst/>
@@ -4265,7 +4265,7 @@
               <a:spcAft>
                 <a:spcPts val="200"/>
               </a:spcAft>
-              <a:defRPr sz="1350" b="1">
+              <a:defRPr sz="1800" b="1">
                 <a:solidFill>
                   <a:srgbClr val="282C3F"/>
                 </a:solidFill>
@@ -4283,7 +4283,7 @@
               <a:spcAft>
                 <a:spcPts val="400"/>
               </a:spcAft>
-              <a:defRPr sz="1000" b="1">
+              <a:defRPr sz="1400" b="1">
                 <a:solidFill>
                   <a:srgbClr val="FF3F6C"/>
                 </a:solidFill>
@@ -4303,7 +4303,7 @@
         </p:nvSpPr>
         <p:spPr>
           <a:xfrm>
-            <a:off x="10424160" y="585216"/>
+            <a:off x="10424160" y="594360"/>
             <a:ext cx="1188720" cy="457200"/>
           </a:xfrm>
           <a:prstGeom prst="rect">
@@ -4318,7 +4318,7 @@
           <a:lstStyle/>
           <a:p>
             <a:pPr algn="r">
-              <a:defRPr sz="2200" b="1">
+              <a:defRPr sz="2400" b="1">
                 <a:solidFill>
                   <a:srgbClr val="FF3F6C"/>
                 </a:solidFill>
@@ -4338,8 +4338,8 @@
         </p:nvSpPr>
         <p:spPr>
           <a:xfrm>
-            <a:off x="640080" y="1444752"/>
-            <a:ext cx="3529584" cy="2487168"/>
+            <a:off x="594360" y="1417320"/>
+            <a:ext cx="3566160" cy="2514600"/>
           </a:xfrm>
           <a:prstGeom prst="roundRect">
             <a:avLst/>
@@ -4347,7 +4347,7 @@
           <a:solidFill>
             <a:srgbClr val="FFFFFF"/>
           </a:solidFill>
-          <a:ln w="12700">
+          <a:ln w="19050">
             <a:solidFill>
               <a:srgbClr val="EAEAEC"/>
             </a:solidFill>
@@ -4383,8 +4383,8 @@
         </p:nvSpPr>
         <p:spPr>
           <a:xfrm>
-            <a:off x="713232" y="1499616"/>
-            <a:ext cx="3383280" cy="2377440"/>
+            <a:off x="667512" y="1472184"/>
+            <a:ext cx="3419856" cy="2404872"/>
           </a:xfrm>
           <a:prstGeom prst="rect">
             <a:avLst/>
@@ -4401,7 +4401,7 @@
               <a:spcAft>
                 <a:spcPts val="200"/>
               </a:spcAft>
-              <a:defRPr sz="980" b="1">
+              <a:defRPr sz="1500" b="1">
                 <a:solidFill>
                   <a:srgbClr val="FF3F6C"/>
                 </a:solidFill>
@@ -4414,12 +4414,12 @@
           <a:p>
             <a:pPr marL="127000" indent="0">
               <a:lnSpc>
-                <a:spcPct val="112000"/>
+                <a:spcPct val="114000"/>
               </a:lnSpc>
               <a:spcAft>
                 <a:spcPts val="200"/>
               </a:spcAft>
-              <a:defRPr sz="850"/>
+              <a:defRPr sz="1400"/>
             </a:pPr>
             <a:r>
               <a:rPr b="1">
@@ -4441,12 +4441,12 @@
           <a:p>
             <a:pPr marL="127000" indent="0">
               <a:lnSpc>
-                <a:spcPct val="112000"/>
+                <a:spcPct val="114000"/>
               </a:lnSpc>
               <a:spcAft>
                 <a:spcPts val="0"/>
               </a:spcAft>
-              <a:defRPr sz="850"/>
+              <a:defRPr sz="1400"/>
             </a:pPr>
             <a:r>
               <a:rPr b="1">
@@ -4475,8 +4475,8 @@
         </p:nvSpPr>
         <p:spPr>
           <a:xfrm>
-            <a:off x="4325112" y="1444752"/>
-            <a:ext cx="3529584" cy="2487168"/>
+            <a:off x="4306824" y="1417320"/>
+            <a:ext cx="3566160" cy="2514600"/>
           </a:xfrm>
           <a:prstGeom prst="roundRect">
             <a:avLst/>
@@ -4484,7 +4484,7 @@
           <a:solidFill>
             <a:srgbClr val="FFFFFF"/>
           </a:solidFill>
-          <a:ln w="12700">
+          <a:ln w="19050">
             <a:solidFill>
               <a:srgbClr val="EAEAEC"/>
             </a:solidFill>
@@ -4520,8 +4520,8 @@
         </p:nvSpPr>
         <p:spPr>
           <a:xfrm>
-            <a:off x="4398264" y="1499616"/>
-            <a:ext cx="3383280" cy="2377440"/>
+            <a:off x="4379976" y="1472184"/>
+            <a:ext cx="3419856" cy="2404872"/>
           </a:xfrm>
           <a:prstGeom prst="rect">
             <a:avLst/>
@@ -4538,7 +4538,7 @@
               <a:spcAft>
                 <a:spcPts val="200"/>
               </a:spcAft>
-              <a:defRPr sz="980" b="1">
+              <a:defRPr sz="1500" b="1">
                 <a:solidFill>
                   <a:srgbClr val="FF3F6C"/>
                 </a:solidFill>
@@ -4551,12 +4551,12 @@
           <a:p>
             <a:pPr marL="127000" indent="0">
               <a:lnSpc>
-                <a:spcPct val="112000"/>
+                <a:spcPct val="114000"/>
               </a:lnSpc>
               <a:spcAft>
                 <a:spcPts val="200"/>
               </a:spcAft>
-              <a:defRPr sz="850"/>
+              <a:defRPr sz="1400"/>
             </a:pPr>
             <a:r>
               <a:rPr b="1">
@@ -4578,12 +4578,12 @@
           <a:p>
             <a:pPr marL="127000" indent="0">
               <a:lnSpc>
-                <a:spcPct val="112000"/>
+                <a:spcPct val="114000"/>
               </a:lnSpc>
               <a:spcAft>
                 <a:spcPts val="0"/>
               </a:spcAft>
-              <a:defRPr sz="850"/>
+              <a:defRPr sz="1400"/>
             </a:pPr>
             <a:r>
               <a:rPr b="1">
@@ -4612,8 +4612,8 @@
         </p:nvSpPr>
         <p:spPr>
           <a:xfrm>
-            <a:off x="8010144" y="1444752"/>
-            <a:ext cx="3529584" cy="2487168"/>
+            <a:off x="8019288" y="1417320"/>
+            <a:ext cx="3566160" cy="2514600"/>
           </a:xfrm>
           <a:prstGeom prst="roundRect">
             <a:avLst/>
@@ -4621,7 +4621,7 @@
           <a:solidFill>
             <a:srgbClr val="FFFFFF"/>
           </a:solidFill>
-          <a:ln w="12700">
+          <a:ln w="19050">
             <a:solidFill>
               <a:srgbClr val="EAEAEC"/>
             </a:solidFill>
@@ -4657,8 +4657,8 @@
         </p:nvSpPr>
         <p:spPr>
           <a:xfrm>
-            <a:off x="8083296" y="1499616"/>
-            <a:ext cx="3383280" cy="2377440"/>
+            <a:off x="8092440" y="1472184"/>
+            <a:ext cx="3419856" cy="2404872"/>
           </a:xfrm>
           <a:prstGeom prst="rect">
             <a:avLst/>
@@ -4675,7 +4675,7 @@
               <a:spcAft>
                 <a:spcPts val="200"/>
               </a:spcAft>
-              <a:defRPr sz="980" b="1">
+              <a:defRPr sz="1500" b="1">
                 <a:solidFill>
                   <a:srgbClr val="FF3F6C"/>
                 </a:solidFill>
@@ -4688,12 +4688,12 @@
           <a:p>
             <a:pPr marL="127000" indent="0">
               <a:lnSpc>
-                <a:spcPct val="112000"/>
+                <a:spcPct val="114000"/>
               </a:lnSpc>
               <a:spcAft>
                 <a:spcPts val="200"/>
               </a:spcAft>
-              <a:defRPr sz="850"/>
+              <a:defRPr sz="1400"/>
             </a:pPr>
             <a:r>
               <a:rPr b="1">
@@ -4715,12 +4715,12 @@
           <a:p>
             <a:pPr marL="127000" indent="0">
               <a:lnSpc>
-                <a:spcPct val="112000"/>
+                <a:spcPct val="114000"/>
               </a:lnSpc>
               <a:spcAft>
                 <a:spcPts val="0"/>
               </a:spcAft>
-              <a:defRPr sz="850"/>
+              <a:defRPr sz="1400"/>
             </a:pPr>
             <a:r>
               <a:rPr b="1">
@@ -4749,8 +4749,8 @@
         </p:nvSpPr>
         <p:spPr>
           <a:xfrm>
-            <a:off x="640080" y="4096512"/>
-            <a:ext cx="3529584" cy="2487168"/>
+            <a:off x="594360" y="4096512"/>
+            <a:ext cx="3566160" cy="2514600"/>
           </a:xfrm>
           <a:prstGeom prst="roundRect">
             <a:avLst/>
@@ -4758,7 +4758,7 @@
           <a:solidFill>
             <a:srgbClr val="FFF0F4"/>
           </a:solidFill>
-          <a:ln w="12700">
+          <a:ln w="19050">
             <a:solidFill>
               <a:srgbClr val="FFC2D1"/>
             </a:solidFill>
@@ -4794,8 +4794,8 @@
         </p:nvSpPr>
         <p:spPr>
           <a:xfrm>
-            <a:off x="713232" y="4151376"/>
-            <a:ext cx="3383280" cy="2377440"/>
+            <a:off x="667512" y="4151376"/>
+            <a:ext cx="3419856" cy="2404872"/>
           </a:xfrm>
           <a:prstGeom prst="rect">
             <a:avLst/>
@@ -4812,7 +4812,7 @@
               <a:spcAft>
                 <a:spcPts val="200"/>
               </a:spcAft>
-              <a:defRPr sz="980" b="1">
+              <a:defRPr sz="1500" b="1">
                 <a:solidFill>
                   <a:srgbClr val="FF3F6C"/>
                 </a:solidFill>
@@ -4825,12 +4825,12 @@
           <a:p>
             <a:pPr marL="127000" indent="0">
               <a:lnSpc>
-                <a:spcPct val="112000"/>
+                <a:spcPct val="114000"/>
               </a:lnSpc>
               <a:spcAft>
                 <a:spcPts val="200"/>
               </a:spcAft>
-              <a:defRPr sz="850"/>
+              <a:defRPr sz="1400"/>
             </a:pPr>
             <a:r>
               <a:rPr b="1">
@@ -4852,12 +4852,12 @@
           <a:p>
             <a:pPr marL="127000" indent="0">
               <a:lnSpc>
-                <a:spcPct val="112000"/>
+                <a:spcPct val="114000"/>
               </a:lnSpc>
               <a:spcAft>
                 <a:spcPts val="200"/>
               </a:spcAft>
-              <a:defRPr sz="850"/>
+              <a:defRPr sz="1400"/>
             </a:pPr>
             <a:r>
               <a:rPr b="1">
@@ -4879,12 +4879,12 @@
           <a:p>
             <a:pPr marL="127000" indent="0">
               <a:lnSpc>
-                <a:spcPct val="112000"/>
+                <a:spcPct val="114000"/>
               </a:lnSpc>
               <a:spcAft>
                 <a:spcPts val="0"/>
               </a:spcAft>
-              <a:defRPr sz="850"/>
+              <a:defRPr sz="1400"/>
             </a:pPr>
             <a:r>
               <a:rPr b="1">
@@ -4913,8 +4913,8 @@
         </p:nvSpPr>
         <p:spPr>
           <a:xfrm>
-            <a:off x="4325112" y="4096512"/>
-            <a:ext cx="3529584" cy="2487168"/>
+            <a:off x="4306824" y="4096512"/>
+            <a:ext cx="3566160" cy="2514600"/>
           </a:xfrm>
           <a:prstGeom prst="roundRect">
             <a:avLst/>
@@ -4922,7 +4922,7 @@
           <a:solidFill>
             <a:srgbClr val="FFF0F4"/>
           </a:solidFill>
-          <a:ln w="12700">
+          <a:ln w="19050">
             <a:solidFill>
               <a:srgbClr val="FFC2D1"/>
             </a:solidFill>
@@ -4958,8 +4958,8 @@
         </p:nvSpPr>
         <p:spPr>
           <a:xfrm>
-            <a:off x="4398264" y="4151376"/>
-            <a:ext cx="3383280" cy="2377440"/>
+            <a:off x="4379976" y="4151376"/>
+            <a:ext cx="3419856" cy="2404872"/>
           </a:xfrm>
           <a:prstGeom prst="rect">
             <a:avLst/>
@@ -4976,7 +4976,7 @@
               <a:spcAft>
                 <a:spcPts val="200"/>
               </a:spcAft>
-              <a:defRPr sz="980" b="1">
+              <a:defRPr sz="1500" b="1">
                 <a:solidFill>
                   <a:srgbClr val="FF3F6C"/>
                 </a:solidFill>
@@ -4989,12 +4989,12 @@
           <a:p>
             <a:pPr marL="127000" indent="0">
               <a:lnSpc>
-                <a:spcPct val="112000"/>
+                <a:spcPct val="114000"/>
               </a:lnSpc>
               <a:spcAft>
                 <a:spcPts val="200"/>
               </a:spcAft>
-              <a:defRPr sz="850"/>
+              <a:defRPr sz="1400"/>
             </a:pPr>
             <a:r>
               <a:rPr b="1">
@@ -5016,12 +5016,12 @@
           <a:p>
             <a:pPr marL="127000" indent="0">
               <a:lnSpc>
-                <a:spcPct val="112000"/>
+                <a:spcPct val="114000"/>
               </a:lnSpc>
               <a:spcAft>
                 <a:spcPts val="200"/>
               </a:spcAft>
-              <a:defRPr sz="850"/>
+              <a:defRPr sz="1400"/>
             </a:pPr>
             <a:r>
               <a:rPr b="1">
@@ -5043,12 +5043,12 @@
           <a:p>
             <a:pPr marL="127000" indent="0">
               <a:lnSpc>
-                <a:spcPct val="112000"/>
+                <a:spcPct val="114000"/>
               </a:lnSpc>
               <a:spcAft>
                 <a:spcPts val="0"/>
               </a:spcAft>
-              <a:defRPr sz="850"/>
+              <a:defRPr sz="1400"/>
             </a:pPr>
             <a:r>
               <a:rPr b="1">
@@ -5077,8 +5077,8 @@
         </p:nvSpPr>
         <p:spPr>
           <a:xfrm>
-            <a:off x="8010144" y="4096512"/>
-            <a:ext cx="3529584" cy="2487168"/>
+            <a:off x="8019288" y="4096512"/>
+            <a:ext cx="3566160" cy="2514600"/>
           </a:xfrm>
           <a:prstGeom prst="roundRect">
             <a:avLst/>
@@ -5086,7 +5086,7 @@
           <a:solidFill>
             <a:srgbClr val="FFF0F4"/>
           </a:solidFill>
-          <a:ln w="12700">
+          <a:ln w="19050">
             <a:solidFill>
               <a:srgbClr val="FFC2D1"/>
             </a:solidFill>
@@ -5122,8 +5122,8 @@
         </p:nvSpPr>
         <p:spPr>
           <a:xfrm>
-            <a:off x="8083296" y="4151376"/>
-            <a:ext cx="3383280" cy="2377440"/>
+            <a:off x="8092440" y="4151376"/>
+            <a:ext cx="3419856" cy="2404872"/>
           </a:xfrm>
           <a:prstGeom prst="rect">
             <a:avLst/>
@@ -5140,7 +5140,7 @@
               <a:spcAft>
                 <a:spcPts val="200"/>
               </a:spcAft>
-              <a:defRPr sz="980" b="1">
+              <a:defRPr sz="1500" b="1">
                 <a:solidFill>
                   <a:srgbClr val="FF3F6C"/>
                 </a:solidFill>
@@ -5153,12 +5153,12 @@
           <a:p>
             <a:pPr marL="127000" indent="0">
               <a:lnSpc>
-                <a:spcPct val="112000"/>
+                <a:spcPct val="114000"/>
               </a:lnSpc>
               <a:spcAft>
                 <a:spcPts val="200"/>
               </a:spcAft>
-              <a:defRPr sz="850"/>
+              <a:defRPr sz="1400"/>
             </a:pPr>
             <a:r>
               <a:rPr b="1">
@@ -5180,12 +5180,12 @@
           <a:p>
             <a:pPr marL="127000" indent="0">
               <a:lnSpc>
-                <a:spcPct val="112000"/>
+                <a:spcPct val="114000"/>
               </a:lnSpc>
               <a:spcAft>
                 <a:spcPts val="200"/>
               </a:spcAft>
-              <a:defRPr sz="850"/>
+              <a:defRPr sz="1400"/>
             </a:pPr>
             <a:r>
               <a:rPr b="1">
@@ -5207,12 +5207,12 @@
           <a:p>
             <a:pPr marL="127000" indent="0">
               <a:lnSpc>
-                <a:spcPct val="112000"/>
+                <a:spcPct val="114000"/>
               </a:lnSpc>
               <a:spcAft>
                 <a:spcPts val="0"/>
               </a:spcAft>
-              <a:defRPr sz="850"/>
+              <a:defRPr sz="1400"/>
             </a:pPr>
             <a:r>
               <a:rPr b="1">
@@ -5259,8 +5259,8 @@
         </p:nvSpPr>
         <p:spPr>
           <a:xfrm>
-            <a:off x="3124047" y="182880"/>
-            <a:ext cx="5943600" cy="329184"/>
+            <a:off x="2666847" y="164592"/>
+            <a:ext cx="6858000" cy="384048"/>
           </a:xfrm>
           <a:prstGeom prst="roundRect">
             <a:avLst/>
@@ -5297,7 +5297,7 @@
               <a:spcAft>
                 <a:spcPts val="0"/>
               </a:spcAft>
-              <a:defRPr sz="950" b="1">
+              <a:defRPr sz="1400" b="1">
                 <a:solidFill>
                   <a:srgbClr val="FFFFFF"/>
                 </a:solidFill>
@@ -5317,8 +5317,8 @@
         </p:nvSpPr>
         <p:spPr>
           <a:xfrm>
-            <a:off x="640080" y="585216"/>
-            <a:ext cx="9601200" cy="777240"/>
+            <a:off x="594360" y="594360"/>
+            <a:ext cx="9875520" cy="777240"/>
           </a:xfrm>
           <a:prstGeom prst="rect">
             <a:avLst/>
@@ -5335,7 +5335,7 @@
               <a:spcAft>
                 <a:spcPts val="200"/>
               </a:spcAft>
-              <a:defRPr sz="1350" b="1">
+              <a:defRPr sz="1800" b="1">
                 <a:solidFill>
                   <a:srgbClr val="282C3F"/>
                 </a:solidFill>
@@ -5353,7 +5353,7 @@
               <a:spcAft>
                 <a:spcPts val="400"/>
               </a:spcAft>
-              <a:defRPr sz="1000" b="1">
+              <a:defRPr sz="1400" b="1">
                 <a:solidFill>
                   <a:srgbClr val="FF3F6C"/>
                 </a:solidFill>
@@ -5373,7 +5373,7 @@
         </p:nvSpPr>
         <p:spPr>
           <a:xfrm>
-            <a:off x="10424160" y="585216"/>
+            <a:off x="10424160" y="594360"/>
             <a:ext cx="1188720" cy="457200"/>
           </a:xfrm>
           <a:prstGeom prst="rect">
@@ -5388,7 +5388,7 @@
           <a:lstStyle/>
           <a:p>
             <a:pPr algn="r">
-              <a:defRPr sz="2200" b="1">
+              <a:defRPr sz="2400" b="1">
                 <a:solidFill>
                   <a:srgbClr val="FF3F6C"/>
                 </a:solidFill>
@@ -5408,8 +5408,8 @@
         </p:nvSpPr>
         <p:spPr>
           <a:xfrm>
-            <a:off x="640080" y="1444752"/>
-            <a:ext cx="4114800" cy="1371600"/>
+            <a:off x="594360" y="1417320"/>
+            <a:ext cx="4114800" cy="1463040"/>
           </a:xfrm>
           <a:prstGeom prst="roundRect">
             <a:avLst/>
@@ -5417,7 +5417,7 @@
           <a:solidFill>
             <a:srgbClr val="FFFFFF"/>
           </a:solidFill>
-          <a:ln w="12700">
+          <a:ln w="19050">
             <a:solidFill>
               <a:srgbClr val="EAEAEC"/>
             </a:solidFill>
@@ -5453,8 +5453,8 @@
         </p:nvSpPr>
         <p:spPr>
           <a:xfrm>
-            <a:off x="749808" y="1517904"/>
-            <a:ext cx="3895344" cy="1225296"/>
+            <a:off x="704088" y="1490472"/>
+            <a:ext cx="3895344" cy="1316736"/>
           </a:xfrm>
           <a:prstGeom prst="rect">
             <a:avLst/>
@@ -5471,7 +5471,7 @@
               <a:spcAft>
                 <a:spcPts val="200"/>
               </a:spcAft>
-              <a:defRPr sz="1050" b="1">
+              <a:defRPr sz="1500" b="1">
                 <a:solidFill>
                   <a:srgbClr val="FF3F6C"/>
                 </a:solidFill>
@@ -5486,7 +5486,7 @@
               <a:lnSpc>
                 <a:spcPct val="115000"/>
               </a:lnSpc>
-              <a:defRPr sz="900">
+              <a:defRPr sz="1400">
                 <a:solidFill>
                   <a:srgbClr val="282C3F"/>
                 </a:solidFill>
@@ -5506,8 +5506,8 @@
         </p:nvSpPr>
         <p:spPr>
           <a:xfrm>
-            <a:off x="4892040" y="1444752"/>
-            <a:ext cx="6659575" cy="1371600"/>
+            <a:off x="4846320" y="1417320"/>
+            <a:ext cx="6751015" cy="1463040"/>
           </a:xfrm>
           <a:prstGeom prst="roundRect">
             <a:avLst/>
@@ -5515,7 +5515,7 @@
           <a:solidFill>
             <a:srgbClr val="FFFFFF"/>
           </a:solidFill>
-          <a:ln w="12700">
+          <a:ln w="19050">
             <a:solidFill>
               <a:srgbClr val="EAEAEC"/>
             </a:solidFill>
@@ -5551,8 +5551,8 @@
         </p:nvSpPr>
         <p:spPr>
           <a:xfrm>
-            <a:off x="5001768" y="1499616"/>
-            <a:ext cx="6440119" cy="274320"/>
+            <a:off x="4956048" y="1472184"/>
+            <a:ext cx="6531559" cy="320040"/>
           </a:xfrm>
           <a:prstGeom prst="rect">
             <a:avLst/>
@@ -5566,7 +5566,7 @@
           <a:lstStyle/>
           <a:p>
             <a:pPr>
-              <a:defRPr sz="1000" b="1">
+              <a:defRPr sz="1500" b="1">
                 <a:solidFill>
                   <a:srgbClr val="FF3F6C"/>
                 </a:solidFill>
@@ -5586,8 +5586,8 @@
         </p:nvSpPr>
         <p:spPr>
           <a:xfrm>
-            <a:off x="5001768" y="1792224"/>
-            <a:ext cx="1536192" cy="932688"/>
+            <a:off x="4956048" y="1801368"/>
+            <a:ext cx="1572768" cy="987552"/>
           </a:xfrm>
           <a:prstGeom prst="roundRect">
             <a:avLst/>
@@ -5595,7 +5595,7 @@
           <a:solidFill>
             <a:srgbClr val="FFF0F4"/>
           </a:solidFill>
-          <a:ln w="12700">
+          <a:ln w="19050">
             <a:solidFill>
               <a:srgbClr val="FFC2D1"/>
             </a:solidFill>
@@ -5631,8 +5631,8 @@
         </p:nvSpPr>
         <p:spPr>
           <a:xfrm>
-            <a:off x="5038344" y="1810512"/>
-            <a:ext cx="1463040" cy="877824"/>
+            <a:off x="4992624" y="1819656"/>
+            <a:ext cx="1499616" cy="932688"/>
           </a:xfrm>
           <a:prstGeom prst="rect">
             <a:avLst/>
@@ -5649,7 +5649,7 @@
               <a:spcAft>
                 <a:spcPts val="100"/>
               </a:spcAft>
-              <a:defRPr sz="850" b="1">
+              <a:defRPr sz="1400" b="1">
                 <a:solidFill>
                   <a:srgbClr val="FF3F6C"/>
                 </a:solidFill>
@@ -5662,9 +5662,9 @@
           <a:p>
             <a:pPr>
               <a:lnSpc>
-                <a:spcPct val="108000"/>
+                <a:spcPct val="110000"/>
               </a:lnSpc>
-              <a:defRPr sz="750">
+              <a:defRPr sz="1400">
                 <a:solidFill>
                   <a:srgbClr val="282C3F"/>
                 </a:solidFill>
@@ -5684,8 +5684,8 @@
         </p:nvSpPr>
         <p:spPr>
           <a:xfrm>
-            <a:off x="6629400" y="1792224"/>
-            <a:ext cx="1536192" cy="932688"/>
+            <a:off x="6620256" y="1801368"/>
+            <a:ext cx="1572768" cy="987552"/>
           </a:xfrm>
           <a:prstGeom prst="roundRect">
             <a:avLst/>
@@ -5693,7 +5693,7 @@
           <a:solidFill>
             <a:srgbClr val="FFF0F4"/>
           </a:solidFill>
-          <a:ln w="12700">
+          <a:ln w="19050">
             <a:solidFill>
               <a:srgbClr val="FFC2D1"/>
             </a:solidFill>
@@ -5729,8 +5729,8 @@
         </p:nvSpPr>
         <p:spPr>
           <a:xfrm>
-            <a:off x="6665976" y="1810512"/>
-            <a:ext cx="1463040" cy="877824"/>
+            <a:off x="6656832" y="1819656"/>
+            <a:ext cx="1499616" cy="932688"/>
           </a:xfrm>
           <a:prstGeom prst="rect">
             <a:avLst/>
@@ -5747,7 +5747,7 @@
               <a:spcAft>
                 <a:spcPts val="100"/>
               </a:spcAft>
-              <a:defRPr sz="850" b="1">
+              <a:defRPr sz="1400" b="1">
                 <a:solidFill>
                   <a:srgbClr val="FF3F6C"/>
                 </a:solidFill>
@@ -5760,9 +5760,9 @@
           <a:p>
             <a:pPr>
               <a:lnSpc>
-                <a:spcPct val="108000"/>
+                <a:spcPct val="110000"/>
               </a:lnSpc>
-              <a:defRPr sz="750">
+              <a:defRPr sz="1400">
                 <a:solidFill>
                   <a:srgbClr val="282C3F"/>
                 </a:solidFill>
@@ -5782,8 +5782,8 @@
         </p:nvSpPr>
         <p:spPr>
           <a:xfrm>
-            <a:off x="8257032" y="1792224"/>
-            <a:ext cx="1536192" cy="932688"/>
+            <a:off x="8284464" y="1801368"/>
+            <a:ext cx="1572768" cy="987552"/>
           </a:xfrm>
           <a:prstGeom prst="roundRect">
             <a:avLst/>
@@ -5791,7 +5791,7 @@
           <a:solidFill>
             <a:srgbClr val="FFF0F4"/>
           </a:solidFill>
-          <a:ln w="12700">
+          <a:ln w="19050">
             <a:solidFill>
               <a:srgbClr val="FFC2D1"/>
             </a:solidFill>
@@ -5827,8 +5827,8 @@
         </p:nvSpPr>
         <p:spPr>
           <a:xfrm>
-            <a:off x="8293608" y="1810512"/>
-            <a:ext cx="1463040" cy="877824"/>
+            <a:off x="8321040" y="1819656"/>
+            <a:ext cx="1499616" cy="932688"/>
           </a:xfrm>
           <a:prstGeom prst="rect">
             <a:avLst/>
@@ -5845,7 +5845,7 @@
               <a:spcAft>
                 <a:spcPts val="100"/>
               </a:spcAft>
-              <a:defRPr sz="850" b="1">
+              <a:defRPr sz="1400" b="1">
                 <a:solidFill>
                   <a:srgbClr val="FF3F6C"/>
                 </a:solidFill>
@@ -5858,9 +5858,9 @@
           <a:p>
             <a:pPr>
               <a:lnSpc>
-                <a:spcPct val="108000"/>
+                <a:spcPct val="110000"/>
               </a:lnSpc>
-              <a:defRPr sz="750">
+              <a:defRPr sz="1400">
                 <a:solidFill>
                   <a:srgbClr val="282C3F"/>
                 </a:solidFill>
@@ -5880,8 +5880,8 @@
         </p:nvSpPr>
         <p:spPr>
           <a:xfrm>
-            <a:off x="9884664" y="1792224"/>
-            <a:ext cx="1536192" cy="932688"/>
+            <a:off x="9948672" y="1801368"/>
+            <a:ext cx="1572768" cy="987552"/>
           </a:xfrm>
           <a:prstGeom prst="roundRect">
             <a:avLst/>
@@ -5889,7 +5889,7 @@
           <a:solidFill>
             <a:srgbClr val="FFF0F4"/>
           </a:solidFill>
-          <a:ln w="12700">
+          <a:ln w="19050">
             <a:solidFill>
               <a:srgbClr val="FFC2D1"/>
             </a:solidFill>
@@ -5925,8 +5925,8 @@
         </p:nvSpPr>
         <p:spPr>
           <a:xfrm>
-            <a:off x="9921240" y="1810512"/>
-            <a:ext cx="1463040" cy="877824"/>
+            <a:off x="9985248" y="1819656"/>
+            <a:ext cx="1499616" cy="932688"/>
           </a:xfrm>
           <a:prstGeom prst="rect">
             <a:avLst/>
@@ -5943,7 +5943,7 @@
               <a:spcAft>
                 <a:spcPts val="100"/>
               </a:spcAft>
-              <a:defRPr sz="850" b="1">
+              <a:defRPr sz="1400" b="1">
                 <a:solidFill>
                   <a:srgbClr val="FF3F6C"/>
                 </a:solidFill>
@@ -5956,9 +5956,9 @@
           <a:p>
             <a:pPr>
               <a:lnSpc>
-                <a:spcPct val="108000"/>
+                <a:spcPct val="110000"/>
               </a:lnSpc>
-              <a:defRPr sz="750">
+              <a:defRPr sz="1400">
                 <a:solidFill>
                   <a:srgbClr val="282C3F"/>
                 </a:solidFill>
@@ -5978,8 +5978,8 @@
         </p:nvSpPr>
         <p:spPr>
           <a:xfrm>
-            <a:off x="640080" y="2953512"/>
-            <a:ext cx="5303520" cy="3630168"/>
+            <a:off x="594360" y="3017520"/>
+            <a:ext cx="5303520" cy="3593592"/>
           </a:xfrm>
           <a:prstGeom prst="roundRect">
             <a:avLst/>
@@ -5987,7 +5987,7 @@
           <a:solidFill>
             <a:srgbClr val="FFFFFF"/>
           </a:solidFill>
-          <a:ln w="12700">
+          <a:ln w="19050">
             <a:solidFill>
               <a:srgbClr val="EAEAEC"/>
             </a:solidFill>
@@ -6023,7 +6023,7 @@
         </p:nvSpPr>
         <p:spPr>
           <a:xfrm>
-            <a:off x="749808" y="3044952"/>
+            <a:off x="704088" y="3090672"/>
             <a:ext cx="5084064" cy="3447288"/>
           </a:xfrm>
           <a:prstGeom prst="rect">
@@ -6032,7 +6032,7 @@
           <a:noFill/>
         </p:spPr>
         <p:txBody>
-          <a:bodyPr wrap="square" lIns="73152" rIns="73152">
+          <a:bodyPr wrap="square" lIns="54864" rIns="54864">
             <a:spAutoFit/>
           </a:bodyPr>
           <a:lstStyle/>
@@ -6041,7 +6041,7 @@
               <a:spcAft>
                 <a:spcPts val="400"/>
               </a:spcAft>
-              <a:defRPr sz="1050" b="1">
+              <a:defRPr sz="1500" b="1">
                 <a:solidFill>
                   <a:srgbClr val="FF3F6C"/>
                 </a:solidFill>
@@ -6062,7 +6062,7 @@
               <a:spcAft>
                 <a:spcPts val="200"/>
               </a:spcAft>
-              <a:defRPr sz="880"/>
+              <a:defRPr sz="1400"/>
             </a:pPr>
             <a:r>
               <a:rPr b="1">
@@ -6092,7 +6092,7 @@
               <a:spcAft>
                 <a:spcPts val="200"/>
               </a:spcAft>
-              <a:defRPr sz="880"/>
+              <a:defRPr sz="1400"/>
             </a:pPr>
             <a:r>
               <a:rPr b="1">
@@ -6122,7 +6122,7 @@
               <a:spcAft>
                 <a:spcPts val="200"/>
               </a:spcAft>
-              <a:defRPr sz="880"/>
+              <a:defRPr sz="1400"/>
             </a:pPr>
             <a:r>
               <a:rPr b="1">
@@ -6152,7 +6152,7 @@
               <a:spcAft>
                 <a:spcPts val="200"/>
               </a:spcAft>
-              <a:defRPr sz="880"/>
+              <a:defRPr sz="1400"/>
             </a:pPr>
             <a:r>
               <a:rPr b="1">
@@ -6181,8 +6181,8 @@
         </p:nvSpPr>
         <p:spPr>
           <a:xfrm>
-            <a:off x="6080760" y="2953512"/>
-            <a:ext cx="5470855" cy="1149096"/>
+            <a:off x="6035040" y="3017520"/>
+            <a:ext cx="5562295" cy="1136904"/>
           </a:xfrm>
           <a:prstGeom prst="roundRect">
             <a:avLst/>
@@ -6190,7 +6190,7 @@
           <a:solidFill>
             <a:srgbClr val="FFF0F4"/>
           </a:solidFill>
-          <a:ln w="12700">
+          <a:ln w="19050">
             <a:solidFill>
               <a:srgbClr val="FFC2D1"/>
             </a:solidFill>
@@ -6226,8 +6226,8 @@
         </p:nvSpPr>
         <p:spPr>
           <a:xfrm>
-            <a:off x="6190488" y="3008376"/>
-            <a:ext cx="5251399" cy="1039368"/>
+            <a:off x="6144768" y="3072384"/>
+            <a:ext cx="5342839" cy="1027176"/>
           </a:xfrm>
           <a:prstGeom prst="rect">
             <a:avLst/>
@@ -6244,7 +6244,7 @@
               <a:spcAft>
                 <a:spcPts val="200"/>
               </a:spcAft>
-              <a:defRPr sz="1000" b="1">
+              <a:defRPr sz="1500" b="1">
                 <a:solidFill>
                   <a:srgbClr val="FF3F6C"/>
                 </a:solidFill>
@@ -6259,7 +6259,7 @@
               <a:lnSpc>
                 <a:spcPct val="112000"/>
               </a:lnSpc>
-              <a:defRPr sz="880">
+              <a:defRPr sz="1400">
                 <a:solidFill>
                   <a:srgbClr val="282C3F"/>
                 </a:solidFill>
@@ -6279,8 +6279,8 @@
         </p:nvSpPr>
         <p:spPr>
           <a:xfrm>
-            <a:off x="6080760" y="4194048"/>
-            <a:ext cx="5470855" cy="1149096"/>
+            <a:off x="6035040" y="4245864"/>
+            <a:ext cx="5562295" cy="1136904"/>
           </a:xfrm>
           <a:prstGeom prst="roundRect">
             <a:avLst/>
@@ -6288,7 +6288,7 @@
           <a:solidFill>
             <a:srgbClr val="FFF0F4"/>
           </a:solidFill>
-          <a:ln w="12700">
+          <a:ln w="19050">
             <a:solidFill>
               <a:srgbClr val="FFC2D1"/>
             </a:solidFill>
@@ -6324,8 +6324,8 @@
         </p:nvSpPr>
         <p:spPr>
           <a:xfrm>
-            <a:off x="6190488" y="4248912"/>
-            <a:ext cx="5251399" cy="1039368"/>
+            <a:off x="6144768" y="4300728"/>
+            <a:ext cx="5342839" cy="1027176"/>
           </a:xfrm>
           <a:prstGeom prst="rect">
             <a:avLst/>
@@ -6342,7 +6342,7 @@
               <a:spcAft>
                 <a:spcPts val="200"/>
               </a:spcAft>
-              <a:defRPr sz="1000" b="1">
+              <a:defRPr sz="1500" b="1">
                 <a:solidFill>
                   <a:srgbClr val="FF3F6C"/>
                 </a:solidFill>
@@ -6357,7 +6357,7 @@
               <a:lnSpc>
                 <a:spcPct val="112000"/>
               </a:lnSpc>
-              <a:defRPr sz="880">
+              <a:defRPr sz="1400">
                 <a:solidFill>
                   <a:srgbClr val="282C3F"/>
                 </a:solidFill>
@@ -6377,8 +6377,8 @@
         </p:nvSpPr>
         <p:spPr>
           <a:xfrm>
-            <a:off x="6080760" y="5434584"/>
-            <a:ext cx="5470855" cy="1149096"/>
+            <a:off x="6035040" y="5474208"/>
+            <a:ext cx="5562295" cy="1136904"/>
           </a:xfrm>
           <a:prstGeom prst="roundRect">
             <a:avLst/>
@@ -6386,7 +6386,7 @@
           <a:solidFill>
             <a:srgbClr val="FFF0F4"/>
           </a:solidFill>
-          <a:ln w="12700">
+          <a:ln w="19050">
             <a:solidFill>
               <a:srgbClr val="FFC2D1"/>
             </a:solidFill>
@@ -6422,8 +6422,8 @@
         </p:nvSpPr>
         <p:spPr>
           <a:xfrm>
-            <a:off x="6190488" y="5489448"/>
-            <a:ext cx="5251399" cy="1039368"/>
+            <a:off x="6144768" y="5529072"/>
+            <a:ext cx="5342839" cy="1027176"/>
           </a:xfrm>
           <a:prstGeom prst="rect">
             <a:avLst/>
@@ -6440,7 +6440,7 @@
               <a:spcAft>
                 <a:spcPts val="200"/>
               </a:spcAft>
-              <a:defRPr sz="1000" b="1">
+              <a:defRPr sz="1500" b="1">
                 <a:solidFill>
                   <a:srgbClr val="FF3F6C"/>
                 </a:solidFill>
@@ -6455,7 +6455,7 @@
               <a:lnSpc>
                 <a:spcPct val="112000"/>
               </a:lnSpc>
-              <a:defRPr sz="880">
+              <a:defRPr sz="1400">
                 <a:solidFill>
                   <a:srgbClr val="282C3F"/>
                 </a:solidFill>
@@ -6493,8 +6493,8 @@
         </p:nvSpPr>
         <p:spPr>
           <a:xfrm>
-            <a:off x="3124047" y="182880"/>
-            <a:ext cx="5943600" cy="329184"/>
+            <a:off x="2666847" y="164592"/>
+            <a:ext cx="6858000" cy="384048"/>
           </a:xfrm>
           <a:prstGeom prst="roundRect">
             <a:avLst/>
@@ -6531,7 +6531,7 @@
               <a:spcAft>
                 <a:spcPts val="0"/>
               </a:spcAft>
-              <a:defRPr sz="950" b="1">
+              <a:defRPr sz="1400" b="1">
                 <a:solidFill>
                   <a:srgbClr val="FFFFFF"/>
                 </a:solidFill>
@@ -6551,8 +6551,8 @@
         </p:nvSpPr>
         <p:spPr>
           <a:xfrm>
-            <a:off x="640080" y="585216"/>
-            <a:ext cx="9601200" cy="777240"/>
+            <a:off x="594360" y="594360"/>
+            <a:ext cx="9875520" cy="777240"/>
           </a:xfrm>
           <a:prstGeom prst="rect">
             <a:avLst/>
@@ -6569,7 +6569,7 @@
               <a:spcAft>
                 <a:spcPts val="200"/>
               </a:spcAft>
-              <a:defRPr sz="1350" b="1">
+              <a:defRPr sz="1800" b="1">
                 <a:solidFill>
                   <a:srgbClr val="282C3F"/>
                 </a:solidFill>
@@ -6587,7 +6587,7 @@
               <a:spcAft>
                 <a:spcPts val="400"/>
               </a:spcAft>
-              <a:defRPr sz="1000" b="1">
+              <a:defRPr sz="1400" b="1">
                 <a:solidFill>
                   <a:srgbClr val="FF3F6C"/>
                 </a:solidFill>
@@ -6607,7 +6607,7 @@
         </p:nvSpPr>
         <p:spPr>
           <a:xfrm>
-            <a:off x="10424160" y="585216"/>
+            <a:off x="10424160" y="594360"/>
             <a:ext cx="1188720" cy="457200"/>
           </a:xfrm>
           <a:prstGeom prst="rect">
@@ -6622,7 +6622,7 @@
           <a:lstStyle/>
           <a:p>
             <a:pPr algn="r">
-              <a:defRPr sz="2200" b="1">
+              <a:defRPr sz="2400" b="1">
                 <a:solidFill>
                   <a:srgbClr val="FF3F6C"/>
                 </a:solidFill>
@@ -6642,8 +6642,8 @@
         </p:nvSpPr>
         <p:spPr>
           <a:xfrm>
-            <a:off x="640080" y="1444752"/>
-            <a:ext cx="10911535" cy="1188720"/>
+            <a:off x="594360" y="1417320"/>
+            <a:ext cx="11002975" cy="1280160"/>
           </a:xfrm>
           <a:prstGeom prst="roundRect">
             <a:avLst/>
@@ -6651,7 +6651,7 @@
           <a:solidFill>
             <a:srgbClr val="FFF0F4"/>
           </a:solidFill>
-          <a:ln w="12700">
+          <a:ln w="19050">
             <a:solidFill>
               <a:srgbClr val="FFC2D1"/>
             </a:solidFill>
@@ -6687,8 +6687,8 @@
         </p:nvSpPr>
         <p:spPr>
           <a:xfrm>
-            <a:off x="777240" y="1517904"/>
-            <a:ext cx="10637215" cy="1042416"/>
+            <a:off x="704088" y="1490472"/>
+            <a:ext cx="10783519" cy="1133856"/>
           </a:xfrm>
           <a:prstGeom prst="rect">
             <a:avLst/>
@@ -6696,7 +6696,7 @@
           <a:noFill/>
         </p:spPr>
         <p:txBody>
-          <a:bodyPr wrap="square" lIns="73152" rIns="73152">
+          <a:bodyPr wrap="square" lIns="54864" rIns="54864">
             <a:spAutoFit/>
           </a:bodyPr>
           <a:lstStyle/>
@@ -6705,7 +6705,7 @@
               <a:spcAft>
                 <a:spcPts val="200"/>
               </a:spcAft>
-              <a:defRPr sz="1050" b="1">
+              <a:defRPr sz="1500" b="1">
                 <a:solidFill>
                   <a:srgbClr val="FF3F6C"/>
                 </a:solidFill>
@@ -6720,7 +6720,7 @@
               <a:lnSpc>
                 <a:spcPct val="115000"/>
               </a:lnSpc>
-              <a:defRPr sz="900"/>
+              <a:defRPr sz="1400"/>
             </a:pPr>
             <a:r>
               <a:rPr>
@@ -6757,8 +6757,8 @@
         </p:nvSpPr>
         <p:spPr>
           <a:xfrm>
-            <a:off x="640080" y="2743200"/>
-            <a:ext cx="3529584" cy="2331720"/>
+            <a:off x="594360" y="2807208"/>
+            <a:ext cx="3566160" cy="2331720"/>
           </a:xfrm>
           <a:prstGeom prst="roundRect">
             <a:avLst/>
@@ -6766,7 +6766,7 @@
           <a:solidFill>
             <a:srgbClr val="FFFFFF"/>
           </a:solidFill>
-          <a:ln w="12700">
+          <a:ln w="19050">
             <a:solidFill>
               <a:srgbClr val="EAEAEC"/>
             </a:solidFill>
@@ -6802,8 +6802,8 @@
         </p:nvSpPr>
         <p:spPr>
           <a:xfrm>
-            <a:off x="713232" y="2798064"/>
-            <a:ext cx="3383280" cy="2221992"/>
+            <a:off x="667512" y="2862072"/>
+            <a:ext cx="3419856" cy="2221992"/>
           </a:xfrm>
           <a:prstGeom prst="rect">
             <a:avLst/>
@@ -6820,7 +6820,7 @@
               <a:spcAft>
                 <a:spcPts val="300"/>
               </a:spcAft>
-              <a:defRPr sz="950" b="1">
+              <a:defRPr sz="1500" b="1">
                 <a:solidFill>
                   <a:srgbClr val="FF3F6C"/>
                 </a:solidFill>
@@ -6835,7 +6835,7 @@
               <a:lnSpc>
                 <a:spcPct val="114000"/>
               </a:lnSpc>
-              <a:defRPr sz="880">
+              <a:defRPr sz="1400">
                 <a:solidFill>
                   <a:srgbClr val="282C3F"/>
                 </a:solidFill>
@@ -6855,8 +6855,8 @@
         </p:nvSpPr>
         <p:spPr>
           <a:xfrm>
-            <a:off x="4325112" y="2743200"/>
-            <a:ext cx="3529584" cy="2331720"/>
+            <a:off x="4306824" y="2807208"/>
+            <a:ext cx="3566160" cy="2331720"/>
           </a:xfrm>
           <a:prstGeom prst="roundRect">
             <a:avLst/>
@@ -6864,7 +6864,7 @@
           <a:solidFill>
             <a:srgbClr val="FFFFFF"/>
           </a:solidFill>
-          <a:ln w="12700">
+          <a:ln w="19050">
             <a:solidFill>
               <a:srgbClr val="EAEAEC"/>
             </a:solidFill>
@@ -6900,8 +6900,8 @@
         </p:nvSpPr>
         <p:spPr>
           <a:xfrm>
-            <a:off x="4398264" y="2798064"/>
-            <a:ext cx="3383280" cy="2221992"/>
+            <a:off x="4379976" y="2862072"/>
+            <a:ext cx="3419856" cy="2221992"/>
           </a:xfrm>
           <a:prstGeom prst="rect">
             <a:avLst/>
@@ -6918,7 +6918,7 @@
               <a:spcAft>
                 <a:spcPts val="300"/>
               </a:spcAft>
-              <a:defRPr sz="950" b="1">
+              <a:defRPr sz="1500" b="1">
                 <a:solidFill>
                   <a:srgbClr val="FF3F6C"/>
                 </a:solidFill>
@@ -6933,7 +6933,7 @@
               <a:lnSpc>
                 <a:spcPct val="114000"/>
               </a:lnSpc>
-              <a:defRPr sz="880">
+              <a:defRPr sz="1400">
                 <a:solidFill>
                   <a:srgbClr val="282C3F"/>
                 </a:solidFill>
@@ -6953,8 +6953,8 @@
         </p:nvSpPr>
         <p:spPr>
           <a:xfrm>
-            <a:off x="8010144" y="2743200"/>
-            <a:ext cx="3529584" cy="2331720"/>
+            <a:off x="8019288" y="2807208"/>
+            <a:ext cx="3566160" cy="2331720"/>
           </a:xfrm>
           <a:prstGeom prst="roundRect">
             <a:avLst/>
@@ -6962,7 +6962,7 @@
           <a:solidFill>
             <a:srgbClr val="FFFFFF"/>
           </a:solidFill>
-          <a:ln w="12700">
+          <a:ln w="19050">
             <a:solidFill>
               <a:srgbClr val="EAEAEC"/>
             </a:solidFill>
@@ -6998,8 +6998,8 @@
         </p:nvSpPr>
         <p:spPr>
           <a:xfrm>
-            <a:off x="8083296" y="2798064"/>
-            <a:ext cx="3383280" cy="2221992"/>
+            <a:off x="8092440" y="2862072"/>
+            <a:ext cx="3419856" cy="2221992"/>
           </a:xfrm>
           <a:prstGeom prst="rect">
             <a:avLst/>
@@ -7016,7 +7016,7 @@
               <a:spcAft>
                 <a:spcPts val="300"/>
               </a:spcAft>
-              <a:defRPr sz="950" b="1">
+              <a:defRPr sz="1500" b="1">
                 <a:solidFill>
                   <a:srgbClr val="FF3F6C"/>
                 </a:solidFill>
@@ -7031,7 +7031,7 @@
               <a:lnSpc>
                 <a:spcPct val="114000"/>
               </a:lnSpc>
-              <a:defRPr sz="880">
+              <a:defRPr sz="1400">
                 <a:solidFill>
                   <a:srgbClr val="282C3F"/>
                 </a:solidFill>
@@ -7051,8 +7051,8 @@
         </p:nvSpPr>
         <p:spPr>
           <a:xfrm>
-            <a:off x="640080" y="5184648"/>
-            <a:ext cx="10911535" cy="1399032"/>
+            <a:off x="594360" y="5248656"/>
+            <a:ext cx="11002975" cy="1362456"/>
           </a:xfrm>
           <a:prstGeom prst="roundRect">
             <a:avLst/>
@@ -7060,7 +7060,7 @@
           <a:solidFill>
             <a:srgbClr val="FFFFFF"/>
           </a:solidFill>
-          <a:ln w="12700">
+          <a:ln w="19050">
             <a:solidFill>
               <a:srgbClr val="EAEAEC"/>
             </a:solidFill>
@@ -7096,8 +7096,8 @@
         </p:nvSpPr>
         <p:spPr>
           <a:xfrm>
-            <a:off x="749808" y="5239512"/>
-            <a:ext cx="10689336" cy="1289304"/>
+            <a:off x="704088" y="5303520"/>
+            <a:ext cx="10783519" cy="1252728"/>
           </a:xfrm>
           <a:prstGeom prst="rect">
             <a:avLst/>
@@ -7114,7 +7114,7 @@
               <a:spcAft>
                 <a:spcPts val="200"/>
               </a:spcAft>
-              <a:defRPr sz="1000" b="1">
+              <a:defRPr sz="1500" b="1">
                 <a:solidFill>
                   <a:srgbClr val="FF3F6C"/>
                 </a:solidFill>
@@ -7129,7 +7129,7 @@
               <a:lnSpc>
                 <a:spcPct val="112000"/>
               </a:lnSpc>
-              <a:defRPr sz="850"/>
+              <a:defRPr sz="1400"/>
             </a:pPr>
             <a:r>
               <a:rPr b="1">
@@ -7185,7 +7185,7 @@
               <a:spcBef>
                 <a:spcPts val="200"/>
               </a:spcBef>
-              <a:defRPr sz="850"/>
+              <a:defRPr sz="1400"/>
             </a:pPr>
             <a:r>
               <a:rPr b="1">
@@ -7232,8 +7232,8 @@
         </p:nvSpPr>
         <p:spPr>
           <a:xfrm>
-            <a:off x="3124047" y="182880"/>
-            <a:ext cx="5943600" cy="329184"/>
+            <a:off x="2666847" y="164592"/>
+            <a:ext cx="6858000" cy="384048"/>
           </a:xfrm>
           <a:prstGeom prst="roundRect">
             <a:avLst/>
@@ -7270,7 +7270,7 @@
               <a:spcAft>
                 <a:spcPts val="0"/>
               </a:spcAft>
-              <a:defRPr sz="950" b="1">
+              <a:defRPr sz="1400" b="1">
                 <a:solidFill>
                   <a:srgbClr val="FFFFFF"/>
                 </a:solidFill>
@@ -7290,8 +7290,8 @@
         </p:nvSpPr>
         <p:spPr>
           <a:xfrm>
-            <a:off x="640080" y="585216"/>
-            <a:ext cx="9601200" cy="777240"/>
+            <a:off x="594360" y="594360"/>
+            <a:ext cx="9875520" cy="777240"/>
           </a:xfrm>
           <a:prstGeom prst="rect">
             <a:avLst/>
@@ -7308,7 +7308,7 @@
               <a:spcAft>
                 <a:spcPts val="200"/>
               </a:spcAft>
-              <a:defRPr sz="1350" b="1">
+              <a:defRPr sz="1800" b="1">
                 <a:solidFill>
                   <a:srgbClr val="282C3F"/>
                 </a:solidFill>
@@ -7326,7 +7326,7 @@
               <a:spcAft>
                 <a:spcPts val="400"/>
               </a:spcAft>
-              <a:defRPr sz="1000" b="1">
+              <a:defRPr sz="1400" b="1">
                 <a:solidFill>
                   <a:srgbClr val="FF3F6C"/>
                 </a:solidFill>
@@ -7346,7 +7346,7 @@
         </p:nvSpPr>
         <p:spPr>
           <a:xfrm>
-            <a:off x="10424160" y="585216"/>
+            <a:off x="10424160" y="594360"/>
             <a:ext cx="1188720" cy="457200"/>
           </a:xfrm>
           <a:prstGeom prst="rect">
@@ -7361,7 +7361,7 @@
           <a:lstStyle/>
           <a:p>
             <a:pPr algn="r">
-              <a:defRPr sz="2200" b="1">
+              <a:defRPr sz="2400" b="1">
                 <a:solidFill>
                   <a:srgbClr val="FF3F6C"/>
                 </a:solidFill>
@@ -7381,8 +7381,8 @@
         </p:nvSpPr>
         <p:spPr>
           <a:xfrm>
-            <a:off x="640080" y="1444752"/>
-            <a:ext cx="5358384" cy="2487168"/>
+            <a:off x="594360" y="1417320"/>
+            <a:ext cx="5394960" cy="2514600"/>
           </a:xfrm>
           <a:prstGeom prst="roundRect">
             <a:avLst/>
@@ -7390,7 +7390,7 @@
           <a:solidFill>
             <a:srgbClr val="FFFFFF"/>
           </a:solidFill>
-          <a:ln w="12700">
+          <a:ln w="19050">
             <a:solidFill>
               <a:srgbClr val="EAEAEC"/>
             </a:solidFill>
@@ -7426,8 +7426,8 @@
         </p:nvSpPr>
         <p:spPr>
           <a:xfrm>
-            <a:off x="749808" y="1517904"/>
-            <a:ext cx="5138928" cy="2340864"/>
+            <a:off x="704088" y="1490472"/>
+            <a:ext cx="5175504" cy="2368296"/>
           </a:xfrm>
           <a:prstGeom prst="rect">
             <a:avLst/>
@@ -7435,7 +7435,7 @@
           <a:noFill/>
         </p:spPr>
         <p:txBody>
-          <a:bodyPr wrap="square" lIns="73152" rIns="73152">
+          <a:bodyPr wrap="square" lIns="54864" rIns="54864">
             <a:spAutoFit/>
           </a:bodyPr>
           <a:lstStyle/>
@@ -7444,7 +7444,7 @@
               <a:spcAft>
                 <a:spcPts val="300"/>
               </a:spcAft>
-              <a:defRPr sz="1050" b="1">
+              <a:defRPr sz="1500" b="1">
                 <a:solidFill>
                   <a:srgbClr val="FF3F6C"/>
                 </a:solidFill>
@@ -7465,7 +7465,7 @@
               <a:spcAft>
                 <a:spcPts val="200"/>
               </a:spcAft>
-              <a:defRPr sz="880"/>
+              <a:defRPr sz="1400"/>
             </a:pPr>
             <a:r>
               <a:rPr b="1">
@@ -7495,7 +7495,7 @@
               <a:spcAft>
                 <a:spcPts val="200"/>
               </a:spcAft>
-              <a:defRPr sz="880"/>
+              <a:defRPr sz="1400"/>
             </a:pPr>
             <a:r>
               <a:rPr b="1">
@@ -7525,7 +7525,7 @@
               <a:spcAft>
                 <a:spcPts val="200"/>
               </a:spcAft>
-              <a:defRPr sz="880"/>
+              <a:defRPr sz="1400"/>
             </a:pPr>
             <a:r>
               <a:rPr b="1">
@@ -7554,8 +7554,8 @@
         </p:nvSpPr>
         <p:spPr>
           <a:xfrm>
-            <a:off x="6181344" y="1444752"/>
-            <a:ext cx="5358384" cy="2487168"/>
+            <a:off x="6199632" y="1417320"/>
+            <a:ext cx="5394960" cy="2514600"/>
           </a:xfrm>
           <a:prstGeom prst="roundRect">
             <a:avLst/>
@@ -7563,7 +7563,7 @@
           <a:solidFill>
             <a:srgbClr val="FFFFFF"/>
           </a:solidFill>
-          <a:ln w="12700">
+          <a:ln w="19050">
             <a:solidFill>
               <a:srgbClr val="EAEAEC"/>
             </a:solidFill>
@@ -7599,8 +7599,8 @@
         </p:nvSpPr>
         <p:spPr>
           <a:xfrm>
-            <a:off x="6291072" y="1517904"/>
-            <a:ext cx="5138928" cy="2340864"/>
+            <a:off x="6309360" y="1490472"/>
+            <a:ext cx="5175504" cy="2368296"/>
           </a:xfrm>
           <a:prstGeom prst="rect">
             <a:avLst/>
@@ -7608,7 +7608,7 @@
           <a:noFill/>
         </p:spPr>
         <p:txBody>
-          <a:bodyPr wrap="square" lIns="73152" rIns="73152">
+          <a:bodyPr wrap="square" lIns="54864" rIns="54864">
             <a:spAutoFit/>
           </a:bodyPr>
           <a:lstStyle/>
@@ -7617,7 +7617,7 @@
               <a:spcAft>
                 <a:spcPts val="300"/>
               </a:spcAft>
-              <a:defRPr sz="1050" b="1">
+              <a:defRPr sz="1500" b="1">
                 <a:solidFill>
                   <a:srgbClr val="FF3F6C"/>
                 </a:solidFill>
@@ -7638,7 +7638,7 @@
               <a:spcAft>
                 <a:spcPts val="200"/>
               </a:spcAft>
-              <a:defRPr sz="880"/>
+              <a:defRPr sz="1400"/>
             </a:pPr>
             <a:r>
               <a:rPr b="1">
@@ -7668,7 +7668,7 @@
               <a:spcAft>
                 <a:spcPts val="200"/>
               </a:spcAft>
-              <a:defRPr sz="880"/>
+              <a:defRPr sz="1400"/>
             </a:pPr>
             <a:r>
               <a:rPr b="1">
@@ -7698,7 +7698,7 @@
               <a:spcAft>
                 <a:spcPts val="200"/>
               </a:spcAft>
-              <a:defRPr sz="880"/>
+              <a:defRPr sz="1400"/>
             </a:pPr>
             <a:r>
               <a:rPr b="1">
@@ -7727,8 +7727,8 @@
         </p:nvSpPr>
         <p:spPr>
           <a:xfrm>
-            <a:off x="640080" y="4096512"/>
-            <a:ext cx="5358384" cy="2487168"/>
+            <a:off x="594360" y="4096512"/>
+            <a:ext cx="5394960" cy="2514600"/>
           </a:xfrm>
           <a:prstGeom prst="roundRect">
             <a:avLst/>
@@ -7736,7 +7736,7 @@
           <a:solidFill>
             <a:srgbClr val="FFFFFF"/>
           </a:solidFill>
-          <a:ln w="12700">
+          <a:ln w="19050">
             <a:solidFill>
               <a:srgbClr val="EAEAEC"/>
             </a:solidFill>
@@ -7772,8 +7772,8 @@
         </p:nvSpPr>
         <p:spPr>
           <a:xfrm>
-            <a:off x="749808" y="4169664"/>
-            <a:ext cx="5138928" cy="2340864"/>
+            <a:off x="704088" y="4169664"/>
+            <a:ext cx="5175504" cy="2368296"/>
           </a:xfrm>
           <a:prstGeom prst="rect">
             <a:avLst/>
@@ -7781,7 +7781,7 @@
           <a:noFill/>
         </p:spPr>
         <p:txBody>
-          <a:bodyPr wrap="square" lIns="73152" rIns="73152">
+          <a:bodyPr wrap="square" lIns="54864" rIns="54864">
             <a:spAutoFit/>
           </a:bodyPr>
           <a:lstStyle/>
@@ -7790,7 +7790,7 @@
               <a:spcAft>
                 <a:spcPts val="300"/>
               </a:spcAft>
-              <a:defRPr sz="1050" b="1">
+              <a:defRPr sz="1500" b="1">
                 <a:solidFill>
                   <a:srgbClr val="FF3F6C"/>
                 </a:solidFill>
@@ -7811,7 +7811,7 @@
               <a:spcAft>
                 <a:spcPts val="200"/>
               </a:spcAft>
-              <a:defRPr sz="880"/>
+              <a:defRPr sz="1400"/>
             </a:pPr>
             <a:r>
               <a:rPr b="1">
@@ -7841,7 +7841,7 @@
               <a:spcAft>
                 <a:spcPts val="200"/>
               </a:spcAft>
-              <a:defRPr sz="880"/>
+              <a:defRPr sz="1400"/>
             </a:pPr>
             <a:r>
               <a:rPr b="1">
@@ -7871,7 +7871,7 @@
               <a:spcAft>
                 <a:spcPts val="200"/>
               </a:spcAft>
-              <a:defRPr sz="880"/>
+              <a:defRPr sz="1400"/>
             </a:pPr>
             <a:r>
               <a:rPr b="1">
@@ -7900,8 +7900,8 @@
         </p:nvSpPr>
         <p:spPr>
           <a:xfrm>
-            <a:off x="6181344" y="4096512"/>
-            <a:ext cx="5358384" cy="2487168"/>
+            <a:off x="6199632" y="4096512"/>
+            <a:ext cx="5394960" cy="2514600"/>
           </a:xfrm>
           <a:prstGeom prst="roundRect">
             <a:avLst/>
@@ -7909,7 +7909,7 @@
           <a:solidFill>
             <a:srgbClr val="FFFFFF"/>
           </a:solidFill>
-          <a:ln w="12700">
+          <a:ln w="19050">
             <a:solidFill>
               <a:srgbClr val="EAEAEC"/>
             </a:solidFill>
@@ -7945,8 +7945,8 @@
         </p:nvSpPr>
         <p:spPr>
           <a:xfrm>
-            <a:off x="6291072" y="4169664"/>
-            <a:ext cx="5138928" cy="2340864"/>
+            <a:off x="6309360" y="4169664"/>
+            <a:ext cx="5175504" cy="2368296"/>
           </a:xfrm>
           <a:prstGeom prst="rect">
             <a:avLst/>
@@ -7954,7 +7954,7 @@
           <a:noFill/>
         </p:spPr>
         <p:txBody>
-          <a:bodyPr wrap="square" lIns="73152" rIns="73152">
+          <a:bodyPr wrap="square" lIns="54864" rIns="54864">
             <a:spAutoFit/>
           </a:bodyPr>
           <a:lstStyle/>
@@ -7963,7 +7963,7 @@
               <a:spcAft>
                 <a:spcPts val="300"/>
               </a:spcAft>
-              <a:defRPr sz="1050" b="1">
+              <a:defRPr sz="1500" b="1">
                 <a:solidFill>
                   <a:srgbClr val="FF3F6C"/>
                 </a:solidFill>
@@ -7984,7 +7984,7 @@
               <a:spcAft>
                 <a:spcPts val="200"/>
               </a:spcAft>
-              <a:defRPr sz="880"/>
+              <a:defRPr sz="1400"/>
             </a:pPr>
             <a:r>
               <a:rPr b="1">
@@ -8014,7 +8014,7 @@
               <a:spcAft>
                 <a:spcPts val="200"/>
               </a:spcAft>
-              <a:defRPr sz="880"/>
+              <a:defRPr sz="1400"/>
             </a:pPr>
             <a:r>
               <a:rPr b="1">
@@ -8044,7 +8044,7 @@
               <a:spcAft>
                 <a:spcPts val="200"/>
               </a:spcAft>
-              <a:defRPr sz="880"/>
+              <a:defRPr sz="1400"/>
             </a:pPr>
             <a:r>
               <a:rPr b="1">
@@ -8091,8 +8091,8 @@
         </p:nvSpPr>
         <p:spPr>
           <a:xfrm>
-            <a:off x="3124047" y="182880"/>
-            <a:ext cx="5943600" cy="329184"/>
+            <a:off x="2666847" y="164592"/>
+            <a:ext cx="6858000" cy="384048"/>
           </a:xfrm>
           <a:prstGeom prst="roundRect">
             <a:avLst/>
@@ -8129,7 +8129,7 @@
               <a:spcAft>
                 <a:spcPts val="0"/>
               </a:spcAft>
-              <a:defRPr sz="950" b="1">
+              <a:defRPr sz="1400" b="1">
                 <a:solidFill>
                   <a:srgbClr val="FFFFFF"/>
                 </a:solidFill>
@@ -8149,8 +8149,8 @@
         </p:nvSpPr>
         <p:spPr>
           <a:xfrm>
-            <a:off x="640080" y="585216"/>
-            <a:ext cx="9601200" cy="777240"/>
+            <a:off x="594360" y="594360"/>
+            <a:ext cx="9875520" cy="777240"/>
           </a:xfrm>
           <a:prstGeom prst="rect">
             <a:avLst/>
@@ -8167,7 +8167,7 @@
               <a:spcAft>
                 <a:spcPts val="200"/>
               </a:spcAft>
-              <a:defRPr sz="1350" b="1">
+              <a:defRPr sz="1800" b="1">
                 <a:solidFill>
                   <a:srgbClr val="282C3F"/>
                 </a:solidFill>
@@ -8185,7 +8185,7 @@
               <a:spcAft>
                 <a:spcPts val="400"/>
               </a:spcAft>
-              <a:defRPr sz="1000" b="1">
+              <a:defRPr sz="1400" b="1">
                 <a:solidFill>
                   <a:srgbClr val="FF3F6C"/>
                 </a:solidFill>
@@ -8205,7 +8205,7 @@
         </p:nvSpPr>
         <p:spPr>
           <a:xfrm>
-            <a:off x="10424160" y="585216"/>
+            <a:off x="10424160" y="594360"/>
             <a:ext cx="1188720" cy="457200"/>
           </a:xfrm>
           <a:prstGeom prst="rect">
@@ -8220,7 +8220,7 @@
           <a:lstStyle/>
           <a:p>
             <a:pPr algn="r">
-              <a:defRPr sz="2200" b="1">
+              <a:defRPr sz="2400" b="1">
                 <a:solidFill>
                   <a:srgbClr val="FF3F6C"/>
                 </a:solidFill>
@@ -8240,8 +8240,8 @@
         </p:nvSpPr>
         <p:spPr>
           <a:xfrm>
-            <a:off x="640080" y="1444752"/>
-            <a:ext cx="10911535" cy="438912"/>
+            <a:off x="594360" y="1417320"/>
+            <a:ext cx="11002975" cy="438912"/>
           </a:xfrm>
           <a:prstGeom prst="roundRect">
             <a:avLst/>
@@ -8249,7 +8249,7 @@
           <a:solidFill>
             <a:srgbClr val="FFF0F4"/>
           </a:solidFill>
-          <a:ln w="12700">
+          <a:ln w="19050">
             <a:solidFill>
               <a:srgbClr val="FFC2D1"/>
             </a:solidFill>
@@ -8285,8 +8285,8 @@
         </p:nvSpPr>
         <p:spPr>
           <a:xfrm>
-            <a:off x="777240" y="1481328"/>
-            <a:ext cx="10637215" cy="365760"/>
+            <a:off x="704088" y="1453896"/>
+            <a:ext cx="10783519" cy="365760"/>
           </a:xfrm>
           <a:prstGeom prst="rect">
             <a:avLst/>
@@ -8300,7 +8300,7 @@
           <a:lstStyle/>
           <a:p>
             <a:pPr>
-              <a:defRPr sz="950" b="1">
+              <a:defRPr sz="1400" b="1">
                 <a:solidFill>
                   <a:srgbClr val="FF3F6C"/>
                 </a:solidFill>
@@ -8320,8 +8320,8 @@
         </p:nvSpPr>
         <p:spPr>
           <a:xfrm>
-            <a:off x="640080" y="1993392"/>
-            <a:ext cx="3529584" cy="2240280"/>
+            <a:off x="594360" y="1965960"/>
+            <a:ext cx="3566160" cy="2267712"/>
           </a:xfrm>
           <a:prstGeom prst="roundRect">
             <a:avLst/>
@@ -8329,7 +8329,7 @@
           <a:solidFill>
             <a:srgbClr val="FFFFFF"/>
           </a:solidFill>
-          <a:ln w="12700">
+          <a:ln w="19050">
             <a:solidFill>
               <a:srgbClr val="EAEAEC"/>
             </a:solidFill>
@@ -8365,8 +8365,8 @@
         </p:nvSpPr>
         <p:spPr>
           <a:xfrm>
-            <a:off x="713232" y="2048256"/>
-            <a:ext cx="3383280" cy="2130552"/>
+            <a:off x="667512" y="2020824"/>
+            <a:ext cx="3419856" cy="2157984"/>
           </a:xfrm>
           <a:prstGeom prst="rect">
             <a:avLst/>
@@ -8383,7 +8383,7 @@
               <a:spcAft>
                 <a:spcPts val="200"/>
               </a:spcAft>
-              <a:defRPr sz="919" b="1">
+              <a:defRPr sz="1500" b="1">
                 <a:solidFill>
                   <a:srgbClr val="FF3F6C"/>
                 </a:solidFill>
@@ -8396,12 +8396,12 @@
           <a:p>
             <a:pPr>
               <a:lnSpc>
-                <a:spcPct val="110000"/>
+                <a:spcPct val="112000"/>
               </a:lnSpc>
               <a:spcAft>
                 <a:spcPts val="200"/>
               </a:spcAft>
-              <a:defRPr sz="840"/>
+              <a:defRPr sz="1400"/>
             </a:pPr>
             <a:r>
               <a:rPr b="1">
@@ -8423,12 +8423,12 @@
           <a:p>
             <a:pPr>
               <a:lnSpc>
-                <a:spcPct val="110000"/>
+                <a:spcPct val="112000"/>
               </a:lnSpc>
               <a:spcAft>
                 <a:spcPts val="0"/>
               </a:spcAft>
-              <a:defRPr sz="840"/>
+              <a:defRPr sz="1400"/>
             </a:pPr>
             <a:r>
               <a:rPr b="1">
@@ -8449,8 +8449,8 @@
         </p:nvSpPr>
         <p:spPr>
           <a:xfrm>
-            <a:off x="4325112" y="1993392"/>
-            <a:ext cx="3529584" cy="2240280"/>
+            <a:off x="4306824" y="1965960"/>
+            <a:ext cx="3566160" cy="2267712"/>
           </a:xfrm>
           <a:prstGeom prst="roundRect">
             <a:avLst/>
@@ -8458,7 +8458,7 @@
           <a:solidFill>
             <a:srgbClr val="FFFFFF"/>
           </a:solidFill>
-          <a:ln w="12700">
+          <a:ln w="19050">
             <a:solidFill>
               <a:srgbClr val="EAEAEC"/>
             </a:solidFill>
@@ -8494,8 +8494,8 @@
         </p:nvSpPr>
         <p:spPr>
           <a:xfrm>
-            <a:off x="4398264" y="2048256"/>
-            <a:ext cx="3383280" cy="2130552"/>
+            <a:off x="4379976" y="2020824"/>
+            <a:ext cx="3419856" cy="2157984"/>
           </a:xfrm>
           <a:prstGeom prst="rect">
             <a:avLst/>
@@ -8512,7 +8512,7 @@
               <a:spcAft>
                 <a:spcPts val="200"/>
               </a:spcAft>
-              <a:defRPr sz="919" b="1">
+              <a:defRPr sz="1500" b="1">
                 <a:solidFill>
                   <a:srgbClr val="FF3F6C"/>
                 </a:solidFill>
@@ -8525,12 +8525,12 @@
           <a:p>
             <a:pPr>
               <a:lnSpc>
-                <a:spcPct val="110000"/>
+                <a:spcPct val="112000"/>
               </a:lnSpc>
               <a:spcAft>
                 <a:spcPts val="200"/>
               </a:spcAft>
-              <a:defRPr sz="840"/>
+              <a:defRPr sz="1400"/>
             </a:pPr>
             <a:r>
               <a:rPr b="1">
@@ -8552,12 +8552,12 @@
           <a:p>
             <a:pPr>
               <a:lnSpc>
-                <a:spcPct val="110000"/>
+                <a:spcPct val="112000"/>
               </a:lnSpc>
               <a:spcAft>
                 <a:spcPts val="0"/>
               </a:spcAft>
-              <a:defRPr sz="840"/>
+              <a:defRPr sz="1400"/>
             </a:pPr>
             <a:r>
               <a:rPr b="1">
@@ -8578,8 +8578,8 @@
         </p:nvSpPr>
         <p:spPr>
           <a:xfrm>
-            <a:off x="8010144" y="1993392"/>
-            <a:ext cx="3529584" cy="2240280"/>
+            <a:off x="8019288" y="1965960"/>
+            <a:ext cx="3566160" cy="2267712"/>
           </a:xfrm>
           <a:prstGeom prst="roundRect">
             <a:avLst/>
@@ -8587,7 +8587,7 @@
           <a:solidFill>
             <a:srgbClr val="FFFFFF"/>
           </a:solidFill>
-          <a:ln w="12700">
+          <a:ln w="19050">
             <a:solidFill>
               <a:srgbClr val="EAEAEC"/>
             </a:solidFill>
@@ -8623,8 +8623,8 @@
         </p:nvSpPr>
         <p:spPr>
           <a:xfrm>
-            <a:off x="8083296" y="2048256"/>
-            <a:ext cx="3383280" cy="2130552"/>
+            <a:off x="8092440" y="2020824"/>
+            <a:ext cx="3419856" cy="2157984"/>
           </a:xfrm>
           <a:prstGeom prst="rect">
             <a:avLst/>
@@ -8641,7 +8641,7 @@
               <a:spcAft>
                 <a:spcPts val="200"/>
               </a:spcAft>
-              <a:defRPr sz="919" b="1">
+              <a:defRPr sz="1500" b="1">
                 <a:solidFill>
                   <a:srgbClr val="FF3F6C"/>
                 </a:solidFill>
@@ -8654,12 +8654,12 @@
           <a:p>
             <a:pPr>
               <a:lnSpc>
-                <a:spcPct val="110000"/>
+                <a:spcPct val="112000"/>
               </a:lnSpc>
               <a:spcAft>
                 <a:spcPts val="200"/>
               </a:spcAft>
-              <a:defRPr sz="840"/>
+              <a:defRPr sz="1400"/>
             </a:pPr>
             <a:r>
               <a:rPr b="1">
@@ -8681,12 +8681,12 @@
           <a:p>
             <a:pPr>
               <a:lnSpc>
-                <a:spcPct val="110000"/>
+                <a:spcPct val="112000"/>
               </a:lnSpc>
               <a:spcAft>
                 <a:spcPts val="0"/>
               </a:spcAft>
-              <a:defRPr sz="840"/>
+              <a:defRPr sz="1400"/>
             </a:pPr>
             <a:r>
               <a:rPr b="1">
@@ -8707,8 +8707,8 @@
         </p:nvSpPr>
         <p:spPr>
           <a:xfrm>
-            <a:off x="640080" y="4343400"/>
-            <a:ext cx="3529584" cy="2240280"/>
+            <a:off x="594360" y="4343400"/>
+            <a:ext cx="3566160" cy="2267712"/>
           </a:xfrm>
           <a:prstGeom prst="roundRect">
             <a:avLst/>
@@ -8716,7 +8716,7 @@
           <a:solidFill>
             <a:srgbClr val="FFFFFF"/>
           </a:solidFill>
-          <a:ln w="12700">
+          <a:ln w="19050">
             <a:solidFill>
               <a:srgbClr val="EAEAEC"/>
             </a:solidFill>
@@ -8752,8 +8752,8 @@
         </p:nvSpPr>
         <p:spPr>
           <a:xfrm>
-            <a:off x="713232" y="4398264"/>
-            <a:ext cx="3383280" cy="2130552"/>
+            <a:off x="667512" y="4398264"/>
+            <a:ext cx="3419856" cy="2157984"/>
           </a:xfrm>
           <a:prstGeom prst="rect">
             <a:avLst/>
@@ -8770,7 +8770,7 @@
               <a:spcAft>
                 <a:spcPts val="200"/>
               </a:spcAft>
-              <a:defRPr sz="919" b="1">
+              <a:defRPr sz="1500" b="1">
                 <a:solidFill>
                   <a:srgbClr val="FF3F6C"/>
                 </a:solidFill>
@@ -8783,12 +8783,12 @@
           <a:p>
             <a:pPr>
               <a:lnSpc>
-                <a:spcPct val="110000"/>
+                <a:spcPct val="112000"/>
               </a:lnSpc>
               <a:spcAft>
                 <a:spcPts val="200"/>
               </a:spcAft>
-              <a:defRPr sz="840"/>
+              <a:defRPr sz="1400"/>
             </a:pPr>
             <a:r>
               <a:rPr b="1">
@@ -8810,12 +8810,12 @@
           <a:p>
             <a:pPr>
               <a:lnSpc>
-                <a:spcPct val="110000"/>
+                <a:spcPct val="112000"/>
               </a:lnSpc>
               <a:spcAft>
                 <a:spcPts val="0"/>
               </a:spcAft>
-              <a:defRPr sz="840"/>
+              <a:defRPr sz="1400"/>
             </a:pPr>
             <a:r>
               <a:rPr b="1">
@@ -8836,8 +8836,8 @@
         </p:nvSpPr>
         <p:spPr>
           <a:xfrm>
-            <a:off x="4325112" y="4343400"/>
-            <a:ext cx="3529584" cy="2240280"/>
+            <a:off x="4306824" y="4343400"/>
+            <a:ext cx="3566160" cy="2267712"/>
           </a:xfrm>
           <a:prstGeom prst="roundRect">
             <a:avLst/>
@@ -8845,7 +8845,7 @@
           <a:solidFill>
             <a:srgbClr val="FFFFFF"/>
           </a:solidFill>
-          <a:ln w="12700">
+          <a:ln w="19050">
             <a:solidFill>
               <a:srgbClr val="EAEAEC"/>
             </a:solidFill>
@@ -8881,8 +8881,8 @@
         </p:nvSpPr>
         <p:spPr>
           <a:xfrm>
-            <a:off x="4398264" y="4398264"/>
-            <a:ext cx="3383280" cy="2130552"/>
+            <a:off x="4379976" y="4398264"/>
+            <a:ext cx="3419856" cy="2157984"/>
           </a:xfrm>
           <a:prstGeom prst="rect">
             <a:avLst/>
@@ -8899,7 +8899,7 @@
               <a:spcAft>
                 <a:spcPts val="200"/>
               </a:spcAft>
-              <a:defRPr sz="919" b="1">
+              <a:defRPr sz="1500" b="1">
                 <a:solidFill>
                   <a:srgbClr val="FF3F6C"/>
                 </a:solidFill>
@@ -8912,12 +8912,12 @@
           <a:p>
             <a:pPr>
               <a:lnSpc>
-                <a:spcPct val="110000"/>
+                <a:spcPct val="112000"/>
               </a:lnSpc>
               <a:spcAft>
                 <a:spcPts val="200"/>
               </a:spcAft>
-              <a:defRPr sz="840"/>
+              <a:defRPr sz="1400"/>
             </a:pPr>
             <a:r>
               <a:rPr b="1">
@@ -8939,12 +8939,12 @@
           <a:p>
             <a:pPr>
               <a:lnSpc>
-                <a:spcPct val="110000"/>
+                <a:spcPct val="112000"/>
               </a:lnSpc>
               <a:spcAft>
                 <a:spcPts val="0"/>
               </a:spcAft>
-              <a:defRPr sz="840"/>
+              <a:defRPr sz="1400"/>
             </a:pPr>
             <a:r>
               <a:rPr b="1">
@@ -8965,8 +8965,8 @@
         </p:nvSpPr>
         <p:spPr>
           <a:xfrm>
-            <a:off x="8010144" y="4343400"/>
-            <a:ext cx="3529584" cy="2240280"/>
+            <a:off x="8019288" y="4343400"/>
+            <a:ext cx="3566160" cy="2267712"/>
           </a:xfrm>
           <a:prstGeom prst="roundRect">
             <a:avLst/>
@@ -8974,7 +8974,7 @@
           <a:solidFill>
             <a:srgbClr val="FFFFFF"/>
           </a:solidFill>
-          <a:ln w="12700">
+          <a:ln w="19050">
             <a:solidFill>
               <a:srgbClr val="EAEAEC"/>
             </a:solidFill>
@@ -9010,8 +9010,8 @@
         </p:nvSpPr>
         <p:spPr>
           <a:xfrm>
-            <a:off x="8083296" y="4398264"/>
-            <a:ext cx="3383280" cy="2130552"/>
+            <a:off x="8092440" y="4398264"/>
+            <a:ext cx="3419856" cy="2157984"/>
           </a:xfrm>
           <a:prstGeom prst="rect">
             <a:avLst/>
@@ -9028,7 +9028,7 @@
               <a:spcAft>
                 <a:spcPts val="200"/>
               </a:spcAft>
-              <a:defRPr sz="919" b="1">
+              <a:defRPr sz="1500" b="1">
                 <a:solidFill>
                   <a:srgbClr val="FF3F6C"/>
                 </a:solidFill>
@@ -9041,12 +9041,12 @@
           <a:p>
             <a:pPr>
               <a:lnSpc>
-                <a:spcPct val="110000"/>
+                <a:spcPct val="112000"/>
               </a:lnSpc>
               <a:spcAft>
                 <a:spcPts val="200"/>
               </a:spcAft>
-              <a:defRPr sz="840"/>
+              <a:defRPr sz="1400"/>
             </a:pPr>
             <a:r>
               <a:rPr b="1">
@@ -9068,12 +9068,12 @@
           <a:p>
             <a:pPr>
               <a:lnSpc>
-                <a:spcPct val="110000"/>
+                <a:spcPct val="112000"/>
               </a:lnSpc>
               <a:spcAft>
                 <a:spcPts val="0"/>
               </a:spcAft>
-              <a:defRPr sz="840"/>
+              <a:defRPr sz="1400"/>
             </a:pPr>
             <a:r>
               <a:rPr b="1">
@@ -9112,8 +9112,8 @@
         </p:nvSpPr>
         <p:spPr>
           <a:xfrm>
-            <a:off x="3124047" y="182880"/>
-            <a:ext cx="5943600" cy="329184"/>
+            <a:off x="2666847" y="164592"/>
+            <a:ext cx="6858000" cy="384048"/>
           </a:xfrm>
           <a:prstGeom prst="roundRect">
             <a:avLst/>
@@ -9150,7 +9150,7 @@
               <a:spcAft>
                 <a:spcPts val="0"/>
               </a:spcAft>
-              <a:defRPr sz="950" b="1">
+              <a:defRPr sz="1400" b="1">
                 <a:solidFill>
                   <a:srgbClr val="FFFFFF"/>
                 </a:solidFill>
@@ -9170,8 +9170,8 @@
         </p:nvSpPr>
         <p:spPr>
           <a:xfrm>
-            <a:off x="640080" y="585216"/>
-            <a:ext cx="9601200" cy="777240"/>
+            <a:off x="594360" y="594360"/>
+            <a:ext cx="9875520" cy="777240"/>
           </a:xfrm>
           <a:prstGeom prst="rect">
             <a:avLst/>
@@ -9188,7 +9188,7 @@
               <a:spcAft>
                 <a:spcPts val="200"/>
               </a:spcAft>
-              <a:defRPr sz="1350" b="1">
+              <a:defRPr sz="1800" b="1">
                 <a:solidFill>
                   <a:srgbClr val="282C3F"/>
                 </a:solidFill>
@@ -9206,7 +9206,7 @@
               <a:spcAft>
                 <a:spcPts val="400"/>
               </a:spcAft>
-              <a:defRPr sz="1000" b="1">
+              <a:defRPr sz="1400" b="1">
                 <a:solidFill>
                   <a:srgbClr val="FF3F6C"/>
                 </a:solidFill>
@@ -9226,7 +9226,7 @@
         </p:nvSpPr>
         <p:spPr>
           <a:xfrm>
-            <a:off x="10424160" y="585216"/>
+            <a:off x="10424160" y="594360"/>
             <a:ext cx="1188720" cy="457200"/>
           </a:xfrm>
           <a:prstGeom prst="rect">
@@ -9241,7 +9241,7 @@
           <a:lstStyle/>
           <a:p>
             <a:pPr algn="r">
-              <a:defRPr sz="2200" b="1">
+              <a:defRPr sz="2400" b="1">
                 <a:solidFill>
                   <a:srgbClr val="FF3F6C"/>
                 </a:solidFill>
@@ -9261,8 +9261,8 @@
         </p:nvSpPr>
         <p:spPr>
           <a:xfrm>
-            <a:off x="640080" y="1444752"/>
-            <a:ext cx="3529584" cy="2487168"/>
+            <a:off x="594360" y="1417320"/>
+            <a:ext cx="3566160" cy="2514600"/>
           </a:xfrm>
           <a:prstGeom prst="roundRect">
             <a:avLst/>
@@ -9270,7 +9270,7 @@
           <a:solidFill>
             <a:srgbClr val="FFFFFF"/>
           </a:solidFill>
-          <a:ln w="12700">
+          <a:ln w="19050">
             <a:solidFill>
               <a:srgbClr val="EAEAEC"/>
             </a:solidFill>
@@ -9306,8 +9306,8 @@
         </p:nvSpPr>
         <p:spPr>
           <a:xfrm>
-            <a:off x="713232" y="1499616"/>
-            <a:ext cx="3383280" cy="2377440"/>
+            <a:off x="667512" y="1472184"/>
+            <a:ext cx="3419856" cy="2404872"/>
           </a:xfrm>
           <a:prstGeom prst="rect">
             <a:avLst/>
@@ -9324,7 +9324,7 @@
               <a:spcAft>
                 <a:spcPts val="300"/>
               </a:spcAft>
-              <a:defRPr sz="980" b="1">
+              <a:defRPr sz="1500" b="1">
                 <a:solidFill>
                   <a:srgbClr val="FF3F6C"/>
                 </a:solidFill>
@@ -9339,7 +9339,7 @@
               <a:lnSpc>
                 <a:spcPct val="114000"/>
               </a:lnSpc>
-              <a:defRPr sz="860">
+              <a:defRPr sz="1400">
                 <a:solidFill>
                   <a:srgbClr val="282C3F"/>
                 </a:solidFill>
@@ -9359,8 +9359,8 @@
         </p:nvSpPr>
         <p:spPr>
           <a:xfrm>
-            <a:off x="4325112" y="1444752"/>
-            <a:ext cx="3529584" cy="2487168"/>
+            <a:off x="4306824" y="1417320"/>
+            <a:ext cx="3566160" cy="2514600"/>
           </a:xfrm>
           <a:prstGeom prst="roundRect">
             <a:avLst/>
@@ -9368,7 +9368,7 @@
           <a:solidFill>
             <a:srgbClr val="FFFFFF"/>
           </a:solidFill>
-          <a:ln w="12700">
+          <a:ln w="19050">
             <a:solidFill>
               <a:srgbClr val="EAEAEC"/>
             </a:solidFill>
@@ -9404,8 +9404,8 @@
         </p:nvSpPr>
         <p:spPr>
           <a:xfrm>
-            <a:off x="4398264" y="1499616"/>
-            <a:ext cx="3383280" cy="2377440"/>
+            <a:off x="4379976" y="1472184"/>
+            <a:ext cx="3419856" cy="2404872"/>
           </a:xfrm>
           <a:prstGeom prst="rect">
             <a:avLst/>
@@ -9422,7 +9422,7 @@
               <a:spcAft>
                 <a:spcPts val="300"/>
               </a:spcAft>
-              <a:defRPr sz="980" b="1">
+              <a:defRPr sz="1500" b="1">
                 <a:solidFill>
                   <a:srgbClr val="FF3F6C"/>
                 </a:solidFill>
@@ -9437,7 +9437,7 @@
               <a:lnSpc>
                 <a:spcPct val="114000"/>
               </a:lnSpc>
-              <a:defRPr sz="860">
+              <a:defRPr sz="1400">
                 <a:solidFill>
                   <a:srgbClr val="282C3F"/>
                 </a:solidFill>
@@ -9457,8 +9457,8 @@
         </p:nvSpPr>
         <p:spPr>
           <a:xfrm>
-            <a:off x="8010144" y="1444752"/>
-            <a:ext cx="3529584" cy="2487168"/>
+            <a:off x="8019288" y="1417320"/>
+            <a:ext cx="3566160" cy="2514600"/>
           </a:xfrm>
           <a:prstGeom prst="roundRect">
             <a:avLst/>
@@ -9466,7 +9466,7 @@
           <a:solidFill>
             <a:srgbClr val="FFFFFF"/>
           </a:solidFill>
-          <a:ln w="12700">
+          <a:ln w="19050">
             <a:solidFill>
               <a:srgbClr val="EAEAEC"/>
             </a:solidFill>
@@ -9502,8 +9502,8 @@
         </p:nvSpPr>
         <p:spPr>
           <a:xfrm>
-            <a:off x="8083296" y="1499616"/>
-            <a:ext cx="3383280" cy="2377440"/>
+            <a:off x="8092440" y="1472184"/>
+            <a:ext cx="3419856" cy="2404872"/>
           </a:xfrm>
           <a:prstGeom prst="rect">
             <a:avLst/>
@@ -9520,7 +9520,7 @@
               <a:spcAft>
                 <a:spcPts val="300"/>
               </a:spcAft>
-              <a:defRPr sz="980" b="1">
+              <a:defRPr sz="1500" b="1">
                 <a:solidFill>
                   <a:srgbClr val="FF3F6C"/>
                 </a:solidFill>
@@ -9535,7 +9535,7 @@
               <a:lnSpc>
                 <a:spcPct val="114000"/>
               </a:lnSpc>
-              <a:defRPr sz="860">
+              <a:defRPr sz="1400">
                 <a:solidFill>
                   <a:srgbClr val="282C3F"/>
                 </a:solidFill>
@@ -9555,8 +9555,8 @@
         </p:nvSpPr>
         <p:spPr>
           <a:xfrm>
-            <a:off x="640080" y="4096512"/>
-            <a:ext cx="5358384" cy="2487168"/>
+            <a:off x="594360" y="4096512"/>
+            <a:ext cx="5394960" cy="2514600"/>
           </a:xfrm>
           <a:prstGeom prst="roundRect">
             <a:avLst/>
@@ -9564,7 +9564,7 @@
           <a:solidFill>
             <a:srgbClr val="FFFFFF"/>
           </a:solidFill>
-          <a:ln w="12700">
+          <a:ln w="19050">
             <a:solidFill>
               <a:srgbClr val="EAEAEC"/>
             </a:solidFill>
@@ -9600,8 +9600,8 @@
         </p:nvSpPr>
         <p:spPr>
           <a:xfrm>
-            <a:off x="713232" y="4151376"/>
-            <a:ext cx="5212080" cy="2377440"/>
+            <a:off x="667512" y="4151376"/>
+            <a:ext cx="5248656" cy="2404872"/>
           </a:xfrm>
           <a:prstGeom prst="rect">
             <a:avLst/>
@@ -9618,7 +9618,7 @@
               <a:spcAft>
                 <a:spcPts val="300"/>
               </a:spcAft>
-              <a:defRPr sz="980" b="1">
+              <a:defRPr sz="1500" b="1">
                 <a:solidFill>
                   <a:srgbClr val="FF3F6C"/>
                 </a:solidFill>
@@ -9636,7 +9636,7 @@
               <a:spcAft>
                 <a:spcPts val="200"/>
               </a:spcAft>
-              <a:defRPr sz="860"/>
+              <a:defRPr sz="1400"/>
             </a:pPr>
             <a:r>
               <a:rPr b="1">
@@ -9660,7 +9660,7 @@
               <a:lnSpc>
                 <a:spcPct val="114000"/>
               </a:lnSpc>
-              <a:defRPr sz="860"/>
+              <a:defRPr sz="1400"/>
             </a:pPr>
             <a:r>
               <a:rPr b="1">
@@ -9689,8 +9689,8 @@
         </p:nvSpPr>
         <p:spPr>
           <a:xfrm>
-            <a:off x="6181344" y="4096512"/>
-            <a:ext cx="5358384" cy="2487168"/>
+            <a:off x="6199632" y="4096512"/>
+            <a:ext cx="5394960" cy="2514600"/>
           </a:xfrm>
           <a:prstGeom prst="roundRect">
             <a:avLst/>
@@ -9698,7 +9698,7 @@
           <a:solidFill>
             <a:srgbClr val="FFFFFF"/>
           </a:solidFill>
-          <a:ln w="12700">
+          <a:ln w="19050">
             <a:solidFill>
               <a:srgbClr val="EAEAEC"/>
             </a:solidFill>
@@ -9734,8 +9734,8 @@
         </p:nvSpPr>
         <p:spPr>
           <a:xfrm>
-            <a:off x="6254496" y="4151376"/>
-            <a:ext cx="5212080" cy="2377440"/>
+            <a:off x="6272784" y="4151376"/>
+            <a:ext cx="5248656" cy="2404872"/>
           </a:xfrm>
           <a:prstGeom prst="rect">
             <a:avLst/>
@@ -9752,7 +9752,7 @@
               <a:spcAft>
                 <a:spcPts val="300"/>
               </a:spcAft>
-              <a:defRPr sz="980" b="1">
+              <a:defRPr sz="1500" b="1">
                 <a:solidFill>
                   <a:srgbClr val="FF3F6C"/>
                 </a:solidFill>
@@ -9767,7 +9767,7 @@
               <a:lnSpc>
                 <a:spcPct val="114000"/>
               </a:lnSpc>
-              <a:defRPr sz="860">
+              <a:defRPr sz="1400">
                 <a:solidFill>
                   <a:srgbClr val="282C3F"/>
                 </a:solidFill>
@@ -9805,8 +9805,8 @@
         </p:nvSpPr>
         <p:spPr>
           <a:xfrm>
-            <a:off x="3124047" y="182880"/>
-            <a:ext cx="5943600" cy="329184"/>
+            <a:off x="2666847" y="164592"/>
+            <a:ext cx="6858000" cy="384048"/>
           </a:xfrm>
           <a:prstGeom prst="roundRect">
             <a:avLst/>
@@ -9843,7 +9843,7 @@
               <a:spcAft>
                 <a:spcPts val="0"/>
               </a:spcAft>
-              <a:defRPr sz="950" b="1">
+              <a:defRPr sz="1400" b="1">
                 <a:solidFill>
                   <a:srgbClr val="FFFFFF"/>
                 </a:solidFill>
@@ -9863,8 +9863,8 @@
         </p:nvSpPr>
         <p:spPr>
           <a:xfrm>
-            <a:off x="640080" y="585216"/>
-            <a:ext cx="9601200" cy="777240"/>
+            <a:off x="594360" y="594360"/>
+            <a:ext cx="9875520" cy="777240"/>
           </a:xfrm>
           <a:prstGeom prst="rect">
             <a:avLst/>
@@ -9881,7 +9881,7 @@
               <a:spcAft>
                 <a:spcPts val="200"/>
               </a:spcAft>
-              <a:defRPr sz="1350" b="1">
+              <a:defRPr sz="1800" b="1">
                 <a:solidFill>
                   <a:srgbClr val="282C3F"/>
                 </a:solidFill>
@@ -9899,7 +9899,7 @@
               <a:spcAft>
                 <a:spcPts val="400"/>
               </a:spcAft>
-              <a:defRPr sz="1000" b="1">
+              <a:defRPr sz="1400" b="1">
                 <a:solidFill>
                   <a:srgbClr val="FF3F6C"/>
                 </a:solidFill>
@@ -9919,7 +9919,7 @@
         </p:nvSpPr>
         <p:spPr>
           <a:xfrm>
-            <a:off x="10424160" y="585216"/>
+            <a:off x="10424160" y="594360"/>
             <a:ext cx="1188720" cy="457200"/>
           </a:xfrm>
           <a:prstGeom prst="rect">
@@ -9934,7 +9934,7 @@
           <a:lstStyle/>
           <a:p>
             <a:pPr algn="r">
-              <a:defRPr sz="2200" b="1">
+              <a:defRPr sz="2400" b="1">
                 <a:solidFill>
                   <a:srgbClr val="FF3F6C"/>
                 </a:solidFill>
@@ -9954,8 +9954,8 @@
         </p:nvSpPr>
         <p:spPr>
           <a:xfrm>
-            <a:off x="640080" y="1444752"/>
-            <a:ext cx="10911535" cy="1234440"/>
+            <a:off x="594360" y="1417320"/>
+            <a:ext cx="11002975" cy="1280160"/>
           </a:xfrm>
           <a:prstGeom prst="roundRect">
             <a:avLst/>
@@ -9963,7 +9963,7 @@
           <a:solidFill>
             <a:srgbClr val="FFF0F4"/>
           </a:solidFill>
-          <a:ln w="12700">
+          <a:ln w="19050">
             <a:solidFill>
               <a:srgbClr val="FFC2D1"/>
             </a:solidFill>
@@ -9999,8 +9999,8 @@
         </p:nvSpPr>
         <p:spPr>
           <a:xfrm>
-            <a:off x="777240" y="1499616"/>
-            <a:ext cx="10637215" cy="1124712"/>
+            <a:off x="704088" y="1472184"/>
+            <a:ext cx="10783519" cy="1170432"/>
           </a:xfrm>
           <a:prstGeom prst="rect">
             <a:avLst/>
@@ -10017,7 +10017,7 @@
               <a:spcAft>
                 <a:spcPts val="300"/>
               </a:spcAft>
-              <a:defRPr sz="1050" b="1">
+              <a:defRPr sz="1500" b="1">
                 <a:solidFill>
                   <a:srgbClr val="FF3F6C"/>
                 </a:solidFill>
@@ -10038,7 +10038,7 @@
               <a:spcAft>
                 <a:spcPts val="200"/>
               </a:spcAft>
-              <a:defRPr sz="880"/>
+              <a:defRPr sz="1400"/>
             </a:pPr>
             <a:r>
               <a:rPr b="1">
@@ -10068,7 +10068,7 @@
               <a:spcAft>
                 <a:spcPts val="200"/>
               </a:spcAft>
-              <a:defRPr sz="880"/>
+              <a:defRPr sz="1400"/>
             </a:pPr>
             <a:r>
               <a:rPr b="1">
@@ -10098,7 +10098,7 @@
               <a:spcAft>
                 <a:spcPts val="200"/>
               </a:spcAft>
-              <a:defRPr sz="880"/>
+              <a:defRPr sz="1400"/>
             </a:pPr>
             <a:r>
               <a:rPr b="1">
@@ -10127,8 +10127,8 @@
         </p:nvSpPr>
         <p:spPr>
           <a:xfrm>
-            <a:off x="640080" y="2807208"/>
-            <a:ext cx="10911535" cy="3776472"/>
+            <a:off x="594360" y="2825496"/>
+            <a:ext cx="11002975" cy="3785616"/>
           </a:xfrm>
           <a:prstGeom prst="roundRect">
             <a:avLst/>
@@ -10136,7 +10136,7 @@
           <a:solidFill>
             <a:srgbClr val="FFFFFF"/>
           </a:solidFill>
-          <a:ln w="12700">
+          <a:ln w="19050">
             <a:solidFill>
               <a:srgbClr val="EAEAEC"/>
             </a:solidFill>
@@ -10172,8 +10172,8 @@
         </p:nvSpPr>
         <p:spPr>
           <a:xfrm>
-            <a:off x="749808" y="2880360"/>
-            <a:ext cx="10689336" cy="3630168"/>
+            <a:off x="704088" y="2898648"/>
+            <a:ext cx="10783519" cy="3639312"/>
           </a:xfrm>
           <a:prstGeom prst="rect">
             <a:avLst/>
@@ -10190,7 +10190,7 @@
               <a:spcAft>
                 <a:spcPts val="400"/>
               </a:spcAft>
-              <a:defRPr sz="1050" b="1">
+              <a:defRPr sz="1500" b="1">
                 <a:solidFill>
                   <a:srgbClr val="FF3F6C"/>
                 </a:solidFill>
@@ -10203,7 +10203,7 @@
           <a:p>
             <a:pPr marL="177800" indent="0">
               <a:lnSpc>
-                <a:spcPct val="114000"/>
+                <a:spcPct val="115000"/>
               </a:lnSpc>
               <a:spcBef>
                 <a:spcPts val="200"/>
@@ -10211,7 +10211,7 @@
               <a:spcAft>
                 <a:spcPts val="300"/>
               </a:spcAft>
-              <a:defRPr sz="880"/>
+              <a:defRPr sz="1400"/>
             </a:pPr>
             <a:r>
               <a:rPr b="1">
@@ -10257,7 +10257,7 @@
           <a:p>
             <a:pPr marL="177800" indent="0">
               <a:lnSpc>
-                <a:spcPct val="114000"/>
+                <a:spcPct val="115000"/>
               </a:lnSpc>
               <a:spcBef>
                 <a:spcPts val="200"/>
@@ -10265,7 +10265,7 @@
               <a:spcAft>
                 <a:spcPts val="300"/>
               </a:spcAft>
-              <a:defRPr sz="880"/>
+              <a:defRPr sz="1400"/>
             </a:pPr>
             <a:r>
               <a:rPr b="1">
@@ -10311,7 +10311,7 @@
           <a:p>
             <a:pPr marL="177800" indent="0">
               <a:lnSpc>
-                <a:spcPct val="114000"/>
+                <a:spcPct val="115000"/>
               </a:lnSpc>
               <a:spcBef>
                 <a:spcPts val="200"/>
@@ -10319,7 +10319,7 @@
               <a:spcAft>
                 <a:spcPts val="300"/>
               </a:spcAft>
-              <a:defRPr sz="880"/>
+              <a:defRPr sz="1400"/>
             </a:pPr>
             <a:r>
               <a:rPr b="1">
@@ -10390,8 +10390,8 @@
         </p:nvSpPr>
         <p:spPr>
           <a:xfrm>
-            <a:off x="3124047" y="182880"/>
-            <a:ext cx="5943600" cy="329184"/>
+            <a:off x="2666847" y="164592"/>
+            <a:ext cx="6858000" cy="384048"/>
           </a:xfrm>
           <a:prstGeom prst="roundRect">
             <a:avLst/>
@@ -10428,7 +10428,7 @@
               <a:spcAft>
                 <a:spcPts val="0"/>
               </a:spcAft>
-              <a:defRPr sz="950" b="1">
+              <a:defRPr sz="1400" b="1">
                 <a:solidFill>
                   <a:srgbClr val="FFFFFF"/>
                 </a:solidFill>
@@ -10448,8 +10448,8 @@
         </p:nvSpPr>
         <p:spPr>
           <a:xfrm>
-            <a:off x="640080" y="585216"/>
-            <a:ext cx="9601200" cy="777240"/>
+            <a:off x="594360" y="594360"/>
+            <a:ext cx="9875520" cy="777240"/>
           </a:xfrm>
           <a:prstGeom prst="rect">
             <a:avLst/>
@@ -10466,7 +10466,7 @@
               <a:spcAft>
                 <a:spcPts val="200"/>
               </a:spcAft>
-              <a:defRPr sz="1350" b="1">
+              <a:defRPr sz="1800" b="1">
                 <a:solidFill>
                   <a:srgbClr val="282C3F"/>
                 </a:solidFill>
@@ -10484,7 +10484,7 @@
               <a:spcAft>
                 <a:spcPts val="400"/>
               </a:spcAft>
-              <a:defRPr sz="1000" b="1">
+              <a:defRPr sz="1400" b="1">
                 <a:solidFill>
                   <a:srgbClr val="FF3F6C"/>
                 </a:solidFill>
@@ -10504,7 +10504,7 @@
         </p:nvSpPr>
         <p:spPr>
           <a:xfrm>
-            <a:off x="10424160" y="585216"/>
+            <a:off x="10424160" y="594360"/>
             <a:ext cx="1188720" cy="457200"/>
           </a:xfrm>
           <a:prstGeom prst="rect">
@@ -10519,7 +10519,7 @@
           <a:lstStyle/>
           <a:p>
             <a:pPr algn="r">
-              <a:defRPr sz="2200" b="1">
+              <a:defRPr sz="2400" b="1">
                 <a:solidFill>
                   <a:srgbClr val="FF3F6C"/>
                 </a:solidFill>
@@ -10539,8 +10539,8 @@
         </p:nvSpPr>
         <p:spPr>
           <a:xfrm>
-            <a:off x="640080" y="1444752"/>
-            <a:ext cx="10911535" cy="1417320"/>
+            <a:off x="594360" y="1417320"/>
+            <a:ext cx="11002975" cy="1463040"/>
           </a:xfrm>
           <a:prstGeom prst="roundRect">
             <a:avLst/>
@@ -10548,7 +10548,7 @@
           <a:solidFill>
             <a:srgbClr val="FFFFFF"/>
           </a:solidFill>
-          <a:ln w="12700">
+          <a:ln w="19050">
             <a:solidFill>
               <a:srgbClr val="EAEAEC"/>
             </a:solidFill>
@@ -10584,8 +10584,8 @@
         </p:nvSpPr>
         <p:spPr>
           <a:xfrm>
-            <a:off x="749808" y="1499616"/>
-            <a:ext cx="10689336" cy="1307592"/>
+            <a:off x="704088" y="1472184"/>
+            <a:ext cx="10783519" cy="1353312"/>
           </a:xfrm>
           <a:prstGeom prst="rect">
             <a:avLst/>
@@ -10602,7 +10602,7 @@
               <a:spcAft>
                 <a:spcPts val="200"/>
               </a:spcAft>
-              <a:defRPr sz="1050" b="1">
+              <a:defRPr sz="1500" b="1">
                 <a:solidFill>
                   <a:srgbClr val="FF3F6C"/>
                 </a:solidFill>
@@ -10615,9 +10615,9 @@
           <a:p>
             <a:pPr>
               <a:lnSpc>
-                <a:spcPct val="112000"/>
+                <a:spcPct val="115000"/>
               </a:lnSpc>
-              <a:defRPr sz="850"/>
+              <a:defRPr sz="1400"/>
             </a:pPr>
             <a:r>
               <a:rPr b="1">
@@ -10694,8 +10694,8 @@
         </p:nvSpPr>
         <p:spPr>
           <a:xfrm>
-            <a:off x="640080" y="2990088"/>
-            <a:ext cx="3529584" cy="3593592"/>
+            <a:off x="594360" y="3008376"/>
+            <a:ext cx="3566160" cy="3602736"/>
           </a:xfrm>
           <a:prstGeom prst="roundRect">
             <a:avLst/>
@@ -10703,7 +10703,7 @@
           <a:solidFill>
             <a:srgbClr val="FFF0F4"/>
           </a:solidFill>
-          <a:ln w="12700">
+          <a:ln w="19050">
             <a:solidFill>
               <a:srgbClr val="FFC2D1"/>
             </a:solidFill>
@@ -10739,8 +10739,8 @@
         </p:nvSpPr>
         <p:spPr>
           <a:xfrm>
-            <a:off x="713232" y="3044952"/>
-            <a:ext cx="3383280" cy="3483864"/>
+            <a:off x="667512" y="3063240"/>
+            <a:ext cx="3419856" cy="3493008"/>
           </a:xfrm>
           <a:prstGeom prst="rect">
             <a:avLst/>
@@ -10757,7 +10757,7 @@
               <a:spcAft>
                 <a:spcPts val="200"/>
               </a:spcAft>
-              <a:defRPr sz="1000" b="1">
+              <a:defRPr sz="1500" b="1">
                 <a:solidFill>
                   <a:srgbClr val="FF3F6C"/>
                 </a:solidFill>
@@ -10775,7 +10775,7 @@
               <a:spcAft>
                 <a:spcPts val="200"/>
               </a:spcAft>
-              <a:defRPr sz="850"/>
+              <a:defRPr sz="1400"/>
             </a:pPr>
             <a:r>
               <a:rPr>
@@ -10804,8 +10804,8 @@
         </p:blipFill>
         <p:spPr>
           <a:xfrm>
-            <a:off x="822960" y="3995928"/>
-            <a:ext cx="3163824" cy="2496312"/>
+            <a:off x="777240" y="4059936"/>
+            <a:ext cx="3200400" cy="2459736"/>
           </a:xfrm>
           <a:prstGeom prst="rect">
             <a:avLst/>
@@ -10820,8 +10820,8 @@
         </p:nvSpPr>
         <p:spPr>
           <a:xfrm>
-            <a:off x="4325112" y="2990088"/>
-            <a:ext cx="3529584" cy="3593592"/>
+            <a:off x="4306824" y="3008376"/>
+            <a:ext cx="3566160" cy="3602736"/>
           </a:xfrm>
           <a:prstGeom prst="roundRect">
             <a:avLst/>
@@ -10829,7 +10829,7 @@
           <a:solidFill>
             <a:srgbClr val="FFF0F4"/>
           </a:solidFill>
-          <a:ln w="12700">
+          <a:ln w="19050">
             <a:solidFill>
               <a:srgbClr val="FFC2D1"/>
             </a:solidFill>
@@ -10865,8 +10865,8 @@
         </p:nvSpPr>
         <p:spPr>
           <a:xfrm>
-            <a:off x="4398264" y="3044952"/>
-            <a:ext cx="3383280" cy="3483864"/>
+            <a:off x="4379976" y="3063240"/>
+            <a:ext cx="3419856" cy="3493008"/>
           </a:xfrm>
           <a:prstGeom prst="rect">
             <a:avLst/>
@@ -10883,7 +10883,7 @@
               <a:spcAft>
                 <a:spcPts val="200"/>
               </a:spcAft>
-              <a:defRPr sz="1000" b="1">
+              <a:defRPr sz="1500" b="1">
                 <a:solidFill>
                   <a:srgbClr val="FF3F6C"/>
                 </a:solidFill>
@@ -10901,7 +10901,7 @@
               <a:spcAft>
                 <a:spcPts val="200"/>
               </a:spcAft>
-              <a:defRPr sz="850"/>
+              <a:defRPr sz="1400"/>
             </a:pPr>
             <a:r>
               <a:rPr>
@@ -10930,8 +10930,8 @@
         </p:blipFill>
         <p:spPr>
           <a:xfrm>
-            <a:off x="4507992" y="3995928"/>
-            <a:ext cx="3163824" cy="2496312"/>
+            <a:off x="4489704" y="4059936"/>
+            <a:ext cx="3200400" cy="2459736"/>
           </a:xfrm>
           <a:prstGeom prst="rect">
             <a:avLst/>
@@ -10946,8 +10946,8 @@
         </p:nvSpPr>
         <p:spPr>
           <a:xfrm>
-            <a:off x="8010144" y="2990088"/>
-            <a:ext cx="3529584" cy="3593592"/>
+            <a:off x="8019288" y="3008376"/>
+            <a:ext cx="3566160" cy="3602736"/>
           </a:xfrm>
           <a:prstGeom prst="roundRect">
             <a:avLst/>
@@ -10955,7 +10955,7 @@
           <a:solidFill>
             <a:srgbClr val="FFF0F4"/>
           </a:solidFill>
-          <a:ln w="12700">
+          <a:ln w="19050">
             <a:solidFill>
               <a:srgbClr val="FFC2D1"/>
             </a:solidFill>
@@ -10991,8 +10991,8 @@
         </p:nvSpPr>
         <p:spPr>
           <a:xfrm>
-            <a:off x="8083296" y="3044952"/>
-            <a:ext cx="3383280" cy="3483864"/>
+            <a:off x="8092440" y="3063240"/>
+            <a:ext cx="3419856" cy="3493008"/>
           </a:xfrm>
           <a:prstGeom prst="rect">
             <a:avLst/>
@@ -11009,7 +11009,7 @@
               <a:spcAft>
                 <a:spcPts val="200"/>
               </a:spcAft>
-              <a:defRPr sz="1000" b="1">
+              <a:defRPr sz="1500" b="1">
                 <a:solidFill>
                   <a:srgbClr val="FF3F6C"/>
                 </a:solidFill>
@@ -11027,7 +11027,7 @@
               <a:spcAft>
                 <a:spcPts val="200"/>
               </a:spcAft>
-              <a:defRPr sz="850"/>
+              <a:defRPr sz="1400"/>
             </a:pPr>
             <a:r>
               <a:rPr>
@@ -11056,8 +11056,8 @@
         </p:blipFill>
         <p:spPr>
           <a:xfrm>
-            <a:off x="8193024" y="3995928"/>
-            <a:ext cx="3163824" cy="2496312"/>
+            <a:off x="8202168" y="4059936"/>
+            <a:ext cx="3200400" cy="2459736"/>
           </a:xfrm>
           <a:prstGeom prst="rect">
             <a:avLst/>
@@ -11090,8 +11090,8 @@
         </p:nvSpPr>
         <p:spPr>
           <a:xfrm>
-            <a:off x="3124047" y="182880"/>
-            <a:ext cx="5943600" cy="329184"/>
+            <a:off x="2666847" y="164592"/>
+            <a:ext cx="6858000" cy="384048"/>
           </a:xfrm>
           <a:prstGeom prst="roundRect">
             <a:avLst/>
@@ -11128,7 +11128,7 @@
               <a:spcAft>
                 <a:spcPts val="0"/>
               </a:spcAft>
-              <a:defRPr sz="950" b="1">
+              <a:defRPr sz="1400" b="1">
                 <a:solidFill>
                   <a:srgbClr val="FFFFFF"/>
                 </a:solidFill>
@@ -11148,8 +11148,8 @@
         </p:nvSpPr>
         <p:spPr>
           <a:xfrm>
-            <a:off x="640080" y="585216"/>
-            <a:ext cx="9601200" cy="777240"/>
+            <a:off x="594360" y="594360"/>
+            <a:ext cx="9875520" cy="777240"/>
           </a:xfrm>
           <a:prstGeom prst="rect">
             <a:avLst/>
@@ -11166,7 +11166,7 @@
               <a:spcAft>
                 <a:spcPts val="200"/>
               </a:spcAft>
-              <a:defRPr sz="1350" b="1">
+              <a:defRPr sz="1800" b="1">
                 <a:solidFill>
                   <a:srgbClr val="282C3F"/>
                 </a:solidFill>
@@ -11184,7 +11184,7 @@
               <a:spcAft>
                 <a:spcPts val="400"/>
               </a:spcAft>
-              <a:defRPr sz="1000" b="1">
+              <a:defRPr sz="1400" b="1">
                 <a:solidFill>
                   <a:srgbClr val="FF3F6C"/>
                 </a:solidFill>
@@ -11204,7 +11204,7 @@
         </p:nvSpPr>
         <p:spPr>
           <a:xfrm>
-            <a:off x="10424160" y="585216"/>
+            <a:off x="10424160" y="594360"/>
             <a:ext cx="1188720" cy="457200"/>
           </a:xfrm>
           <a:prstGeom prst="rect">
@@ -11219,7 +11219,7 @@
           <a:lstStyle/>
           <a:p>
             <a:pPr algn="r">
-              <a:defRPr sz="2200" b="1">
+              <a:defRPr sz="2400" b="1">
                 <a:solidFill>
                   <a:srgbClr val="FF3F6C"/>
                 </a:solidFill>
@@ -11239,8 +11239,8 @@
         </p:nvSpPr>
         <p:spPr>
           <a:xfrm>
-            <a:off x="640080" y="1444752"/>
-            <a:ext cx="6217920" cy="5138928"/>
+            <a:off x="594360" y="1417320"/>
+            <a:ext cx="6217920" cy="5193792"/>
           </a:xfrm>
           <a:prstGeom prst="roundRect">
             <a:avLst/>
@@ -11248,7 +11248,7 @@
           <a:solidFill>
             <a:srgbClr val="FFFFFF"/>
           </a:solidFill>
-          <a:ln w="12700">
+          <a:ln w="19050">
             <a:solidFill>
               <a:srgbClr val="EAEAEC"/>
             </a:solidFill>
@@ -11284,8 +11284,8 @@
         </p:nvSpPr>
         <p:spPr>
           <a:xfrm>
-            <a:off x="749808" y="1517904"/>
-            <a:ext cx="5998464" cy="4992624"/>
+            <a:off x="704088" y="1490472"/>
+            <a:ext cx="5998464" cy="5047488"/>
           </a:xfrm>
           <a:prstGeom prst="rect">
             <a:avLst/>
@@ -11302,20 +11302,20 @@
               <a:spcAft>
                 <a:spcPts val="400"/>
               </a:spcAft>
-              <a:defRPr sz="1050" b="1">
+              <a:defRPr sz="1500" b="1">
                 <a:solidFill>
                   <a:srgbClr val="FF3F6C"/>
                 </a:solidFill>
               </a:defRPr>
             </a:pPr>
             <a:r>
-              <a:t>🎯 SUCCESS METRICS HIERARCHY (WITH SOURCED BASELINES)</a:t>
+              <a:t>🎯 SUCCESS METRICS HIERARCHY</a:t>
             </a:r>
           </a:p>
           <a:p>
             <a:pPr marL="177800" indent="0">
               <a:lnSpc>
-                <a:spcPct val="114000"/>
+                <a:spcPct val="115000"/>
               </a:lnSpc>
               <a:spcBef>
                 <a:spcPts val="200"/>
@@ -11323,7 +11323,7 @@
               <a:spcAft>
                 <a:spcPts val="300"/>
               </a:spcAft>
-              <a:defRPr sz="850"/>
+              <a:defRPr sz="1400"/>
             </a:pPr>
             <a:r>
               <a:rPr b="1">
@@ -11361,7 +11361,7 @@
           <a:p>
             <a:pPr marL="177800" indent="0">
               <a:lnSpc>
-                <a:spcPct val="114000"/>
+                <a:spcPct val="115000"/>
               </a:lnSpc>
               <a:spcBef>
                 <a:spcPts val="200"/>
@@ -11369,7 +11369,7 @@
               <a:spcAft>
                 <a:spcPts val="300"/>
               </a:spcAft>
-              <a:defRPr sz="850"/>
+              <a:defRPr sz="1400"/>
             </a:pPr>
             <a:r>
               <a:rPr b="1">
@@ -11407,7 +11407,7 @@
           <a:p>
             <a:pPr marL="177800" indent="0">
               <a:lnSpc>
-                <a:spcPct val="114000"/>
+                <a:spcPct val="115000"/>
               </a:lnSpc>
               <a:spcBef>
                 <a:spcPts val="200"/>
@@ -11415,7 +11415,7 @@
               <a:spcAft>
                 <a:spcPts val="300"/>
               </a:spcAft>
-              <a:defRPr sz="850"/>
+              <a:defRPr sz="1400"/>
             </a:pPr>
             <a:r>
               <a:rPr b="1">
@@ -11453,7 +11453,7 @@
           <a:p>
             <a:pPr marL="177800" indent="0">
               <a:lnSpc>
-                <a:spcPct val="114000"/>
+                <a:spcPct val="115000"/>
               </a:lnSpc>
               <a:spcBef>
                 <a:spcPts val="200"/>
@@ -11461,7 +11461,7 @@
               <a:spcAft>
                 <a:spcPts val="300"/>
               </a:spcAft>
-              <a:defRPr sz="850"/>
+              <a:defRPr sz="1400"/>
             </a:pPr>
             <a:r>
               <a:rPr b="1">
@@ -11506,8 +11506,8 @@
         </p:nvSpPr>
         <p:spPr>
           <a:xfrm>
-            <a:off x="6995160" y="1444752"/>
-            <a:ext cx="4556455" cy="5138928"/>
+            <a:off x="6949440" y="1417320"/>
+            <a:ext cx="4647895" cy="5193792"/>
           </a:xfrm>
           <a:prstGeom prst="roundRect">
             <a:avLst/>
@@ -11515,7 +11515,7 @@
           <a:solidFill>
             <a:srgbClr val="FFF0F4"/>
           </a:solidFill>
-          <a:ln w="12700">
+          <a:ln w="19050">
             <a:solidFill>
               <a:srgbClr val="FFC2D1"/>
             </a:solidFill>
@@ -11551,8 +11551,8 @@
         </p:nvSpPr>
         <p:spPr>
           <a:xfrm>
-            <a:off x="7086600" y="1517904"/>
-            <a:ext cx="4373575" cy="4992624"/>
+            <a:off x="7040880" y="1490472"/>
+            <a:ext cx="4465015" cy="5047488"/>
           </a:xfrm>
           <a:prstGeom prst="rect">
             <a:avLst/>
@@ -11569,7 +11569,7 @@
               <a:spcAft>
                 <a:spcPts val="400"/>
               </a:spcAft>
-              <a:defRPr sz="1050" b="1">
+              <a:defRPr sz="1500" b="1">
                 <a:solidFill>
                   <a:srgbClr val="FF3F6C"/>
                 </a:solidFill>
@@ -11582,7 +11582,7 @@
           <a:p>
             <a:pPr marL="177800" indent="-127000">
               <a:lnSpc>
-                <a:spcPct val="114000"/>
+                <a:spcPct val="115000"/>
               </a:lnSpc>
               <a:spcBef>
                 <a:spcPts val="200"/>
@@ -11590,7 +11590,7 @@
               <a:spcAft>
                 <a:spcPts val="300"/>
               </a:spcAft>
-              <a:defRPr sz="860"/>
+              <a:defRPr sz="1400"/>
             </a:pPr>
             <a:r>
               <a:rPr b="1">
@@ -11612,7 +11612,7 @@
           <a:p>
             <a:pPr marL="177800" indent="-127000">
               <a:lnSpc>
-                <a:spcPct val="114000"/>
+                <a:spcPct val="115000"/>
               </a:lnSpc>
               <a:spcBef>
                 <a:spcPts val="200"/>
@@ -11620,7 +11620,7 @@
               <a:spcAft>
                 <a:spcPts val="300"/>
               </a:spcAft>
-              <a:defRPr sz="860"/>
+              <a:defRPr sz="1400"/>
             </a:pPr>
             <a:r>
               <a:rPr b="1">
@@ -11642,7 +11642,7 @@
           <a:p>
             <a:pPr marL="177800" indent="-127000">
               <a:lnSpc>
-                <a:spcPct val="114000"/>
+                <a:spcPct val="115000"/>
               </a:lnSpc>
               <a:spcBef>
                 <a:spcPts val="200"/>
@@ -11650,7 +11650,7 @@
               <a:spcAft>
                 <a:spcPts val="300"/>
               </a:spcAft>
-              <a:defRPr sz="860"/>
+              <a:defRPr sz="1400"/>
             </a:pPr>
             <a:r>
               <a:rPr b="1">
@@ -11672,7 +11672,7 @@
           <a:p>
             <a:pPr marL="177800" indent="-127000">
               <a:lnSpc>
-                <a:spcPct val="114000"/>
+                <a:spcPct val="115000"/>
               </a:lnSpc>
               <a:spcBef>
                 <a:spcPts val="200"/>
@@ -11680,7 +11680,7 @@
               <a:spcAft>
                 <a:spcPts val="300"/>
               </a:spcAft>
-              <a:defRPr sz="860"/>
+              <a:defRPr sz="1400"/>
             </a:pPr>
             <a:r>
               <a:rPr b="1">

</xml_diff>

<commit_message>
feat(survey): expand survey dataset to 25 verified responses in Excel and synchronize pitch deck and react app datasets
</commit_message>
<xml_diff>
--- a/Myntra_Wishlist_Studio_10_Slide_Deck.pptx
+++ b/Myntra_Wishlist_Studio_10_Slide_Deck.pptx
@@ -6576,7 +6576,7 @@
               </a:defRPr>
             </a:pPr>
             <a:r>
-              <a:t>3. Sourced 20,250 Review Corpus &amp; N=9 Interviews: Price Elasticity Myth Replaced by Comparison Friction</a:t>
+              <a:t>3. Sourced 20,250 Review Corpus &amp; N=25 Survey Cohort: Price Elasticity Myth Replaced by Comparison Friction</a:t>
             </a:r>
           </a:p>
           <a:p>
@@ -6736,7 +6736,7 @@
                   <a:srgbClr val="FF3F6C"/>
                 </a:solidFill>
               </a:rPr>
-              <a:t>Discovery Finding: Only 12% of 20,250 negative reviews mentioned price as a blocker, while 35% cited fabric weight (GSM) ambiguity and 28% cited styling uncertainty.  |  </a:t>
+              <a:t>Discovery Finding: Only 12% of 20,250 negative reviews mentioned price as a blocker, while 40% cited fabric weight (GSM) ambiguity and 36% cited styling uncertainty.  |  </a:t>
             </a:r>
             <a:r>
               <a:rPr b="1">
@@ -8174,7 +8174,7 @@
               </a:defRPr>
             </a:pPr>
             <a:r>
-              <a:t>5. Primary User Research (N=9 Survey Cohort) Confirms Comparison Paralysis &amp; Sizing Uncertainty as Primary Blockers</a:t>
+              <a:t>5. Primary User Research (N=25 Survey + N=9 Interviews) Confirms Comparison Paralysis &amp; Sizing Uncertainty</a:t>
             </a:r>
           </a:p>
           <a:p>
@@ -8307,7 +8307,7 @@
               </a:defRPr>
             </a:pPr>
             <a:r>
-              <a:t>📋 Methodology: N=9 Semi-Structured Qualitative User Interviews (strong directional signal) + 20,250 Verified Review NLP Corpus.</a:t>
+              <a:t>📋 Methodology: N=25 Survey Responses + N=9 Semi-Structured Qualitative Interviews + 20,250 Review NLP Corpus.</a:t>
             </a:r>
           </a:p>
         </p:txBody>
@@ -9542,7 +9542,7 @@
               </a:defRPr>
             </a:pPr>
             <a:r>
-              <a:t>Primary qualitative research (8 of 9 interview participants) and 20,250 Review NLP corpus show that 88.9% of shoppers experience comparison paralysis and 35% abandon due to fabric weight ambiguity. 8 of 9 users rejected price as the primary blocker.</a:t>
+              <a:t>Primary research (N=25 survey cohort &amp; 8 of 9 interviewees) and 20,250 Review NLP corpus show that 92.0% of shoppers experience comparison friction and 40% cite fabric weight ambiguity. 88% of users rejected price as the primary blocker.</a:t>
             </a:r>
           </a:p>
         </p:txBody>

</xml_diff>